<commit_message>
Rework contract section: two separate contracts, empty slides per topic
Co-Authored-By: Claude Sonnet 5.5 <noreply@anthropic.com>
Claude-Session: https://claude.ai/code/session_01SVoKafBmW5nnvB217TvhV6
</commit_message>
<xml_diff>
--- a/presentation_with_contract.pptx
+++ b/presentation_with_contract.pptx
@@ -36,6 +36,11 @@
     <p:sldId id="284" r:id="rId36"/>
     <p:sldId id="285" r:id="rId37"/>
     <p:sldId id="286" r:id="rId38"/>
+    <p:sldId id="287" r:id="rId39"/>
+    <p:sldId id="288" r:id="rId40"/>
+    <p:sldId id="289" r:id="rId41"/>
+    <p:sldId id="290" r:id="rId42"/>
+    <p:sldId id="291" r:id="rId43"/>
   </p:sldIdLst>
   <p:sldSz cx="18288000" cy="10287000"/>
   <p:notesSz cx="6858000" cy="9144000"/>
@@ -20465,7 +20470,7 @@
                 <a:cs typeface="Fira Sans Extra Condensed Bold"/>
                 <a:sym typeface="Fira Sans Extra Condensed Bold"/>
               </a:rPr>
-              <a:t>Договір між </a:t>
+              <a:t>Два договори з </a:t>
             </a:r>
             <a:r>
               <a:rPr lang="uk-UA" sz="5400" b="1">
@@ -20477,7 +20482,7 @@
                 <a:cs typeface="Fira Sans Extra Condensed Bold"/>
                 <a:sym typeface="Fira Sans Extra Condensed Bold"/>
               </a:rPr>
-              <a:t>трьома сторонами</a:t>
+              <a:t>Lviv Croissants</a:t>
             </a:r>
           </a:p>
         </p:txBody>
@@ -20491,7 +20496,7 @@
         <p:spPr>
           <a:xfrm>
             <a:off x="1219200" y="2500000"/>
-            <a:ext cx="5130803" cy="5900000"/>
+            <a:ext cx="3800000" cy="5900000"/>
           </a:xfrm>
           <a:prstGeom prst="roundRect">
             <a:avLst>
@@ -20512,7 +20517,7 @@
         <p:spPr>
           <a:xfrm>
             <a:off x="1504950" y="2800000"/>
-            <a:ext cx="4559303" cy="1100000"/>
+            <a:ext cx="3228500" cy="1100000"/>
           </a:xfrm>
           <a:prstGeom prst="rect">
             <a:avLst/>
@@ -20556,7 +20561,7 @@
         <p:spPr>
           <a:xfrm>
             <a:off x="1504950" y="4000000"/>
-            <a:ext cx="4559303" cy="1800000"/>
+            <a:ext cx="3228500" cy="1800000"/>
           </a:xfrm>
           <a:prstGeom prst="rect">
             <a:avLst/>
@@ -20599,7 +20604,7 @@
               </a:spcAft>
             </a:pPr>
             <a:r>
-              <a:rPr lang="uk-UA" sz="2600" b="0">
+              <a:rPr lang="uk-UA" sz="2400" b="0">
                 <a:solidFill>
                   <a:srgbClr val="FBFBF8"/>
                 </a:solidFill>
@@ -20622,7 +20627,7 @@
         <p:spPr>
           <a:xfrm>
             <a:off x="1504950" y="6000000"/>
-            <a:ext cx="4559303" cy="2200000"/>
+            <a:ext cx="3228500" cy="2200000"/>
           </a:xfrm>
           <a:prstGeom prst="rect">
             <a:avLst/>
@@ -20665,7 +20670,7 @@
               </a:spcAft>
             </a:pPr>
             <a:r>
-              <a:rPr lang="uk-UA" sz="2600" b="0">
+              <a:rPr lang="uk-UA" sz="2400" b="0">
                 <a:solidFill>
                   <a:srgbClr val="FBFBF8"/>
                 </a:solidFill>
@@ -20674,7 +20679,7 @@
                 <a:cs typeface="Fira Sans Extra Condensed"/>
                 <a:sym typeface="Fira Sans Extra Condensed"/>
               </a:rPr>
-              <a:t>Нікому не підпорядковується; звертається лише до Lviv Croissants</a:t>
+              <a:t>Звертається лише до Lviv Croissants</a:t>
             </a:r>
           </a:p>
         </p:txBody>
@@ -20687,8 +20692,8 @@
         </p:nvSpPr>
         <p:spPr>
           <a:xfrm>
-            <a:off x="6638003" y="2500000"/>
-            <a:ext cx="5130803" cy="5900000"/>
+            <a:off x="7244000" y="2500000"/>
+            <a:ext cx="3800000" cy="5900000"/>
           </a:xfrm>
           <a:prstGeom prst="roundRect">
             <a:avLst>
@@ -20708,8 +20713,8 @@
         </p:nvSpPr>
         <p:spPr>
           <a:xfrm>
-            <a:off x="6923753" y="2800000"/>
-            <a:ext cx="4559303" cy="1100000"/>
+            <a:off x="7529750" y="2800000"/>
+            <a:ext cx="3228500" cy="1100000"/>
           </a:xfrm>
           <a:prstGeom prst="rect">
             <a:avLst/>
@@ -20752,8 +20757,8 @@
         </p:nvSpPr>
         <p:spPr>
           <a:xfrm>
-            <a:off x="6923753" y="4000000"/>
-            <a:ext cx="4559303" cy="1800000"/>
+            <a:off x="7529750" y="4000000"/>
+            <a:ext cx="3228500" cy="1800000"/>
           </a:xfrm>
           <a:prstGeom prst="rect">
             <a:avLst/>
@@ -20796,7 +20801,7 @@
               </a:spcAft>
             </a:pPr>
             <a:r>
-              <a:rPr lang="uk-UA" sz="2600" b="0">
+              <a:rPr lang="uk-UA" sz="2400" b="0">
                 <a:solidFill>
                   <a:srgbClr val="FBFBF8"/>
                 </a:solidFill>
@@ -20818,8 +20823,8 @@
         </p:nvSpPr>
         <p:spPr>
           <a:xfrm>
-            <a:off x="6923753" y="6000000"/>
-            <a:ext cx="4559303" cy="2200000"/>
+            <a:off x="7529750" y="6000000"/>
+            <a:ext cx="3228500" cy="2200000"/>
           </a:xfrm>
           <a:prstGeom prst="rect">
             <a:avLst/>
@@ -20862,7 +20867,7 @@
               </a:spcAft>
             </a:pPr>
             <a:r>
-              <a:rPr lang="uk-UA" sz="2600" b="0">
+              <a:rPr lang="uk-UA" sz="2400" b="0">
                 <a:solidFill>
                   <a:srgbClr val="FBFBF8"/>
                 </a:solidFill>
@@ -20871,7 +20876,7 @@
                 <a:cs typeface="Fira Sans Extra Condensed"/>
                 <a:sym typeface="Fira Sans Extra Condensed"/>
               </a:rPr>
-              <a:t>Центральна ланка: фільтрує запити між інвестором і оператором</a:t>
+              <a:t>Центральна ланка між інвестором і оператором</a:t>
             </a:r>
           </a:p>
         </p:txBody>
@@ -20884,8 +20889,8 @@
         </p:nvSpPr>
         <p:spPr>
           <a:xfrm>
-            <a:off x="12056806" y="2500000"/>
-            <a:ext cx="5130803" cy="5900000"/>
+            <a:off x="13268800" y="2500000"/>
+            <a:ext cx="3800000" cy="5900000"/>
           </a:xfrm>
           <a:prstGeom prst="roundRect">
             <a:avLst>
@@ -20905,8 +20910,8 @@
         </p:nvSpPr>
         <p:spPr>
           <a:xfrm>
-            <a:off x="12342556" y="2800000"/>
-            <a:ext cx="4559303" cy="1100000"/>
+            <a:off x="13554550" y="2800000"/>
+            <a:ext cx="3228500" cy="1100000"/>
           </a:xfrm>
           <a:prstGeom prst="rect">
             <a:avLst/>
@@ -20949,8 +20954,8 @@
         </p:nvSpPr>
         <p:spPr>
           <a:xfrm>
-            <a:off x="12342556" y="4000000"/>
-            <a:ext cx="4559303" cy="1800000"/>
+            <a:off x="13554550" y="4000000"/>
+            <a:ext cx="3228500" cy="1800000"/>
           </a:xfrm>
           <a:prstGeom prst="rect">
             <a:avLst/>
@@ -20993,7 +20998,7 @@
               </a:spcAft>
             </a:pPr>
             <a:r>
-              <a:rPr lang="uk-UA" sz="2600" b="0">
+              <a:rPr lang="uk-UA" sz="2400" b="0">
                 <a:solidFill>
                   <a:srgbClr val="FBFBF8"/>
                 </a:solidFill>
@@ -21015,8 +21020,8 @@
         </p:nvSpPr>
         <p:spPr>
           <a:xfrm>
-            <a:off x="12342556" y="6000000"/>
-            <a:ext cx="4559303" cy="2200000"/>
+            <a:off x="13554550" y="6000000"/>
+            <a:ext cx="3228500" cy="2200000"/>
           </a:xfrm>
           <a:prstGeom prst="rect">
             <a:avLst/>
@@ -21059,7 +21064,7 @@
               </a:spcAft>
             </a:pPr>
             <a:r>
-              <a:rPr lang="uk-UA" sz="2600" b="0">
+              <a:rPr lang="uk-UA" sz="2400" b="0">
                 <a:solidFill>
                   <a:srgbClr val="FBFBF8"/>
                 </a:solidFill>
@@ -21068,14 +21073,148 @@
                 <a:cs typeface="Fira Sans Extra Condensed"/>
                 <a:sym typeface="Fira Sans Extra Condensed"/>
               </a:rPr>
-              <a:t>Підпорядковується Lviv Croissants; працює за стандартами бренду</a:t>
+              <a:t>Підпорядковується Lviv Croissants</a:t>
+            </a:r>
+          </a:p>
+        </p:txBody>
+      </p:sp>
+      <p:cxnSp>
+        <p:nvCxnSpPr>
+          <p:cNvPr name="Arrow 15" id="15"/>
+          <p:cNvCxnSpPr/>
+          <p:nvPr/>
+        </p:nvCxnSpPr>
+        <p:spPr>
+          <a:xfrm>
+            <a:off x="5169200" y="5000000"/>
+            <a:ext cx="1924800" cy="0"/>
+          </a:xfrm>
+          <a:prstGeom prst="line">
+            <a:avLst/>
+          </a:prstGeom>
+          <a:ln w="38100">
+            <a:solidFill>
+              <a:srgbClr val="FBFBF8"/>
+            </a:solidFill>
+            <a:headEnd type="triangle"/>
+            <a:tailEnd type="triangle"/>
+          </a:ln>
+        </p:spPr>
+      </p:cxnSp>
+      <p:sp>
+        <p:nvSpPr>
+          <p:cNvPr name="TextBox 16" id="16"/>
+          <p:cNvSpPr txBox="true"/>
+          <p:nvPr/>
+        </p:nvSpPr>
+        <p:spPr>
+          <a:xfrm>
+            <a:off x="5169200" y="4300000"/>
+            <a:ext cx="1924800" cy="500000"/>
+          </a:xfrm>
+          <a:prstGeom prst="rect">
+            <a:avLst/>
+          </a:prstGeom>
+        </p:spPr>
+        <p:txBody>
+          <a:bodyPr anchor="t" wrap="square" rtlCol="false" tIns="0" lIns="0" bIns="0" rIns="0">
+            <a:noAutofit/>
+          </a:bodyPr>
+          <a:lstStyle/>
+          <a:p>
+            <a:pPr algn="ctr">
+              <a:lnSpc>
+                <a:spcPct val="100000"/>
+              </a:lnSpc>
+              <a:spcAft>
+                <a:spcPts val="0"/>
+              </a:spcAft>
+            </a:pPr>
+            <a:r>
+              <a:rPr lang="uk-UA" sz="2600" b="1">
+                <a:solidFill>
+                  <a:srgbClr val="F4B6C8"/>
+                </a:solidFill>
+                <a:latin typeface="Fira Sans Extra Condensed Bold"/>
+                <a:ea typeface="Fira Sans Extra Condensed Bold"/>
+                <a:cs typeface="Fira Sans Extra Condensed Bold"/>
+                <a:sym typeface="Fira Sans Extra Condensed Bold"/>
+              </a:rPr>
+              <a:t>Договір 1</a:t>
+            </a:r>
+          </a:p>
+        </p:txBody>
+      </p:sp>
+      <p:cxnSp>
+        <p:nvCxnSpPr>
+          <p:cNvPr name="Arrow 17" id="17"/>
+          <p:cNvCxnSpPr/>
+          <p:nvPr/>
+        </p:nvCxnSpPr>
+        <p:spPr>
+          <a:xfrm>
+            <a:off x="11194000" y="5000000"/>
+            <a:ext cx="1924800" cy="0"/>
+          </a:xfrm>
+          <a:prstGeom prst="line">
+            <a:avLst/>
+          </a:prstGeom>
+          <a:ln w="38100">
+            <a:solidFill>
+              <a:srgbClr val="FBFBF8"/>
+            </a:solidFill>
+            <a:headEnd type="triangle"/>
+            <a:tailEnd type="triangle"/>
+          </a:ln>
+        </p:spPr>
+      </p:cxnSp>
+      <p:sp>
+        <p:nvSpPr>
+          <p:cNvPr name="TextBox 18" id="18"/>
+          <p:cNvSpPr txBox="true"/>
+          <p:nvPr/>
+        </p:nvSpPr>
+        <p:spPr>
+          <a:xfrm>
+            <a:off x="11194000" y="4300000"/>
+            <a:ext cx="1924800" cy="500000"/>
+          </a:xfrm>
+          <a:prstGeom prst="rect">
+            <a:avLst/>
+          </a:prstGeom>
+        </p:spPr>
+        <p:txBody>
+          <a:bodyPr anchor="t" wrap="square" rtlCol="false" tIns="0" lIns="0" bIns="0" rIns="0">
+            <a:noAutofit/>
+          </a:bodyPr>
+          <a:lstStyle/>
+          <a:p>
+            <a:pPr algn="ctr">
+              <a:lnSpc>
+                <a:spcPct val="100000"/>
+              </a:lnSpc>
+              <a:spcAft>
+                <a:spcPts val="0"/>
+              </a:spcAft>
+            </a:pPr>
+            <a:r>
+              <a:rPr lang="uk-UA" sz="2600" b="1">
+                <a:solidFill>
+                  <a:srgbClr val="F4B6C8"/>
+                </a:solidFill>
+                <a:latin typeface="Fira Sans Extra Condensed Bold"/>
+                <a:ea typeface="Fira Sans Extra Condensed Bold"/>
+                <a:cs typeface="Fira Sans Extra Condensed Bold"/>
+                <a:sym typeface="Fira Sans Extra Condensed Bold"/>
+              </a:rPr>
+              <a:t>Договір 2</a:t>
             </a:r>
           </a:p>
         </p:txBody>
       </p:sp>
       <p:sp>
         <p:nvSpPr>
-          <p:cNvPr name="Note 15" id="15"/>
+          <p:cNvPr name="Note 19" id="19"/>
           <p:cNvSpPr/>
           <p:nvPr/>
         </p:nvSpPr>
@@ -21096,7 +21235,7 @@
       </p:sp>
       <p:sp>
         <p:nvSpPr>
-          <p:cNvPr name="TextBox 16" id="16"/>
+          <p:cNvPr name="TextBox 20" id="20"/>
           <p:cNvSpPr txBox="true"/>
           <p:nvPr/>
         </p:nvSpPr>
@@ -21133,7 +21272,7 @@
                 <a:cs typeface="Fira Sans Extra Condensed Bold"/>
                 <a:sym typeface="Fira Sans Extra Condensed Bold"/>
               </a:rPr>
-              <a:t>Основа: один тристоронній договір або пакет двох пов'язаних (формат — на обговорення)</a:t>
+              <a:t>Інвестор і оператор укладають договори окремо: якщо один партнер виходить, договір іншого продовжує діяти</a:t>
             </a:r>
           </a:p>
         </p:txBody>
@@ -21221,7 +21360,7 @@
                 <a:cs typeface="Fira Sans Extra Condensed Bold"/>
                 <a:sym typeface="Fira Sans Extra Condensed Bold"/>
               </a:rPr>
-              <a:t>договір</a:t>
+              <a:t>кожен договір</a:t>
             </a:r>
           </a:p>
         </p:txBody>
@@ -22510,7 +22649,7 @@
                 <a:cs typeface="Fira Sans Extra Condensed Bold"/>
                 <a:sym typeface="Fira Sans Extra Condensed Bold"/>
               </a:rPr>
-              <a:t>Це каркас: кожен розділ деталізуємо окремо</a:t>
+              <a:t>Каркас однаковий для обох договорів; кожен розділ — на окремому слайді</a:t>
             </a:r>
           </a:p>
         </p:txBody>
@@ -22579,682 +22718,26 @@
             <a:r>
               <a:rPr lang="uk-UA" sz="5400" b="1">
                 <a:solidFill>
-                  <a:srgbClr val="FBFBF8"/>
+                  <a:srgbClr val="F4B6C8"/>
                 </a:solidFill>
                 <a:latin typeface="Fira Sans Extra Condensed Bold"/>
                 <a:ea typeface="Fira Sans Extra Condensed Bold"/>
                 <a:cs typeface="Fira Sans Extra Condensed Bold"/>
                 <a:sym typeface="Fira Sans Extra Condensed Bold"/>
               </a:rPr>
-              <a:t>Права та обов'язки </a:t>
+              <a:t>1  </a:t>
             </a:r>
             <a:r>
               <a:rPr lang="uk-UA" sz="5400" b="1">
                 <a:solidFill>
-                  <a:srgbClr val="F4B6C8"/>
+                  <a:srgbClr val="FBFBF8"/>
                 </a:solidFill>
                 <a:latin typeface="Fira Sans Extra Condensed Bold"/>
                 <a:ea typeface="Fira Sans Extra Condensed Bold"/>
                 <a:cs typeface="Fira Sans Extra Condensed Bold"/>
                 <a:sym typeface="Fira Sans Extra Condensed Bold"/>
               </a:rPr>
-              <a:t>сторін</a:t>
-            </a:r>
-          </a:p>
-        </p:txBody>
-      </p:sp>
-      <p:sp>
-        <p:nvSpPr>
-          <p:cNvPr name="Card 3" id="3"/>
-          <p:cNvSpPr/>
-          <p:nvPr/>
-        </p:nvSpPr>
-        <p:spPr>
-          <a:xfrm>
-            <a:off x="1219200" y="2300000"/>
-            <a:ext cx="5130803" cy="6200000"/>
-          </a:xfrm>
-          <a:prstGeom prst="roundRect">
-            <a:avLst>
-              <a:gd name="adj" fmla="val 7000"/>
-            </a:avLst>
-          </a:prstGeom>
-          <a:solidFill>
-            <a:srgbClr val="135F45"/>
-          </a:solidFill>
-        </p:spPr>
-      </p:sp>
-      <p:sp>
-        <p:nvSpPr>
-          <p:cNvPr name="TextBox 4" id="4"/>
-          <p:cNvSpPr txBox="true"/>
-          <p:nvPr/>
-        </p:nvSpPr>
-        <p:spPr>
-          <a:xfrm>
-            <a:off x="1504950" y="2550000"/>
-            <a:ext cx="4559303" cy="700000"/>
-          </a:xfrm>
-          <a:prstGeom prst="rect">
-            <a:avLst/>
-          </a:prstGeom>
-        </p:spPr>
-        <p:txBody>
-          <a:bodyPr anchor="t" wrap="square" rtlCol="false" tIns="0" lIns="0" bIns="0" rIns="0">
-            <a:noAutofit/>
-          </a:bodyPr>
-          <a:lstStyle/>
-          <a:p>
-            <a:pPr algn="l">
-              <a:lnSpc>
-                <a:spcPct val="100000"/>
-              </a:lnSpc>
-              <a:spcAft>
-                <a:spcPts val="0"/>
-              </a:spcAft>
-            </a:pPr>
-            <a:r>
-              <a:rPr lang="uk-UA" sz="3200" b="1">
-                <a:solidFill>
-                  <a:srgbClr val="F4B6C8"/>
-                </a:solidFill>
-                <a:latin typeface="Fira Sans Extra Condensed Bold"/>
-                <a:ea typeface="Fira Sans Extra Condensed Bold"/>
-                <a:cs typeface="Fira Sans Extra Condensed Bold"/>
-                <a:sym typeface="Fira Sans Extra Condensed Bold"/>
-              </a:rPr>
-              <a:t>Інвестор</a:t>
-            </a:r>
-          </a:p>
-        </p:txBody>
-      </p:sp>
-      <p:sp>
-        <p:nvSpPr>
-          <p:cNvPr name="TextBox 5" id="5"/>
-          <p:cNvSpPr txBox="true"/>
-          <p:nvPr/>
-        </p:nvSpPr>
-        <p:spPr>
-          <a:xfrm>
-            <a:off x="1504950" y="3450000"/>
-            <a:ext cx="4559303" cy="4900000"/>
-          </a:xfrm>
-          <a:prstGeom prst="rect">
-            <a:avLst/>
-          </a:prstGeom>
-        </p:spPr>
-        <p:txBody>
-          <a:bodyPr anchor="t" wrap="square" rtlCol="false" tIns="0" lIns="0" bIns="0" rIns="0">
-            <a:noAutofit/>
-          </a:bodyPr>
-          <a:lstStyle/>
-          <a:p>
-            <a:pPr algn="l">
-              <a:lnSpc>
-                <a:spcPct val="100000"/>
-              </a:lnSpc>
-              <a:spcAft>
-                <a:spcPts val="1800"/>
-              </a:spcAft>
-            </a:pPr>
-            <a:r>
-              <a:rPr lang="uk-UA" sz="2400" b="0">
-                <a:solidFill>
-                  <a:srgbClr val="FBFBF8"/>
-                </a:solidFill>
-                <a:latin typeface="Fira Sans Extra Condensed"/>
-                <a:ea typeface="Fira Sans Extra Condensed"/>
-                <a:cs typeface="Fira Sans Extra Condensed"/>
-                <a:sym typeface="Fira Sans Extra Condensed"/>
-              </a:rPr>
-              <a:t>— Фінансує закріплені за роллю витрати</a:t>
-            </a:r>
-          </a:p>
-          <a:p>
-            <a:pPr algn="l">
-              <a:lnSpc>
-                <a:spcPct val="100000"/>
-              </a:lnSpc>
-              <a:spcAft>
-                <a:spcPts val="1800"/>
-              </a:spcAft>
-            </a:pPr>
-            <a:r>
-              <a:rPr lang="uk-UA" sz="2400" b="0">
-                <a:solidFill>
-                  <a:srgbClr val="FBFBF8"/>
-                </a:solidFill>
-                <a:latin typeface="Fira Sans Extra Condensed"/>
-                <a:ea typeface="Fira Sans Extra Condensed"/>
-                <a:cs typeface="Fira Sans Extra Condensed"/>
-                <a:sym typeface="Fira Sans Extra Condensed"/>
-              </a:rPr>
-              <a:t>— Будівництво, інтер'єр, ліцензії, дозволи</a:t>
-            </a:r>
-          </a:p>
-          <a:p>
-            <a:pPr algn="l">
-              <a:lnSpc>
-                <a:spcPct val="100000"/>
-              </a:lnSpc>
-              <a:spcAft>
-                <a:spcPts val="1800"/>
-              </a:spcAft>
-            </a:pPr>
-            <a:r>
-              <a:rPr lang="uk-UA" sz="2400" b="0">
-                <a:solidFill>
-                  <a:srgbClr val="FBFBF8"/>
-                </a:solidFill>
-                <a:latin typeface="Fira Sans Extra Condensed"/>
-                <a:ea typeface="Fira Sans Extra Condensed"/>
-                <a:cs typeface="Fira Sans Extra Condensed"/>
-                <a:sym typeface="Fira Sans Extra Condensed"/>
-              </a:rPr>
-              <a:t>— Підписує договір оренди приміщення</a:t>
-            </a:r>
-          </a:p>
-          <a:p>
-            <a:pPr algn="l">
-              <a:lnSpc>
-                <a:spcPct val="100000"/>
-              </a:lnSpc>
-              <a:spcAft>
-                <a:spcPts val="1800"/>
-              </a:spcAft>
-            </a:pPr>
-            <a:r>
-              <a:rPr lang="uk-UA" sz="2400" b="0">
-                <a:solidFill>
-                  <a:srgbClr val="FBFBF8"/>
-                </a:solidFill>
-                <a:latin typeface="Fira Sans Extra Condensed"/>
-                <a:ea typeface="Fira Sans Extra Condensed"/>
-                <a:cs typeface="Fira Sans Extra Condensed"/>
-                <a:sym typeface="Fira Sans Extra Condensed"/>
-              </a:rPr>
-              <a:t>— Отримує частку прибутку за шкалою</a:t>
-            </a:r>
-          </a:p>
-          <a:p>
-            <a:pPr algn="l">
-              <a:lnSpc>
-                <a:spcPct val="100000"/>
-              </a:lnSpc>
-              <a:spcAft>
-                <a:spcPts val="1800"/>
-              </a:spcAft>
-            </a:pPr>
-            <a:r>
-              <a:rPr lang="uk-UA" sz="2400" b="0">
-                <a:solidFill>
-                  <a:srgbClr val="FBFBF8"/>
-                </a:solidFill>
-                <a:latin typeface="Fira Sans Extra Condensed"/>
-                <a:ea typeface="Fira Sans Extra Condensed"/>
-                <a:cs typeface="Fira Sans Extra Condensed"/>
-                <a:sym typeface="Fira Sans Extra Condensed"/>
-              </a:rPr>
-              <a:t>— Питання щодо роботи — через Lviv Croissants</a:t>
-            </a:r>
-          </a:p>
-        </p:txBody>
-      </p:sp>
-      <p:sp>
-        <p:nvSpPr>
-          <p:cNvPr name="Card 6" id="6"/>
-          <p:cNvSpPr/>
-          <p:nvPr/>
-        </p:nvSpPr>
-        <p:spPr>
-          <a:xfrm>
-            <a:off x="6638003" y="2300000"/>
-            <a:ext cx="5130803" cy="6200000"/>
-          </a:xfrm>
-          <a:prstGeom prst="roundRect">
-            <a:avLst>
-              <a:gd name="adj" fmla="val 7000"/>
-            </a:avLst>
-          </a:prstGeom>
-          <a:solidFill>
-            <a:srgbClr val="135F45"/>
-          </a:solidFill>
-        </p:spPr>
-      </p:sp>
-      <p:sp>
-        <p:nvSpPr>
-          <p:cNvPr name="TextBox 7" id="7"/>
-          <p:cNvSpPr txBox="true"/>
-          <p:nvPr/>
-        </p:nvSpPr>
-        <p:spPr>
-          <a:xfrm>
-            <a:off x="6923753" y="2550000"/>
-            <a:ext cx="4559303" cy="700000"/>
-          </a:xfrm>
-          <a:prstGeom prst="rect">
-            <a:avLst/>
-          </a:prstGeom>
-        </p:spPr>
-        <p:txBody>
-          <a:bodyPr anchor="t" wrap="square" rtlCol="false" tIns="0" lIns="0" bIns="0" rIns="0">
-            <a:noAutofit/>
-          </a:bodyPr>
-          <a:lstStyle/>
-          <a:p>
-            <a:pPr algn="l">
-              <a:lnSpc>
-                <a:spcPct val="100000"/>
-              </a:lnSpc>
-              <a:spcAft>
-                <a:spcPts val="0"/>
-              </a:spcAft>
-            </a:pPr>
-            <a:r>
-              <a:rPr lang="uk-UA" sz="3200" b="1">
-                <a:solidFill>
-                  <a:srgbClr val="F4B6C8"/>
-                </a:solidFill>
-                <a:latin typeface="Fira Sans Extra Condensed Bold"/>
-                <a:ea typeface="Fira Sans Extra Condensed Bold"/>
-                <a:cs typeface="Fira Sans Extra Condensed Bold"/>
-                <a:sym typeface="Fira Sans Extra Condensed Bold"/>
-              </a:rPr>
-              <a:t>Lviv Croissants</a:t>
-            </a:r>
-          </a:p>
-        </p:txBody>
-      </p:sp>
-      <p:sp>
-        <p:nvSpPr>
-          <p:cNvPr name="TextBox 8" id="8"/>
-          <p:cNvSpPr txBox="true"/>
-          <p:nvPr/>
-        </p:nvSpPr>
-        <p:spPr>
-          <a:xfrm>
-            <a:off x="6923753" y="3450000"/>
-            <a:ext cx="4559303" cy="4900000"/>
-          </a:xfrm>
-          <a:prstGeom prst="rect">
-            <a:avLst/>
-          </a:prstGeom>
-        </p:spPr>
-        <p:txBody>
-          <a:bodyPr anchor="t" wrap="square" rtlCol="false" tIns="0" lIns="0" bIns="0" rIns="0">
-            <a:noAutofit/>
-          </a:bodyPr>
-          <a:lstStyle/>
-          <a:p>
-            <a:pPr algn="l">
-              <a:lnSpc>
-                <a:spcPct val="100000"/>
-              </a:lnSpc>
-              <a:spcAft>
-                <a:spcPts val="1800"/>
-              </a:spcAft>
-            </a:pPr>
-            <a:r>
-              <a:rPr lang="uk-UA" sz="2400" b="0">
-                <a:solidFill>
-                  <a:srgbClr val="FBFBF8"/>
-                </a:solidFill>
-                <a:latin typeface="Fira Sans Extra Condensed"/>
-                <a:ea typeface="Fira Sans Extra Condensed"/>
-                <a:cs typeface="Fira Sans Extra Condensed"/>
-                <a:sym typeface="Fira Sans Extra Condensed"/>
-              </a:rPr>
-              <a:t>— Надає бренд, стандарти, рецептури</a:t>
-            </a:r>
-          </a:p>
-          <a:p>
-            <a:pPr algn="l">
-              <a:lnSpc>
-                <a:spcPct val="100000"/>
-              </a:lnSpc>
-              <a:spcAft>
-                <a:spcPts val="1800"/>
-              </a:spcAft>
-            </a:pPr>
-            <a:r>
-              <a:rPr lang="uk-UA" sz="2400" b="0">
-                <a:solidFill>
-                  <a:srgbClr val="FBFBF8"/>
-                </a:solidFill>
-                <a:latin typeface="Fira Sans Extra Condensed"/>
-                <a:ea typeface="Fira Sans Extra Condensed"/>
-                <a:cs typeface="Fira Sans Extra Condensed"/>
-                <a:sym typeface="Fira Sans Extra Condensed"/>
-              </a:rPr>
-              <a:t>— Навчає операційного директора й команду</a:t>
-            </a:r>
-          </a:p>
-          <a:p>
-            <a:pPr algn="l">
-              <a:lnSpc>
-                <a:spcPct val="100000"/>
-              </a:lnSpc>
-              <a:spcAft>
-                <a:spcPts val="1800"/>
-              </a:spcAft>
-            </a:pPr>
-            <a:r>
-              <a:rPr lang="uk-UA" sz="2400" b="0">
-                <a:solidFill>
-                  <a:srgbClr val="FBFBF8"/>
-                </a:solidFill>
-                <a:latin typeface="Fira Sans Extra Condensed"/>
-                <a:ea typeface="Fira Sans Extra Condensed"/>
-                <a:cs typeface="Fira Sans Extra Condensed"/>
-                <a:sym typeface="Fira Sans Extra Condensed"/>
-              </a:rPr>
-              <a:t>— Дає Internal Systems та підтримку</a:t>
-            </a:r>
-          </a:p>
-          <a:p>
-            <a:pPr algn="l">
-              <a:lnSpc>
-                <a:spcPct val="100000"/>
-              </a:lnSpc>
-              <a:spcAft>
-                <a:spcPts val="1800"/>
-              </a:spcAft>
-            </a:pPr>
-            <a:r>
-              <a:rPr lang="uk-UA" sz="2400" b="0">
-                <a:solidFill>
-                  <a:srgbClr val="FBFBF8"/>
-                </a:solidFill>
-                <a:latin typeface="Fira Sans Extra Condensed"/>
-                <a:ea typeface="Fira Sans Extra Condensed"/>
-                <a:cs typeface="Fira Sans Extra Condensed"/>
-                <a:sym typeface="Fira Sans Extra Condensed"/>
-              </a:rPr>
-              <a:t>— Узгоджує зміни з оператором</a:t>
-            </a:r>
-          </a:p>
-          <a:p>
-            <a:pPr algn="l">
-              <a:lnSpc>
-                <a:spcPct val="100000"/>
-              </a:lnSpc>
-              <a:spcAft>
-                <a:spcPts val="1800"/>
-              </a:spcAft>
-            </a:pPr>
-            <a:r>
-              <a:rPr lang="uk-UA" sz="2400" b="0">
-                <a:solidFill>
-                  <a:srgbClr val="FBFBF8"/>
-                </a:solidFill>
-                <a:latin typeface="Fira Sans Extra Condensed"/>
-                <a:ea typeface="Fira Sans Extra Condensed"/>
-                <a:cs typeface="Fira Sans Extra Condensed"/>
-                <a:sym typeface="Fira Sans Extra Condensed"/>
-              </a:rPr>
-              <a:t>— Передає запити на дофінансування інвестору</a:t>
-            </a:r>
-          </a:p>
-        </p:txBody>
-      </p:sp>
-      <p:sp>
-        <p:nvSpPr>
-          <p:cNvPr name="Card 9" id="9"/>
-          <p:cNvSpPr/>
-          <p:nvPr/>
-        </p:nvSpPr>
-        <p:spPr>
-          <a:xfrm>
-            <a:off x="12056806" y="2300000"/>
-            <a:ext cx="5130803" cy="6200000"/>
-          </a:xfrm>
-          <a:prstGeom prst="roundRect">
-            <a:avLst>
-              <a:gd name="adj" fmla="val 7000"/>
-            </a:avLst>
-          </a:prstGeom>
-          <a:solidFill>
-            <a:srgbClr val="135F45"/>
-          </a:solidFill>
-        </p:spPr>
-      </p:sp>
-      <p:sp>
-        <p:nvSpPr>
-          <p:cNvPr name="TextBox 10" id="10"/>
-          <p:cNvSpPr txBox="true"/>
-          <p:nvPr/>
-        </p:nvSpPr>
-        <p:spPr>
-          <a:xfrm>
-            <a:off x="12342556" y="2550000"/>
-            <a:ext cx="4559303" cy="700000"/>
-          </a:xfrm>
-          <a:prstGeom prst="rect">
-            <a:avLst/>
-          </a:prstGeom>
-        </p:spPr>
-        <p:txBody>
-          <a:bodyPr anchor="t" wrap="square" rtlCol="false" tIns="0" lIns="0" bIns="0" rIns="0">
-            <a:noAutofit/>
-          </a:bodyPr>
-          <a:lstStyle/>
-          <a:p>
-            <a:pPr algn="l">
-              <a:lnSpc>
-                <a:spcPct val="100000"/>
-              </a:lnSpc>
-              <a:spcAft>
-                <a:spcPts val="0"/>
-              </a:spcAft>
-            </a:pPr>
-            <a:r>
-              <a:rPr lang="uk-UA" sz="3200" b="1">
-                <a:solidFill>
-                  <a:srgbClr val="F4B6C8"/>
-                </a:solidFill>
-                <a:latin typeface="Fira Sans Extra Condensed Bold"/>
-                <a:ea typeface="Fira Sans Extra Condensed Bold"/>
-                <a:cs typeface="Fira Sans Extra Condensed Bold"/>
-                <a:sym typeface="Fira Sans Extra Condensed Bold"/>
-              </a:rPr>
-              <a:t>Оператор</a:t>
-            </a:r>
-          </a:p>
-        </p:txBody>
-      </p:sp>
-      <p:sp>
-        <p:nvSpPr>
-          <p:cNvPr name="TextBox 11" id="11"/>
-          <p:cNvSpPr txBox="true"/>
-          <p:nvPr/>
-        </p:nvSpPr>
-        <p:spPr>
-          <a:xfrm>
-            <a:off x="12342556" y="3450000"/>
-            <a:ext cx="4559303" cy="4900000"/>
-          </a:xfrm>
-          <a:prstGeom prst="rect">
-            <a:avLst/>
-          </a:prstGeom>
-        </p:spPr>
-        <p:txBody>
-          <a:bodyPr anchor="t" wrap="square" rtlCol="false" tIns="0" lIns="0" bIns="0" rIns="0">
-            <a:noAutofit/>
-          </a:bodyPr>
-          <a:lstStyle/>
-          <a:p>
-            <a:pPr algn="l">
-              <a:lnSpc>
-                <a:spcPct val="100000"/>
-              </a:lnSpc>
-              <a:spcAft>
-                <a:spcPts val="1800"/>
-              </a:spcAft>
-            </a:pPr>
-            <a:r>
-              <a:rPr lang="uk-UA" sz="2400" b="0">
-                <a:solidFill>
-                  <a:srgbClr val="FBFBF8"/>
-                </a:solidFill>
-                <a:latin typeface="Fira Sans Extra Condensed"/>
-                <a:ea typeface="Fira Sans Extra Condensed"/>
-                <a:cs typeface="Fira Sans Extra Condensed"/>
-                <a:sym typeface="Fira Sans Extra Condensed"/>
-              </a:rPr>
-              <a:t>— Фінансує закріплені за роллю витрати</a:t>
-            </a:r>
-          </a:p>
-          <a:p>
-            <a:pPr algn="l">
-              <a:lnSpc>
-                <a:spcPct val="100000"/>
-              </a:lnSpc>
-              <a:spcAft>
-                <a:spcPts val="1800"/>
-              </a:spcAft>
-            </a:pPr>
-            <a:r>
-              <a:rPr lang="uk-UA" sz="2400" b="0">
-                <a:solidFill>
-                  <a:srgbClr val="FBFBF8"/>
-                </a:solidFill>
-                <a:latin typeface="Fira Sans Extra Condensed"/>
-                <a:ea typeface="Fira Sans Extra Condensed"/>
-                <a:cs typeface="Fira Sans Extra Condensed"/>
-                <a:sym typeface="Fira Sans Extra Condensed"/>
-              </a:rPr>
-              <a:t>— Комплектує команду, замовляє продукти</a:t>
-            </a:r>
-          </a:p>
-          <a:p>
-            <a:pPr algn="l">
-              <a:lnSpc>
-                <a:spcPct val="100000"/>
-              </a:lnSpc>
-              <a:spcAft>
-                <a:spcPts val="1800"/>
-              </a:spcAft>
-            </a:pPr>
-            <a:r>
-              <a:rPr lang="uk-UA" sz="2400" b="0">
-                <a:solidFill>
-                  <a:srgbClr val="FBFBF8"/>
-                </a:solidFill>
-                <a:latin typeface="Fira Sans Extra Condensed"/>
-                <a:ea typeface="Fira Sans Extra Condensed"/>
-                <a:cs typeface="Fira Sans Extra Condensed"/>
-                <a:sym typeface="Fira Sans Extra Condensed"/>
-              </a:rPr>
-              <a:t>— Щодня керує пекарнею за стандартами</a:t>
-            </a:r>
-          </a:p>
-          <a:p>
-            <a:pPr algn="l">
-              <a:lnSpc>
-                <a:spcPct val="100000"/>
-              </a:lnSpc>
-              <a:spcAft>
-                <a:spcPts val="1800"/>
-              </a:spcAft>
-            </a:pPr>
-            <a:r>
-              <a:rPr lang="uk-UA" sz="2400" b="0">
-                <a:solidFill>
-                  <a:srgbClr val="FBFBF8"/>
-                </a:solidFill>
-                <a:latin typeface="Fira Sans Extra Condensed"/>
-                <a:ea typeface="Fira Sans Extra Condensed"/>
-                <a:cs typeface="Fira Sans Extra Condensed"/>
-                <a:sym typeface="Fira Sans Extra Condensed"/>
-              </a:rPr>
-              <a:t>— Звітує про результати</a:t>
-            </a:r>
-          </a:p>
-          <a:p>
-            <a:pPr algn="l">
-              <a:lnSpc>
-                <a:spcPct val="100000"/>
-              </a:lnSpc>
-              <a:spcAft>
-                <a:spcPts val="1800"/>
-              </a:spcAft>
-            </a:pPr>
-            <a:r>
-              <a:rPr lang="uk-UA" sz="2400" b="0">
-                <a:solidFill>
-                  <a:srgbClr val="FBFBF8"/>
-                </a:solidFill>
-                <a:latin typeface="Fira Sans Extra Condensed"/>
-                <a:ea typeface="Fira Sans Extra Condensed"/>
-                <a:cs typeface="Fira Sans Extra Condensed"/>
-                <a:sym typeface="Fira Sans Extra Condensed"/>
-              </a:rPr>
-              <a:t>— Отримує частку прибутку за шкалою</a:t>
-            </a:r>
-          </a:p>
-        </p:txBody>
-      </p:sp>
-      <p:sp>
-        <p:nvSpPr>
-          <p:cNvPr name="Note 12" id="12"/>
-          <p:cNvSpPr/>
-          <p:nvPr/>
-        </p:nvSpPr>
-        <p:spPr>
-          <a:xfrm>
-            <a:off x="1219200" y="8750000"/>
-            <a:ext cx="15849600" cy="1000000"/>
-          </a:xfrm>
-          <a:prstGeom prst="roundRect">
-            <a:avLst>
-              <a:gd name="adj" fmla="val 7000"/>
-            </a:avLst>
-          </a:prstGeom>
-          <a:solidFill>
-            <a:srgbClr val="F4B6C8"/>
-          </a:solidFill>
-        </p:spPr>
-      </p:sp>
-      <p:sp>
-        <p:nvSpPr>
-          <p:cNvPr name="TextBox 13" id="13"/>
-          <p:cNvSpPr txBox="true"/>
-          <p:nvPr/>
-        </p:nvSpPr>
-        <p:spPr>
-          <a:xfrm>
-            <a:off x="1500000" y="8750000"/>
-            <a:ext cx="15286000" cy="1000000"/>
-          </a:xfrm>
-          <a:prstGeom prst="rect">
-            <a:avLst/>
-          </a:prstGeom>
-        </p:spPr>
-        <p:txBody>
-          <a:bodyPr anchor="ctr" wrap="square" rtlCol="false" tIns="0" lIns="0" bIns="0" rIns="0">
-            <a:noAutofit/>
-          </a:bodyPr>
-          <a:lstStyle/>
-          <a:p>
-            <a:pPr algn="ctr">
-              <a:lnSpc>
-                <a:spcPct val="100000"/>
-              </a:lnSpc>
-              <a:spcAft>
-                <a:spcPts val="0"/>
-              </a:spcAft>
-            </a:pPr>
-            <a:r>
-              <a:rPr lang="uk-UA" sz="2600" b="1">
-                <a:solidFill>
-                  <a:srgbClr val="0E4D38"/>
-                </a:solidFill>
-                <a:latin typeface="Fira Sans Extra Condensed Bold"/>
-                <a:ea typeface="Fira Sans Extra Condensed Bold"/>
-                <a:cs typeface="Fira Sans Extra Condensed Bold"/>
-                <a:sym typeface="Fira Sans Extra Condensed Bold"/>
-              </a:rPr>
-              <a:t>Детальні переліки — у додатках до договору</a:t>
+              <a:t>Сторони та предмет</a:t>
             </a:r>
           </a:p>
         </p:txBody>
@@ -24595,660 +24078,26 @@
             <a:r>
               <a:rPr lang="uk-UA" sz="5400" b="1">
                 <a:solidFill>
-                  <a:srgbClr val="FBFBF8"/>
+                  <a:srgbClr val="F4B6C8"/>
                 </a:solidFill>
                 <a:latin typeface="Fira Sans Extra Condensed Bold"/>
                 <a:ea typeface="Fira Sans Extra Condensed Bold"/>
                 <a:cs typeface="Fira Sans Extra Condensed Bold"/>
                 <a:sym typeface="Fira Sans Extra Condensed Bold"/>
               </a:rPr>
-              <a:t>Фінансові </a:t>
+              <a:t>2  </a:t>
             </a:r>
             <a:r>
               <a:rPr lang="uk-UA" sz="5400" b="1">
                 <a:solidFill>
-                  <a:srgbClr val="F4B6C8"/>
+                  <a:srgbClr val="FBFBF8"/>
                 </a:solidFill>
                 <a:latin typeface="Fira Sans Extra Condensed Bold"/>
                 <a:ea typeface="Fira Sans Extra Condensed Bold"/>
                 <a:cs typeface="Fira Sans Extra Condensed Bold"/>
                 <a:sym typeface="Fira Sans Extra Condensed Bold"/>
               </a:rPr>
-              <a:t>умови</a:t>
-            </a:r>
-          </a:p>
-        </p:txBody>
-      </p:sp>
-      <p:sp>
-        <p:nvSpPr>
-          <p:cNvPr name="Card 3" id="3"/>
-          <p:cNvSpPr/>
-          <p:nvPr/>
-        </p:nvSpPr>
-        <p:spPr>
-          <a:xfrm>
-            <a:off x="1219200" y="2300000"/>
-            <a:ext cx="5130803" cy="6200000"/>
-          </a:xfrm>
-          <a:prstGeom prst="roundRect">
-            <a:avLst>
-              <a:gd name="adj" fmla="val 7000"/>
-            </a:avLst>
-          </a:prstGeom>
-          <a:solidFill>
-            <a:srgbClr val="135F45"/>
-          </a:solidFill>
-        </p:spPr>
-      </p:sp>
-      <p:sp>
-        <p:nvSpPr>
-          <p:cNvPr name="TextBox 4" id="4"/>
-          <p:cNvSpPr txBox="true"/>
-          <p:nvPr/>
-        </p:nvSpPr>
-        <p:spPr>
-          <a:xfrm>
-            <a:off x="1504950" y="2550000"/>
-            <a:ext cx="4559303" cy="1000000"/>
-          </a:xfrm>
-          <a:prstGeom prst="rect">
-            <a:avLst/>
-          </a:prstGeom>
-        </p:spPr>
-        <p:txBody>
-          <a:bodyPr anchor="t" wrap="square" rtlCol="false" tIns="0" lIns="0" bIns="0" rIns="0">
-            <a:noAutofit/>
-          </a:bodyPr>
-          <a:lstStyle/>
-          <a:p>
-            <a:pPr algn="l">
-              <a:lnSpc>
-                <a:spcPct val="100000"/>
-              </a:lnSpc>
-              <a:spcAft>
-                <a:spcPts val="0"/>
-              </a:spcAft>
-            </a:pPr>
-            <a:r>
-              <a:rPr lang="uk-UA" sz="3000" b="1">
-                <a:solidFill>
-                  <a:srgbClr val="F4B6C8"/>
-                </a:solidFill>
-                <a:latin typeface="Fira Sans Extra Condensed Bold"/>
-                <a:ea typeface="Fira Sans Extra Condensed Bold"/>
-                <a:cs typeface="Fira Sans Extra Condensed Bold"/>
-                <a:sym typeface="Fira Sans Extra Condensed Bold"/>
-              </a:rPr>
-              <a:t>Початкові інвестиції</a:t>
-            </a:r>
-          </a:p>
-        </p:txBody>
-      </p:sp>
-      <p:sp>
-        <p:nvSpPr>
-          <p:cNvPr name="TextBox 5" id="5"/>
-          <p:cNvSpPr txBox="true"/>
-          <p:nvPr/>
-        </p:nvSpPr>
-        <p:spPr>
-          <a:xfrm>
-            <a:off x="1504950" y="3800000"/>
-            <a:ext cx="4559303" cy="4500000"/>
-          </a:xfrm>
-          <a:prstGeom prst="rect">
-            <a:avLst/>
-          </a:prstGeom>
-        </p:spPr>
-        <p:txBody>
-          <a:bodyPr anchor="t" wrap="square" rtlCol="false" tIns="0" lIns="0" bIns="0" rIns="0">
-            <a:noAutofit/>
-          </a:bodyPr>
-          <a:lstStyle/>
-          <a:p>
-            <a:pPr algn="l">
-              <a:lnSpc>
-                <a:spcPct val="100000"/>
-              </a:lnSpc>
-              <a:spcAft>
-                <a:spcPts val="200"/>
-              </a:spcAft>
-            </a:pPr>
-            <a:r>
-              <a:rPr lang="uk-UA" sz="2200" b="0">
-                <a:solidFill>
-                  <a:srgbClr val="F4B6C8"/>
-                </a:solidFill>
-                <a:latin typeface="Fira Sans Extra Condensed"/>
-                <a:ea typeface="Fira Sans Extra Condensed"/>
-                <a:cs typeface="Fira Sans Extra Condensed"/>
-                <a:sym typeface="Fira Sans Extra Condensed"/>
-              </a:rPr>
-              <a:t>Інвестор</a:t>
-            </a:r>
-          </a:p>
-          <a:p>
-            <a:pPr algn="l">
-              <a:lnSpc>
-                <a:spcPct val="100000"/>
-              </a:lnSpc>
-              <a:spcAft>
-                <a:spcPts val="2200"/>
-              </a:spcAft>
-            </a:pPr>
-            <a:r>
-              <a:rPr lang="uk-UA" sz="2800" b="1">
-                <a:solidFill>
-                  <a:srgbClr val="FBFBF8"/>
-                </a:solidFill>
-                <a:latin typeface="Fira Sans Extra Condensed Bold"/>
-                <a:ea typeface="Fira Sans Extra Condensed Bold"/>
-                <a:cs typeface="Fira Sans Extra Condensed Bold"/>
-                <a:sym typeface="Fira Sans Extra Condensed Bold"/>
-              </a:rPr>
-              <a:t>€188 000 – €266 000</a:t>
-            </a:r>
-          </a:p>
-          <a:p>
-            <a:pPr algn="l">
-              <a:lnSpc>
-                <a:spcPct val="100000"/>
-              </a:lnSpc>
-              <a:spcAft>
-                <a:spcPts val="200"/>
-              </a:spcAft>
-            </a:pPr>
-            <a:r>
-              <a:rPr lang="uk-UA" sz="2200" b="0">
-                <a:solidFill>
-                  <a:srgbClr val="F4B6C8"/>
-                </a:solidFill>
-                <a:latin typeface="Fira Sans Extra Condensed"/>
-                <a:ea typeface="Fira Sans Extra Condensed"/>
-                <a:cs typeface="Fira Sans Extra Condensed"/>
-                <a:sym typeface="Fira Sans Extra Condensed"/>
-              </a:rPr>
-              <a:t>Оператор</a:t>
-            </a:r>
-          </a:p>
-          <a:p>
-            <a:pPr algn="l">
-              <a:lnSpc>
-                <a:spcPct val="100000"/>
-              </a:lnSpc>
-              <a:spcAft>
-                <a:spcPts val="2200"/>
-              </a:spcAft>
-            </a:pPr>
-            <a:r>
-              <a:rPr lang="uk-UA" sz="2800" b="1">
-                <a:solidFill>
-                  <a:srgbClr val="FBFBF8"/>
-                </a:solidFill>
-                <a:latin typeface="Fira Sans Extra Condensed Bold"/>
-                <a:ea typeface="Fira Sans Extra Condensed Bold"/>
-                <a:cs typeface="Fira Sans Extra Condensed Bold"/>
-                <a:sym typeface="Fira Sans Extra Condensed Bold"/>
-              </a:rPr>
-              <a:t>€42 000 – €50 000</a:t>
-            </a:r>
-          </a:p>
-        </p:txBody>
-      </p:sp>
-      <p:sp>
-        <p:nvSpPr>
-          <p:cNvPr name="Card 6" id="6"/>
-          <p:cNvSpPr/>
-          <p:nvPr/>
-        </p:nvSpPr>
-        <p:spPr>
-          <a:xfrm>
-            <a:off x="6638003" y="2300000"/>
-            <a:ext cx="5130803" cy="6200000"/>
-          </a:xfrm>
-          <a:prstGeom prst="roundRect">
-            <a:avLst>
-              <a:gd name="adj" fmla="val 7000"/>
-            </a:avLst>
-          </a:prstGeom>
-          <a:solidFill>
-            <a:srgbClr val="135F45"/>
-          </a:solidFill>
-        </p:spPr>
-      </p:sp>
-      <p:sp>
-        <p:nvSpPr>
-          <p:cNvPr name="TextBox 7" id="7"/>
-          <p:cNvSpPr txBox="true"/>
-          <p:nvPr/>
-        </p:nvSpPr>
-        <p:spPr>
-          <a:xfrm>
-            <a:off x="6923753" y="2550000"/>
-            <a:ext cx="4559303" cy="1000000"/>
-          </a:xfrm>
-          <a:prstGeom prst="rect">
-            <a:avLst/>
-          </a:prstGeom>
-        </p:spPr>
-        <p:txBody>
-          <a:bodyPr anchor="t" wrap="square" rtlCol="false" tIns="0" lIns="0" bIns="0" rIns="0">
-            <a:noAutofit/>
-          </a:bodyPr>
-          <a:lstStyle/>
-          <a:p>
-            <a:pPr algn="l">
-              <a:lnSpc>
-                <a:spcPct val="100000"/>
-              </a:lnSpc>
-              <a:spcAft>
-                <a:spcPts val="0"/>
-              </a:spcAft>
-            </a:pPr>
-            <a:r>
-              <a:rPr lang="uk-UA" sz="3000" b="1">
-                <a:solidFill>
-                  <a:srgbClr val="F4B6C8"/>
-                </a:solidFill>
-                <a:latin typeface="Fira Sans Extra Condensed Bold"/>
-                <a:ea typeface="Fira Sans Extra Condensed Bold"/>
-                <a:cs typeface="Fira Sans Extra Condensed Bold"/>
-                <a:sym typeface="Fira Sans Extra Condensed Bold"/>
-              </a:rPr>
-              <a:t>Шкала розподілу прибутку</a:t>
-            </a:r>
-          </a:p>
-        </p:txBody>
-      </p:sp>
-      <p:sp>
-        <p:nvSpPr>
-          <p:cNvPr name="TextBox 8" id="8"/>
-          <p:cNvSpPr txBox="true"/>
-          <p:nvPr/>
-        </p:nvSpPr>
-        <p:spPr>
-          <a:xfrm>
-            <a:off x="6923753" y="3800000"/>
-            <a:ext cx="4559303" cy="4500000"/>
-          </a:xfrm>
-          <a:prstGeom prst="rect">
-            <a:avLst/>
-          </a:prstGeom>
-        </p:spPr>
-        <p:txBody>
-          <a:bodyPr anchor="t" wrap="square" rtlCol="false" tIns="0" lIns="0" bIns="0" rIns="0">
-            <a:noAutofit/>
-          </a:bodyPr>
-          <a:lstStyle/>
-          <a:p>
-            <a:pPr algn="l">
-              <a:lnSpc>
-                <a:spcPct val="100000"/>
-              </a:lnSpc>
-              <a:spcAft>
-                <a:spcPts val="200"/>
-              </a:spcAft>
-            </a:pPr>
-            <a:r>
-              <a:rPr lang="uk-UA" sz="2200" b="0">
-                <a:solidFill>
-                  <a:srgbClr val="F4B6C8"/>
-                </a:solidFill>
-                <a:latin typeface="Fira Sans Extra Condensed"/>
-                <a:ea typeface="Fira Sans Extra Condensed"/>
-                <a:cs typeface="Fira Sans Extra Condensed"/>
-                <a:sym typeface="Fira Sans Extra Condensed"/>
-              </a:rPr>
-              <a:t>Етап 1 (до 50% окупності)</a:t>
-            </a:r>
-          </a:p>
-          <a:p>
-            <a:pPr algn="l">
-              <a:lnSpc>
-                <a:spcPct val="100000"/>
-              </a:lnSpc>
-              <a:spcAft>
-                <a:spcPts val="2200"/>
-              </a:spcAft>
-            </a:pPr>
-            <a:r>
-              <a:rPr lang="uk-UA" sz="2800" b="1">
-                <a:solidFill>
-                  <a:srgbClr val="FBFBF8"/>
-                </a:solidFill>
-                <a:latin typeface="Fira Sans Extra Condensed Bold"/>
-                <a:ea typeface="Fira Sans Extra Condensed Bold"/>
-                <a:cs typeface="Fira Sans Extra Condensed Bold"/>
-                <a:sym typeface="Fira Sans Extra Condensed Bold"/>
-              </a:rPr>
-              <a:t>інвестор 60% / оператор 40%</a:t>
-            </a:r>
-          </a:p>
-          <a:p>
-            <a:pPr algn="l">
-              <a:lnSpc>
-                <a:spcPct val="100000"/>
-              </a:lnSpc>
-              <a:spcAft>
-                <a:spcPts val="200"/>
-              </a:spcAft>
-            </a:pPr>
-            <a:r>
-              <a:rPr lang="uk-UA" sz="2200" b="0">
-                <a:solidFill>
-                  <a:srgbClr val="F4B6C8"/>
-                </a:solidFill>
-                <a:latin typeface="Fira Sans Extra Condensed"/>
-                <a:ea typeface="Fira Sans Extra Condensed"/>
-                <a:cs typeface="Fira Sans Extra Condensed"/>
-                <a:sym typeface="Fira Sans Extra Condensed"/>
-              </a:rPr>
-              <a:t>Етап 2 (до 100%)</a:t>
-            </a:r>
-          </a:p>
-          <a:p>
-            <a:pPr algn="l">
-              <a:lnSpc>
-                <a:spcPct val="100000"/>
-              </a:lnSpc>
-              <a:spcAft>
-                <a:spcPts val="2200"/>
-              </a:spcAft>
-            </a:pPr>
-            <a:r>
-              <a:rPr lang="uk-UA" sz="2800" b="1">
-                <a:solidFill>
-                  <a:srgbClr val="FBFBF8"/>
-                </a:solidFill>
-                <a:latin typeface="Fira Sans Extra Condensed Bold"/>
-                <a:ea typeface="Fira Sans Extra Condensed Bold"/>
-                <a:cs typeface="Fira Sans Extra Condensed Bold"/>
-                <a:sym typeface="Fira Sans Extra Condensed Bold"/>
-              </a:rPr>
-              <a:t>50% / 50%</a:t>
-            </a:r>
-          </a:p>
-          <a:p>
-            <a:pPr algn="l">
-              <a:lnSpc>
-                <a:spcPct val="100000"/>
-              </a:lnSpc>
-              <a:spcAft>
-                <a:spcPts val="200"/>
-              </a:spcAft>
-            </a:pPr>
-            <a:r>
-              <a:rPr lang="uk-UA" sz="2200" b="0">
-                <a:solidFill>
-                  <a:srgbClr val="F4B6C8"/>
-                </a:solidFill>
-                <a:latin typeface="Fira Sans Extra Condensed"/>
-                <a:ea typeface="Fira Sans Extra Condensed"/>
-                <a:cs typeface="Fira Sans Extra Condensed"/>
-                <a:sym typeface="Fira Sans Extra Condensed"/>
-              </a:rPr>
-              <a:t>Етап 3 (після окупності)</a:t>
-            </a:r>
-          </a:p>
-          <a:p>
-            <a:pPr algn="l">
-              <a:lnSpc>
-                <a:spcPct val="100000"/>
-              </a:lnSpc>
-              <a:spcAft>
-                <a:spcPts val="2200"/>
-              </a:spcAft>
-            </a:pPr>
-            <a:r>
-              <a:rPr lang="uk-UA" sz="2800" b="1">
-                <a:solidFill>
-                  <a:srgbClr val="FBFBF8"/>
-                </a:solidFill>
-                <a:latin typeface="Fira Sans Extra Condensed Bold"/>
-                <a:ea typeface="Fira Sans Extra Condensed Bold"/>
-                <a:cs typeface="Fira Sans Extra Condensed Bold"/>
-                <a:sym typeface="Fira Sans Extra Condensed Bold"/>
-              </a:rPr>
-              <a:t>40% / 60%</a:t>
-            </a:r>
-          </a:p>
-        </p:txBody>
-      </p:sp>
-      <p:sp>
-        <p:nvSpPr>
-          <p:cNvPr name="Card 9" id="9"/>
-          <p:cNvSpPr/>
-          <p:nvPr/>
-        </p:nvSpPr>
-        <p:spPr>
-          <a:xfrm>
-            <a:off x="12056806" y="2300000"/>
-            <a:ext cx="5130803" cy="6200000"/>
-          </a:xfrm>
-          <a:prstGeom prst="roundRect">
-            <a:avLst>
-              <a:gd name="adj" fmla="val 7000"/>
-            </a:avLst>
-          </a:prstGeom>
-          <a:solidFill>
-            <a:srgbClr val="135F45"/>
-          </a:solidFill>
-        </p:spPr>
-      </p:sp>
-      <p:sp>
-        <p:nvSpPr>
-          <p:cNvPr name="TextBox 10" id="10"/>
-          <p:cNvSpPr txBox="true"/>
-          <p:nvPr/>
-        </p:nvSpPr>
-        <p:spPr>
-          <a:xfrm>
-            <a:off x="12342556" y="2550000"/>
-            <a:ext cx="4559303" cy="1000000"/>
-          </a:xfrm>
-          <a:prstGeom prst="rect">
-            <a:avLst/>
-          </a:prstGeom>
-        </p:spPr>
-        <p:txBody>
-          <a:bodyPr anchor="t" wrap="square" rtlCol="false" tIns="0" lIns="0" bIns="0" rIns="0">
-            <a:noAutofit/>
-          </a:bodyPr>
-          <a:lstStyle/>
-          <a:p>
-            <a:pPr algn="l">
-              <a:lnSpc>
-                <a:spcPct val="100000"/>
-              </a:lnSpc>
-              <a:spcAft>
-                <a:spcPts val="0"/>
-              </a:spcAft>
-            </a:pPr>
-            <a:r>
-              <a:rPr lang="uk-UA" sz="3000" b="1">
-                <a:solidFill>
-                  <a:srgbClr val="F4B6C8"/>
-                </a:solidFill>
-                <a:latin typeface="Fira Sans Extra Condensed Bold"/>
-                <a:ea typeface="Fira Sans Extra Condensed Bold"/>
-                <a:cs typeface="Fira Sans Extra Condensed Bold"/>
-                <a:sym typeface="Fira Sans Extra Condensed Bold"/>
-              </a:rPr>
-              <a:t>Платежі франчайзеру</a:t>
-            </a:r>
-          </a:p>
-        </p:txBody>
-      </p:sp>
-      <p:sp>
-        <p:nvSpPr>
-          <p:cNvPr name="TextBox 11" id="11"/>
-          <p:cNvSpPr txBox="true"/>
-          <p:nvPr/>
-        </p:nvSpPr>
-        <p:spPr>
-          <a:xfrm>
-            <a:off x="12342556" y="3800000"/>
-            <a:ext cx="4559303" cy="4500000"/>
-          </a:xfrm>
-          <a:prstGeom prst="rect">
-            <a:avLst/>
-          </a:prstGeom>
-        </p:spPr>
-        <p:txBody>
-          <a:bodyPr anchor="t" wrap="square" rtlCol="false" tIns="0" lIns="0" bIns="0" rIns="0">
-            <a:noAutofit/>
-          </a:bodyPr>
-          <a:lstStyle/>
-          <a:p>
-            <a:pPr algn="l">
-              <a:lnSpc>
-                <a:spcPct val="100000"/>
-              </a:lnSpc>
-              <a:spcAft>
-                <a:spcPts val="200"/>
-              </a:spcAft>
-            </a:pPr>
-            <a:r>
-              <a:rPr lang="uk-UA" sz="2200" b="0">
-                <a:solidFill>
-                  <a:srgbClr val="F4B6C8"/>
-                </a:solidFill>
-                <a:latin typeface="Fira Sans Extra Condensed"/>
-                <a:ea typeface="Fira Sans Extra Condensed"/>
-                <a:cs typeface="Fira Sans Extra Condensed"/>
-                <a:sym typeface="Fira Sans Extra Condensed"/>
-              </a:rPr>
-              <a:t>Від доходу</a:t>
-            </a:r>
-          </a:p>
-          <a:p>
-            <a:pPr algn="l">
-              <a:lnSpc>
-                <a:spcPct val="100000"/>
-              </a:lnSpc>
-              <a:spcAft>
-                <a:spcPts val="2200"/>
-              </a:spcAft>
-            </a:pPr>
-            <a:r>
-              <a:rPr lang="uk-UA" sz="2800" b="1">
-                <a:solidFill>
-                  <a:srgbClr val="FBFBF8"/>
-                </a:solidFill>
-                <a:latin typeface="Fira Sans Extra Condensed Bold"/>
-                <a:ea typeface="Fira Sans Extra Condensed Bold"/>
-                <a:cs typeface="Fira Sans Extra Condensed Bold"/>
-                <a:sym typeface="Fira Sans Extra Condensed Bold"/>
-              </a:rPr>
-              <a:t>1%</a:t>
-            </a:r>
-          </a:p>
-          <a:p>
-            <a:pPr algn="l">
-              <a:lnSpc>
-                <a:spcPct val="100000"/>
-              </a:lnSpc>
-              <a:spcAft>
-                <a:spcPts val="200"/>
-              </a:spcAft>
-            </a:pPr>
-            <a:r>
-              <a:rPr lang="uk-UA" sz="2200" b="0">
-                <a:solidFill>
-                  <a:srgbClr val="F4B6C8"/>
-                </a:solidFill>
-                <a:latin typeface="Fira Sans Extra Condensed"/>
-                <a:ea typeface="Fira Sans Extra Condensed"/>
-                <a:cs typeface="Fira Sans Extra Condensed"/>
-                <a:sym typeface="Fira Sans Extra Condensed"/>
-              </a:rPr>
-              <a:t>Від прибутку</a:t>
-            </a:r>
-          </a:p>
-          <a:p>
-            <a:pPr algn="l">
-              <a:lnSpc>
-                <a:spcPct val="100000"/>
-              </a:lnSpc>
-              <a:spcAft>
-                <a:spcPts val="2200"/>
-              </a:spcAft>
-            </a:pPr>
-            <a:r>
-              <a:rPr lang="uk-UA" sz="2800" b="1">
-                <a:solidFill>
-                  <a:srgbClr val="FBFBF8"/>
-                </a:solidFill>
-                <a:latin typeface="Fira Sans Extra Condensed Bold"/>
-                <a:ea typeface="Fira Sans Extra Condensed Bold"/>
-                <a:cs typeface="Fira Sans Extra Condensed Bold"/>
-                <a:sym typeface="Fira Sans Extra Condensed Bold"/>
-              </a:rPr>
-              <a:t>3%</a:t>
-            </a:r>
-          </a:p>
-        </p:txBody>
-      </p:sp>
-      <p:sp>
-        <p:nvSpPr>
-          <p:cNvPr name="Note 12" id="12"/>
-          <p:cNvSpPr/>
-          <p:nvPr/>
-        </p:nvSpPr>
-        <p:spPr>
-          <a:xfrm>
-            <a:off x="1219200" y="8750000"/>
-            <a:ext cx="15849600" cy="1000000"/>
-          </a:xfrm>
-          <a:prstGeom prst="roundRect">
-            <a:avLst>
-              <a:gd name="adj" fmla="val 7000"/>
-            </a:avLst>
-          </a:prstGeom>
-          <a:solidFill>
-            <a:srgbClr val="F4B6C8"/>
-          </a:solidFill>
-        </p:spPr>
-      </p:sp>
-      <p:sp>
-        <p:nvSpPr>
-          <p:cNvPr name="TextBox 13" id="13"/>
-          <p:cNvSpPr txBox="true"/>
-          <p:nvPr/>
-        </p:nvSpPr>
-        <p:spPr>
-          <a:xfrm>
-            <a:off x="1500000" y="8750000"/>
-            <a:ext cx="15286000" cy="1000000"/>
-          </a:xfrm>
-          <a:prstGeom prst="rect">
-            <a:avLst/>
-          </a:prstGeom>
-        </p:spPr>
-        <p:txBody>
-          <a:bodyPr anchor="ctr" wrap="square" rtlCol="false" tIns="0" lIns="0" bIns="0" rIns="0">
-            <a:noAutofit/>
-          </a:bodyPr>
-          <a:lstStyle/>
-          <a:p>
-            <a:pPr algn="ctr">
-              <a:lnSpc>
-                <a:spcPct val="100000"/>
-              </a:lnSpc>
-              <a:spcAft>
-                <a:spcPts val="0"/>
-              </a:spcAft>
-            </a:pPr>
-            <a:r>
-              <a:rPr lang="uk-UA" sz="2600" b="1">
-                <a:solidFill>
-                  <a:srgbClr val="0E4D38"/>
-                </a:solidFill>
-                <a:latin typeface="Fira Sans Extra Condensed Bold"/>
-                <a:ea typeface="Fira Sans Extra Condensed Bold"/>
-                <a:cs typeface="Fira Sans Extra Condensed Bold"/>
-                <a:sym typeface="Fira Sans Extra Condensed Bold"/>
-              </a:rPr>
-              <a:t>Цифри взято з поточної моделі; порядок виплат, звітність і перерахунки — до деталізації</a:t>
+              <a:t>Права й обов'язки</a:t>
             </a:r>
           </a:p>
         </p:txBody>
@@ -25317,61 +24166,72 @@
             <a:r>
               <a:rPr lang="uk-UA" sz="5400" b="1">
                 <a:solidFill>
-                  <a:srgbClr val="FBFBF8"/>
+                  <a:srgbClr val="F4B6C8"/>
                 </a:solidFill>
                 <a:latin typeface="Fira Sans Extra Condensed Bold"/>
                 <a:ea typeface="Fira Sans Extra Condensed Bold"/>
                 <a:cs typeface="Fira Sans Extra Condensed Bold"/>
                 <a:sym typeface="Fira Sans Extra Condensed Bold"/>
               </a:rPr>
-              <a:t>До деталізації у </a:t>
+              <a:t>3  </a:t>
             </a:r>
             <a:r>
               <a:rPr lang="uk-UA" sz="5400" b="1">
                 <a:solidFill>
-                  <a:srgbClr val="F4B6C8"/>
+                  <a:srgbClr val="FBFBF8"/>
                 </a:solidFill>
                 <a:latin typeface="Fira Sans Extra Condensed Bold"/>
                 <a:ea typeface="Fira Sans Extra Condensed Bold"/>
                 <a:cs typeface="Fira Sans Extra Condensed Bold"/>
                 <a:sym typeface="Fira Sans Extra Condensed Bold"/>
               </a:rPr>
-              <a:t>договорі</a:t>
+              <a:t>Фінанси</a:t>
             </a:r>
           </a:p>
         </p:txBody>
       </p:sp>
+    </p:spTree>
+  </p:cSld>
+  <p:clrMapOvr>
+    <a:masterClrMapping/>
+  </p:clrMapOvr>
+</p:sld>
+</file>
+
+<file path=ppt/slides/slide32.xml><?xml version="1.0" encoding="utf-8"?>
+<p:sld xmlns:p="http://schemas.openxmlformats.org/presentationml/2006/main" xmlns:a="http://schemas.openxmlformats.org/drawingml/2006/main">
+  <p:cSld>
+    <p:bg>
+      <p:bgPr>
+        <a:solidFill>
+          <a:srgbClr val="0E4D38"/>
+        </a:solidFill>
+      </p:bgPr>
+    </p:bg>
+    <p:spTree>
+      <p:nvGrpSpPr>
+        <p:cNvPr id="1" name=""/>
+        <p:cNvGrpSpPr/>
+        <p:nvPr/>
+      </p:nvGrpSpPr>
+      <p:grpSpPr>
+        <a:xfrm>
+          <a:off x="0" y="0"/>
+          <a:ext cx="0" cy="0"/>
+          <a:chOff x="0" y="0"/>
+          <a:chExt cx="0" cy="0"/>
+        </a:xfrm>
+      </p:grpSpPr>
       <p:sp>
         <p:nvSpPr>
-          <p:cNvPr name="Card 3" id="3"/>
-          <p:cNvSpPr/>
+          <p:cNvPr name="TextBox 2" id="2"/>
+          <p:cNvSpPr txBox="true"/>
           <p:nvPr/>
         </p:nvSpPr>
         <p:spPr>
           <a:xfrm>
-            <a:off x="1219200" y="2300000"/>
-            <a:ext cx="5130803" cy="2950000"/>
-          </a:xfrm>
-          <a:prstGeom prst="roundRect">
-            <a:avLst>
-              <a:gd name="adj" fmla="val 7000"/>
-            </a:avLst>
-          </a:prstGeom>
-          <a:solidFill>
-            <a:srgbClr val="135F45"/>
-          </a:solidFill>
-        </p:spPr>
-      </p:sp>
-      <p:sp>
-        <p:nvSpPr>
-          <p:cNvPr name="TextBox 4" id="4"/>
-          <p:cNvSpPr txBox="true"/>
-          <p:nvPr/>
-        </p:nvSpPr>
-        <p:spPr>
-          <a:xfrm>
-            <a:off x="1504950" y="2600000"/>
-            <a:ext cx="4559303" cy="700000"/>
+            <a:off x="981456" y="1000000"/>
+            <a:ext cx="16325088" cy="900000"/>
           </a:xfrm>
           <a:prstGeom prst="rect">
             <a:avLst/>
@@ -25383,7 +24243,7 @@
           </a:bodyPr>
           <a:lstStyle/>
           <a:p>
-            <a:pPr algn="l">
+            <a:pPr algn="ctr">
               <a:lnSpc>
                 <a:spcPct val="100000"/>
               </a:lnSpc>
@@ -25392,7 +24252,7 @@
               </a:spcAft>
             </a:pPr>
             <a:r>
-              <a:rPr lang="uk-UA" sz="3200" b="1">
+              <a:rPr lang="uk-UA" sz="5400" b="1">
                 <a:solidFill>
                   <a:srgbClr val="F4B6C8"/>
                 </a:solidFill>
@@ -25401,21 +24261,65 @@
                 <a:cs typeface="Fira Sans Extra Condensed Bold"/>
                 <a:sym typeface="Fira Sans Extra Condensed Bold"/>
               </a:rPr>
-              <a:t>Формат</a:t>
+              <a:t>4  </a:t>
+            </a:r>
+            <a:r>
+              <a:rPr lang="uk-UA" sz="5400" b="1">
+                <a:solidFill>
+                  <a:srgbClr val="FBFBF8"/>
+                </a:solidFill>
+                <a:latin typeface="Fira Sans Extra Condensed Bold"/>
+                <a:ea typeface="Fira Sans Extra Condensed Bold"/>
+                <a:cs typeface="Fira Sans Extra Condensed Bold"/>
+                <a:sym typeface="Fira Sans Extra Condensed Bold"/>
+              </a:rPr>
+              <a:t>Бренд і стандарти</a:t>
             </a:r>
           </a:p>
         </p:txBody>
       </p:sp>
+    </p:spTree>
+  </p:cSld>
+  <p:clrMapOvr>
+    <a:masterClrMapping/>
+  </p:clrMapOvr>
+</p:sld>
+</file>
+
+<file path=ppt/slides/slide33.xml><?xml version="1.0" encoding="utf-8"?>
+<p:sld xmlns:p="http://schemas.openxmlformats.org/presentationml/2006/main" xmlns:a="http://schemas.openxmlformats.org/drawingml/2006/main">
+  <p:cSld>
+    <p:bg>
+      <p:bgPr>
+        <a:solidFill>
+          <a:srgbClr val="0E4D38"/>
+        </a:solidFill>
+      </p:bgPr>
+    </p:bg>
+    <p:spTree>
+      <p:nvGrpSpPr>
+        <p:cNvPr id="1" name=""/>
+        <p:cNvGrpSpPr/>
+        <p:nvPr/>
+      </p:nvGrpSpPr>
+      <p:grpSpPr>
+        <a:xfrm>
+          <a:off x="0" y="0"/>
+          <a:ext cx="0" cy="0"/>
+          <a:chOff x="0" y="0"/>
+          <a:chExt cx="0" cy="0"/>
+        </a:xfrm>
+      </p:grpSpPr>
       <p:sp>
         <p:nvSpPr>
-          <p:cNvPr name="TextBox 5" id="5"/>
+          <p:cNvPr name="TextBox 2" id="2"/>
           <p:cNvSpPr txBox="true"/>
           <p:nvPr/>
         </p:nvSpPr>
         <p:spPr>
           <a:xfrm>
-            <a:off x="1504950" y="3500000"/>
-            <a:ext cx="4559303" cy="1600000"/>
+            <a:off x="981456" y="1000000"/>
+            <a:ext cx="16325088" cy="900000"/>
           </a:xfrm>
           <a:prstGeom prst="rect">
             <a:avLst/>
@@ -25427,7 +24331,7 @@
           </a:bodyPr>
           <a:lstStyle/>
           <a:p>
-            <a:pPr algn="l">
+            <a:pPr algn="ctr">
               <a:lnSpc>
                 <a:spcPct val="100000"/>
               </a:lnSpc>
@@ -25436,51 +24340,74 @@
               </a:spcAft>
             </a:pPr>
             <a:r>
-              <a:rPr lang="uk-UA" sz="2600" b="0">
+              <a:rPr lang="uk-UA" sz="5400" b="1">
+                <a:solidFill>
+                  <a:srgbClr val="F4B6C8"/>
+                </a:solidFill>
+                <a:latin typeface="Fira Sans Extra Condensed Bold"/>
+                <a:ea typeface="Fira Sans Extra Condensed Bold"/>
+                <a:cs typeface="Fira Sans Extra Condensed Bold"/>
+                <a:sym typeface="Fira Sans Extra Condensed Bold"/>
+              </a:rPr>
+              <a:t>5  </a:t>
+            </a:r>
+            <a:r>
+              <a:rPr lang="uk-UA" sz="5400" b="1">
                 <a:solidFill>
                   <a:srgbClr val="FBFBF8"/>
                 </a:solidFill>
-                <a:latin typeface="Fira Sans Extra Condensed"/>
-                <a:ea typeface="Fira Sans Extra Condensed"/>
-                <a:cs typeface="Fira Sans Extra Condensed"/>
-                <a:sym typeface="Fira Sans Extra Condensed"/>
-              </a:rPr>
-              <a:t>Один тристоронній договір чи два пов'язані?</a:t>
+                <a:latin typeface="Fira Sans Extra Condensed Bold"/>
+                <a:ea typeface="Fira Sans Extra Condensed Bold"/>
+                <a:cs typeface="Fira Sans Extra Condensed Bold"/>
+                <a:sym typeface="Fira Sans Extra Condensed Bold"/>
+              </a:rPr>
+              <a:t>Звітність і контроль</a:t>
             </a:r>
           </a:p>
         </p:txBody>
       </p:sp>
+    </p:spTree>
+  </p:cSld>
+  <p:clrMapOvr>
+    <a:masterClrMapping/>
+  </p:clrMapOvr>
+</p:sld>
+</file>
+
+<file path=ppt/slides/slide34.xml><?xml version="1.0" encoding="utf-8"?>
+<p:sld xmlns:p="http://schemas.openxmlformats.org/presentationml/2006/main" xmlns:a="http://schemas.openxmlformats.org/drawingml/2006/main">
+  <p:cSld>
+    <p:bg>
+      <p:bgPr>
+        <a:solidFill>
+          <a:srgbClr val="0E4D38"/>
+        </a:solidFill>
+      </p:bgPr>
+    </p:bg>
+    <p:spTree>
+      <p:nvGrpSpPr>
+        <p:cNvPr id="1" name=""/>
+        <p:cNvGrpSpPr/>
+        <p:nvPr/>
+      </p:nvGrpSpPr>
+      <p:grpSpPr>
+        <a:xfrm>
+          <a:off x="0" y="0"/>
+          <a:ext cx="0" cy="0"/>
+          <a:chOff x="0" y="0"/>
+          <a:chExt cx="0" cy="0"/>
+        </a:xfrm>
+      </p:grpSpPr>
       <p:sp>
         <p:nvSpPr>
-          <p:cNvPr name="Card 6" id="6"/>
-          <p:cNvSpPr/>
+          <p:cNvPr name="TextBox 2" id="2"/>
+          <p:cNvSpPr txBox="true"/>
           <p:nvPr/>
         </p:nvSpPr>
         <p:spPr>
           <a:xfrm>
-            <a:off x="6638003" y="2300000"/>
-            <a:ext cx="5130803" cy="2950000"/>
-          </a:xfrm>
-          <a:prstGeom prst="roundRect">
-            <a:avLst>
-              <a:gd name="adj" fmla="val 7000"/>
-            </a:avLst>
-          </a:prstGeom>
-          <a:solidFill>
-            <a:srgbClr val="135F45"/>
-          </a:solidFill>
-        </p:spPr>
-      </p:sp>
-      <p:sp>
-        <p:nvSpPr>
-          <p:cNvPr name="TextBox 7" id="7"/>
-          <p:cNvSpPr txBox="true"/>
-          <p:nvPr/>
-        </p:nvSpPr>
-        <p:spPr>
-          <a:xfrm>
-            <a:off x="6923753" y="2600000"/>
-            <a:ext cx="4559303" cy="700000"/>
+            <a:off x="981456" y="1000000"/>
+            <a:ext cx="16325088" cy="900000"/>
           </a:xfrm>
           <a:prstGeom prst="rect">
             <a:avLst/>
@@ -25492,7 +24419,7 @@
           </a:bodyPr>
           <a:lstStyle/>
           <a:p>
-            <a:pPr algn="l">
+            <a:pPr algn="ctr">
               <a:lnSpc>
                 <a:spcPct val="100000"/>
               </a:lnSpc>
@@ -25501,7 +24428,7 @@
               </a:spcAft>
             </a:pPr>
             <a:r>
-              <a:rPr lang="uk-UA" sz="3200" b="1">
+              <a:rPr lang="uk-UA" sz="5400" b="1">
                 <a:solidFill>
                   <a:srgbClr val="F4B6C8"/>
                 </a:solidFill>
@@ -25510,21 +24437,65 @@
                 <a:cs typeface="Fira Sans Extra Condensed Bold"/>
                 <a:sym typeface="Fira Sans Extra Condensed Bold"/>
               </a:rPr>
-              <a:t>Строк</a:t>
+              <a:t>6  </a:t>
+            </a:r>
+            <a:r>
+              <a:rPr lang="uk-UA" sz="5400" b="1">
+                <a:solidFill>
+                  <a:srgbClr val="FBFBF8"/>
+                </a:solidFill>
+                <a:latin typeface="Fira Sans Extra Condensed Bold"/>
+                <a:ea typeface="Fira Sans Extra Condensed Bold"/>
+                <a:cs typeface="Fira Sans Extra Condensed Bold"/>
+                <a:sym typeface="Fira Sans Extra Condensed Bold"/>
+              </a:rPr>
+              <a:t>Строк і продовження</a:t>
             </a:r>
           </a:p>
         </p:txBody>
       </p:sp>
+    </p:spTree>
+  </p:cSld>
+  <p:clrMapOvr>
+    <a:masterClrMapping/>
+  </p:clrMapOvr>
+</p:sld>
+</file>
+
+<file path=ppt/slides/slide35.xml><?xml version="1.0" encoding="utf-8"?>
+<p:sld xmlns:p="http://schemas.openxmlformats.org/presentationml/2006/main" xmlns:a="http://schemas.openxmlformats.org/drawingml/2006/main">
+  <p:cSld>
+    <p:bg>
+      <p:bgPr>
+        <a:solidFill>
+          <a:srgbClr val="0E4D38"/>
+        </a:solidFill>
+      </p:bgPr>
+    </p:bg>
+    <p:spTree>
+      <p:nvGrpSpPr>
+        <p:cNvPr id="1" name=""/>
+        <p:cNvGrpSpPr/>
+        <p:nvPr/>
+      </p:nvGrpSpPr>
+      <p:grpSpPr>
+        <a:xfrm>
+          <a:off x="0" y="0"/>
+          <a:ext cx="0" cy="0"/>
+          <a:chOff x="0" y="0"/>
+          <a:chExt cx="0" cy="0"/>
+        </a:xfrm>
+      </p:grpSpPr>
       <p:sp>
         <p:nvSpPr>
-          <p:cNvPr name="TextBox 8" id="8"/>
+          <p:cNvPr name="TextBox 2" id="2"/>
           <p:cNvSpPr txBox="true"/>
           <p:nvPr/>
         </p:nvSpPr>
         <p:spPr>
           <a:xfrm>
-            <a:off x="6923753" y="3500000"/>
-            <a:ext cx="4559303" cy="1600000"/>
+            <a:off x="981456" y="1000000"/>
+            <a:ext cx="16325088" cy="900000"/>
           </a:xfrm>
           <a:prstGeom prst="rect">
             <a:avLst/>
@@ -25536,7 +24507,7 @@
           </a:bodyPr>
           <a:lstStyle/>
           <a:p>
-            <a:pPr algn="l">
+            <a:pPr algn="ctr">
               <a:lnSpc>
                 <a:spcPct val="100000"/>
               </a:lnSpc>
@@ -25545,51 +24516,74 @@
               </a:spcAft>
             </a:pPr>
             <a:r>
-              <a:rPr lang="uk-UA" sz="2600" b="0">
+              <a:rPr lang="uk-UA" sz="5400" b="1">
+                <a:solidFill>
+                  <a:srgbClr val="F4B6C8"/>
+                </a:solidFill>
+                <a:latin typeface="Fira Sans Extra Condensed Bold"/>
+                <a:ea typeface="Fira Sans Extra Condensed Bold"/>
+                <a:cs typeface="Fira Sans Extra Condensed Bold"/>
+                <a:sym typeface="Fira Sans Extra Condensed Bold"/>
+              </a:rPr>
+              <a:t>7  </a:t>
+            </a:r>
+            <a:r>
+              <a:rPr lang="uk-UA" sz="5400" b="1">
                 <a:solidFill>
                   <a:srgbClr val="FBFBF8"/>
                 </a:solidFill>
-                <a:latin typeface="Fira Sans Extra Condensed"/>
-                <a:ea typeface="Fira Sans Extra Condensed"/>
-                <a:cs typeface="Fira Sans Extra Condensed"/>
-                <a:sym typeface="Fira Sans Extra Condensed"/>
-              </a:rPr>
-              <a:t>Тривалість і умови продовження</a:t>
+                <a:latin typeface="Fira Sans Extra Condensed Bold"/>
+                <a:ea typeface="Fira Sans Extra Condensed Bold"/>
+                <a:cs typeface="Fira Sans Extra Condensed Bold"/>
+                <a:sym typeface="Fira Sans Extra Condensed Bold"/>
+              </a:rPr>
+              <a:t>Зміни та вихід</a:t>
             </a:r>
           </a:p>
         </p:txBody>
       </p:sp>
+    </p:spTree>
+  </p:cSld>
+  <p:clrMapOvr>
+    <a:masterClrMapping/>
+  </p:clrMapOvr>
+</p:sld>
+</file>
+
+<file path=ppt/slides/slide36.xml><?xml version="1.0" encoding="utf-8"?>
+<p:sld xmlns:p="http://schemas.openxmlformats.org/presentationml/2006/main" xmlns:a="http://schemas.openxmlformats.org/drawingml/2006/main">
+  <p:cSld>
+    <p:bg>
+      <p:bgPr>
+        <a:solidFill>
+          <a:srgbClr val="0E4D38"/>
+        </a:solidFill>
+      </p:bgPr>
+    </p:bg>
+    <p:spTree>
+      <p:nvGrpSpPr>
+        <p:cNvPr id="1" name=""/>
+        <p:cNvGrpSpPr/>
+        <p:nvPr/>
+      </p:nvGrpSpPr>
+      <p:grpSpPr>
+        <a:xfrm>
+          <a:off x="0" y="0"/>
+          <a:ext cx="0" cy="0"/>
+          <a:chOff x="0" y="0"/>
+          <a:chExt cx="0" cy="0"/>
+        </a:xfrm>
+      </p:grpSpPr>
       <p:sp>
         <p:nvSpPr>
-          <p:cNvPr name="Card 9" id="9"/>
-          <p:cNvSpPr/>
+          <p:cNvPr name="TextBox 2" id="2"/>
+          <p:cNvSpPr txBox="true"/>
           <p:nvPr/>
         </p:nvSpPr>
         <p:spPr>
           <a:xfrm>
-            <a:off x="12056806" y="2300000"/>
-            <a:ext cx="5130803" cy="2950000"/>
-          </a:xfrm>
-          <a:prstGeom prst="roundRect">
-            <a:avLst>
-              <a:gd name="adj" fmla="val 7000"/>
-            </a:avLst>
-          </a:prstGeom>
-          <a:solidFill>
-            <a:srgbClr val="135F45"/>
-          </a:solidFill>
-        </p:spPr>
-      </p:sp>
-      <p:sp>
-        <p:nvSpPr>
-          <p:cNvPr name="TextBox 10" id="10"/>
-          <p:cNvSpPr txBox="true"/>
-          <p:nvPr/>
-        </p:nvSpPr>
-        <p:spPr>
-          <a:xfrm>
-            <a:off x="12342556" y="2600000"/>
-            <a:ext cx="4559303" cy="700000"/>
+            <a:off x="981456" y="1000000"/>
+            <a:ext cx="16325088" cy="900000"/>
           </a:xfrm>
           <a:prstGeom prst="rect">
             <a:avLst/>
@@ -25601,442 +24595,6 @@
           </a:bodyPr>
           <a:lstStyle/>
           <a:p>
-            <a:pPr algn="l">
-              <a:lnSpc>
-                <a:spcPct val="100000"/>
-              </a:lnSpc>
-              <a:spcAft>
-                <a:spcPts val="0"/>
-              </a:spcAft>
-            </a:pPr>
-            <a:r>
-              <a:rPr lang="uk-UA" sz="3200" b="1">
-                <a:solidFill>
-                  <a:srgbClr val="F4B6C8"/>
-                </a:solidFill>
-                <a:latin typeface="Fira Sans Extra Condensed Bold"/>
-                <a:ea typeface="Fira Sans Extra Condensed Bold"/>
-                <a:cs typeface="Fira Sans Extra Condensed Bold"/>
-                <a:sym typeface="Fira Sans Extra Condensed Bold"/>
-              </a:rPr>
-              <a:t>Вихід інвестора</a:t>
-            </a:r>
-          </a:p>
-        </p:txBody>
-      </p:sp>
-      <p:sp>
-        <p:nvSpPr>
-          <p:cNvPr name="TextBox 11" id="11"/>
-          <p:cNvSpPr txBox="true"/>
-          <p:nvPr/>
-        </p:nvSpPr>
-        <p:spPr>
-          <a:xfrm>
-            <a:off x="12342556" y="3500000"/>
-            <a:ext cx="4559303" cy="1600000"/>
-          </a:xfrm>
-          <a:prstGeom prst="rect">
-            <a:avLst/>
-          </a:prstGeom>
-        </p:spPr>
-        <p:txBody>
-          <a:bodyPr anchor="t" wrap="square" rtlCol="false" tIns="0" lIns="0" bIns="0" rIns="0">
-            <a:noAutofit/>
-          </a:bodyPr>
-          <a:lstStyle/>
-          <a:p>
-            <a:pPr algn="l">
-              <a:lnSpc>
-                <a:spcPct val="100000"/>
-              </a:lnSpc>
-              <a:spcAft>
-                <a:spcPts val="0"/>
-              </a:spcAft>
-            </a:pPr>
-            <a:r>
-              <a:rPr lang="uk-UA" sz="2600" b="0">
-                <a:solidFill>
-                  <a:srgbClr val="FBFBF8"/>
-                </a:solidFill>
-                <a:latin typeface="Fira Sans Extra Condensed"/>
-                <a:ea typeface="Fira Sans Extra Condensed"/>
-                <a:cs typeface="Fira Sans Extra Condensed"/>
-                <a:sym typeface="Fira Sans Extra Condensed"/>
-              </a:rPr>
-              <a:t>Продаж частки, викуп, умови розірвання</a:t>
-            </a:r>
-          </a:p>
-        </p:txBody>
-      </p:sp>
-      <p:sp>
-        <p:nvSpPr>
-          <p:cNvPr name="Card 12" id="12"/>
-          <p:cNvSpPr/>
-          <p:nvPr/>
-        </p:nvSpPr>
-        <p:spPr>
-          <a:xfrm>
-            <a:off x="1219200" y="5550000"/>
-            <a:ext cx="5130803" cy="2950000"/>
-          </a:xfrm>
-          <a:prstGeom prst="roundRect">
-            <a:avLst>
-              <a:gd name="adj" fmla="val 7000"/>
-            </a:avLst>
-          </a:prstGeom>
-          <a:solidFill>
-            <a:srgbClr val="135F45"/>
-          </a:solidFill>
-        </p:spPr>
-      </p:sp>
-      <p:sp>
-        <p:nvSpPr>
-          <p:cNvPr name="TextBox 13" id="13"/>
-          <p:cNvSpPr txBox="true"/>
-          <p:nvPr/>
-        </p:nvSpPr>
-        <p:spPr>
-          <a:xfrm>
-            <a:off x="1504950" y="5850000"/>
-            <a:ext cx="4559303" cy="700000"/>
-          </a:xfrm>
-          <a:prstGeom prst="rect">
-            <a:avLst/>
-          </a:prstGeom>
-        </p:spPr>
-        <p:txBody>
-          <a:bodyPr anchor="t" wrap="square" rtlCol="false" tIns="0" lIns="0" bIns="0" rIns="0">
-            <a:noAutofit/>
-          </a:bodyPr>
-          <a:lstStyle/>
-          <a:p>
-            <a:pPr algn="l">
-              <a:lnSpc>
-                <a:spcPct val="100000"/>
-              </a:lnSpc>
-              <a:spcAft>
-                <a:spcPts val="0"/>
-              </a:spcAft>
-            </a:pPr>
-            <a:r>
-              <a:rPr lang="uk-UA" sz="3200" b="1">
-                <a:solidFill>
-                  <a:srgbClr val="F4B6C8"/>
-                </a:solidFill>
-                <a:latin typeface="Fira Sans Extra Condensed Bold"/>
-                <a:ea typeface="Fira Sans Extra Condensed Bold"/>
-                <a:cs typeface="Fira Sans Extra Condensed Bold"/>
-                <a:sym typeface="Fira Sans Extra Condensed Bold"/>
-              </a:rPr>
-              <a:t>Заміна оператора</a:t>
-            </a:r>
-          </a:p>
-        </p:txBody>
-      </p:sp>
-      <p:sp>
-        <p:nvSpPr>
-          <p:cNvPr name="TextBox 14" id="14"/>
-          <p:cNvSpPr txBox="true"/>
-          <p:nvPr/>
-        </p:nvSpPr>
-        <p:spPr>
-          <a:xfrm>
-            <a:off x="1504950" y="6750000"/>
-            <a:ext cx="4559303" cy="1600000"/>
-          </a:xfrm>
-          <a:prstGeom prst="rect">
-            <a:avLst/>
-          </a:prstGeom>
-        </p:spPr>
-        <p:txBody>
-          <a:bodyPr anchor="t" wrap="square" rtlCol="false" tIns="0" lIns="0" bIns="0" rIns="0">
-            <a:noAutofit/>
-          </a:bodyPr>
-          <a:lstStyle/>
-          <a:p>
-            <a:pPr algn="l">
-              <a:lnSpc>
-                <a:spcPct val="100000"/>
-              </a:lnSpc>
-              <a:spcAft>
-                <a:spcPts val="0"/>
-              </a:spcAft>
-            </a:pPr>
-            <a:r>
-              <a:rPr lang="uk-UA" sz="2600" b="0">
-                <a:solidFill>
-                  <a:srgbClr val="FBFBF8"/>
-                </a:solidFill>
-                <a:latin typeface="Fira Sans Extra Condensed"/>
-                <a:ea typeface="Fira Sans Extra Condensed"/>
-                <a:cs typeface="Fira Sans Extra Condensed"/>
-                <a:sym typeface="Fira Sans Extra Condensed"/>
-              </a:rPr>
-              <a:t>Підстави, порядок, права інвестора</a:t>
-            </a:r>
-          </a:p>
-        </p:txBody>
-      </p:sp>
-      <p:sp>
-        <p:nvSpPr>
-          <p:cNvPr name="Card 15" id="15"/>
-          <p:cNvSpPr/>
-          <p:nvPr/>
-        </p:nvSpPr>
-        <p:spPr>
-          <a:xfrm>
-            <a:off x="6638003" y="5550000"/>
-            <a:ext cx="5130803" cy="2950000"/>
-          </a:xfrm>
-          <a:prstGeom prst="roundRect">
-            <a:avLst>
-              <a:gd name="adj" fmla="val 7000"/>
-            </a:avLst>
-          </a:prstGeom>
-          <a:solidFill>
-            <a:srgbClr val="135F45"/>
-          </a:solidFill>
-        </p:spPr>
-      </p:sp>
-      <p:sp>
-        <p:nvSpPr>
-          <p:cNvPr name="TextBox 16" id="16"/>
-          <p:cNvSpPr txBox="true"/>
-          <p:nvPr/>
-        </p:nvSpPr>
-        <p:spPr>
-          <a:xfrm>
-            <a:off x="6923753" y="5850000"/>
-            <a:ext cx="4559303" cy="700000"/>
-          </a:xfrm>
-          <a:prstGeom prst="rect">
-            <a:avLst/>
-          </a:prstGeom>
-        </p:spPr>
-        <p:txBody>
-          <a:bodyPr anchor="t" wrap="square" rtlCol="false" tIns="0" lIns="0" bIns="0" rIns="0">
-            <a:noAutofit/>
-          </a:bodyPr>
-          <a:lstStyle/>
-          <a:p>
-            <a:pPr algn="l">
-              <a:lnSpc>
-                <a:spcPct val="100000"/>
-              </a:lnSpc>
-              <a:spcAft>
-                <a:spcPts val="0"/>
-              </a:spcAft>
-            </a:pPr>
-            <a:r>
-              <a:rPr lang="uk-UA" sz="3200" b="1">
-                <a:solidFill>
-                  <a:srgbClr val="F4B6C8"/>
-                </a:solidFill>
-                <a:latin typeface="Fira Sans Extra Condensed Bold"/>
-                <a:ea typeface="Fira Sans Extra Condensed Bold"/>
-                <a:cs typeface="Fira Sans Extra Condensed Bold"/>
-                <a:sym typeface="Fira Sans Extra Condensed Bold"/>
-              </a:rPr>
-              <a:t>Контроль</a:t>
-            </a:r>
-          </a:p>
-        </p:txBody>
-      </p:sp>
-      <p:sp>
-        <p:nvSpPr>
-          <p:cNvPr name="TextBox 17" id="17"/>
-          <p:cNvSpPr txBox="true"/>
-          <p:nvPr/>
-        </p:nvSpPr>
-        <p:spPr>
-          <a:xfrm>
-            <a:off x="6923753" y="6750000"/>
-            <a:ext cx="4559303" cy="1600000"/>
-          </a:xfrm>
-          <a:prstGeom prst="rect">
-            <a:avLst/>
-          </a:prstGeom>
-        </p:spPr>
-        <p:txBody>
-          <a:bodyPr anchor="t" wrap="square" rtlCol="false" tIns="0" lIns="0" bIns="0" rIns="0">
-            <a:noAutofit/>
-          </a:bodyPr>
-          <a:lstStyle/>
-          <a:p>
-            <a:pPr algn="l">
-              <a:lnSpc>
-                <a:spcPct val="100000"/>
-              </a:lnSpc>
-              <a:spcAft>
-                <a:spcPts val="0"/>
-              </a:spcAft>
-            </a:pPr>
-            <a:r>
-              <a:rPr lang="uk-UA" sz="2600" b="0">
-                <a:solidFill>
-                  <a:srgbClr val="FBFBF8"/>
-                </a:solidFill>
-                <a:latin typeface="Fira Sans Extra Condensed"/>
-                <a:ea typeface="Fira Sans Extra Condensed"/>
-                <a:cs typeface="Fira Sans Extra Condensed"/>
-                <a:sym typeface="Fira Sans Extra Condensed"/>
-              </a:rPr>
-              <a:t>Звітність, аудит, доступ до даних</a:t>
-            </a:r>
-          </a:p>
-        </p:txBody>
-      </p:sp>
-      <p:sp>
-        <p:nvSpPr>
-          <p:cNvPr name="Card 18" id="18"/>
-          <p:cNvSpPr/>
-          <p:nvPr/>
-        </p:nvSpPr>
-        <p:spPr>
-          <a:xfrm>
-            <a:off x="12056806" y="5550000"/>
-            <a:ext cx="5130803" cy="2950000"/>
-          </a:xfrm>
-          <a:prstGeom prst="roundRect">
-            <a:avLst>
-              <a:gd name="adj" fmla="val 7000"/>
-            </a:avLst>
-          </a:prstGeom>
-          <a:solidFill>
-            <a:srgbClr val="135F45"/>
-          </a:solidFill>
-        </p:spPr>
-      </p:sp>
-      <p:sp>
-        <p:nvSpPr>
-          <p:cNvPr name="TextBox 19" id="19"/>
-          <p:cNvSpPr txBox="true"/>
-          <p:nvPr/>
-        </p:nvSpPr>
-        <p:spPr>
-          <a:xfrm>
-            <a:off x="12342556" y="5850000"/>
-            <a:ext cx="4559303" cy="700000"/>
-          </a:xfrm>
-          <a:prstGeom prst="rect">
-            <a:avLst/>
-          </a:prstGeom>
-        </p:spPr>
-        <p:txBody>
-          <a:bodyPr anchor="t" wrap="square" rtlCol="false" tIns="0" lIns="0" bIns="0" rIns="0">
-            <a:noAutofit/>
-          </a:bodyPr>
-          <a:lstStyle/>
-          <a:p>
-            <a:pPr algn="l">
-              <a:lnSpc>
-                <a:spcPct val="100000"/>
-              </a:lnSpc>
-              <a:spcAft>
-                <a:spcPts val="0"/>
-              </a:spcAft>
-            </a:pPr>
-            <a:r>
-              <a:rPr lang="uk-UA" sz="3200" b="1">
-                <a:solidFill>
-                  <a:srgbClr val="F4B6C8"/>
-                </a:solidFill>
-                <a:latin typeface="Fira Sans Extra Condensed Bold"/>
-                <a:ea typeface="Fira Sans Extra Condensed Bold"/>
-                <a:cs typeface="Fira Sans Extra Condensed Bold"/>
-                <a:sym typeface="Fira Sans Extra Condensed Bold"/>
-              </a:rPr>
-              <a:t>Спори</a:t>
-            </a:r>
-          </a:p>
-        </p:txBody>
-      </p:sp>
-      <p:sp>
-        <p:nvSpPr>
-          <p:cNvPr name="TextBox 20" id="20"/>
-          <p:cNvSpPr txBox="true"/>
-          <p:nvPr/>
-        </p:nvSpPr>
-        <p:spPr>
-          <a:xfrm>
-            <a:off x="12342556" y="6750000"/>
-            <a:ext cx="4559303" cy="1600000"/>
-          </a:xfrm>
-          <a:prstGeom prst="rect">
-            <a:avLst/>
-          </a:prstGeom>
-        </p:spPr>
-        <p:txBody>
-          <a:bodyPr anchor="t" wrap="square" rtlCol="false" tIns="0" lIns="0" bIns="0" rIns="0">
-            <a:noAutofit/>
-          </a:bodyPr>
-          <a:lstStyle/>
-          <a:p>
-            <a:pPr algn="l">
-              <a:lnSpc>
-                <a:spcPct val="100000"/>
-              </a:lnSpc>
-              <a:spcAft>
-                <a:spcPts val="0"/>
-              </a:spcAft>
-            </a:pPr>
-            <a:r>
-              <a:rPr lang="uk-UA" sz="2600" b="0">
-                <a:solidFill>
-                  <a:srgbClr val="FBFBF8"/>
-                </a:solidFill>
-                <a:latin typeface="Fira Sans Extra Condensed"/>
-                <a:ea typeface="Fira Sans Extra Condensed"/>
-                <a:cs typeface="Fira Sans Extra Condensed"/>
-                <a:sym typeface="Fira Sans Extra Condensed"/>
-              </a:rPr>
-              <a:t>Право, юрисдикція, порядок вирішення</a:t>
-            </a:r>
-          </a:p>
-        </p:txBody>
-      </p:sp>
-      <p:sp>
-        <p:nvSpPr>
-          <p:cNvPr name="Note 21" id="21"/>
-          <p:cNvSpPr/>
-          <p:nvPr/>
-        </p:nvSpPr>
-        <p:spPr>
-          <a:xfrm>
-            <a:off x="1219200" y="8750000"/>
-            <a:ext cx="15849600" cy="1000000"/>
-          </a:xfrm>
-          <a:prstGeom prst="roundRect">
-            <a:avLst>
-              <a:gd name="adj" fmla="val 7000"/>
-            </a:avLst>
-          </a:prstGeom>
-          <a:solidFill>
-            <a:srgbClr val="F4B6C8"/>
-          </a:solidFill>
-        </p:spPr>
-      </p:sp>
-      <p:sp>
-        <p:nvSpPr>
-          <p:cNvPr name="TextBox 22" id="22"/>
-          <p:cNvSpPr txBox="true"/>
-          <p:nvPr/>
-        </p:nvSpPr>
-        <p:spPr>
-          <a:xfrm>
-            <a:off x="1500000" y="8750000"/>
-            <a:ext cx="15286000" cy="1000000"/>
-          </a:xfrm>
-          <a:prstGeom prst="rect">
-            <a:avLst/>
-          </a:prstGeom>
-        </p:spPr>
-        <p:txBody>
-          <a:bodyPr anchor="ctr" wrap="square" rtlCol="false" tIns="0" lIns="0" bIns="0" rIns="0">
-            <a:noAutofit/>
-          </a:bodyPr>
-          <a:lstStyle/>
-          <a:p>
             <a:pPr algn="ctr">
               <a:lnSpc>
                 <a:spcPct val="100000"/>
@@ -26046,16 +24604,28 @@
               </a:spcAft>
             </a:pPr>
             <a:r>
-              <a:rPr lang="uk-UA" sz="2600" b="1">
-                <a:solidFill>
-                  <a:srgbClr val="0E4D38"/>
+              <a:rPr lang="uk-UA" sz="5400" b="1">
+                <a:solidFill>
+                  <a:srgbClr val="F4B6C8"/>
                 </a:solidFill>
                 <a:latin typeface="Fira Sans Extra Condensed Bold"/>
                 <a:ea typeface="Fira Sans Extra Condensed Bold"/>
                 <a:cs typeface="Fira Sans Extra Condensed Bold"/>
                 <a:sym typeface="Fira Sans Extra Condensed Bold"/>
               </a:rPr>
-              <a:t>Наступний крок: узгодити позиції трьох сторін по кожному пункту</a:t>
+              <a:t>8  </a:t>
+            </a:r>
+            <a:r>
+              <a:rPr lang="uk-UA" sz="5400" b="1">
+                <a:solidFill>
+                  <a:srgbClr val="FBFBF8"/>
+                </a:solidFill>
+                <a:latin typeface="Fira Sans Extra Condensed Bold"/>
+                <a:ea typeface="Fira Sans Extra Condensed Bold"/>
+                <a:cs typeface="Fira Sans Extra Condensed Bold"/>
+                <a:sym typeface="Fira Sans Extra Condensed Bold"/>
+              </a:rPr>
+              <a:t>Відповідальність</a:t>
             </a:r>
           </a:p>
         </p:txBody>

</xml_diff>

<commit_message>
Simplify contract slide to scheme only
Co-Authored-By: Claude Sonnet 5.5 <noreply@anthropic.com>
Claude-Session: https://claude.ai/code/session_01SVoKafBmW5nnvB217TvhV6
</commit_message>
<xml_diff>
--- a/presentation_with_contract.pptx
+++ b/presentation_with_contract.pptx
@@ -20495,8 +20495,8 @@
         </p:nvSpPr>
         <p:spPr>
           <a:xfrm>
-            <a:off x="1219200" y="2500000"/>
-            <a:ext cx="3800000" cy="5900000"/>
+            <a:off x="1219200" y="3300000"/>
+            <a:ext cx="3800000" cy="2600000"/>
           </a:xfrm>
           <a:prstGeom prst="roundRect">
             <a:avLst>
@@ -20516,20 +20516,20 @@
         </p:nvSpPr>
         <p:spPr>
           <a:xfrm>
-            <a:off x="1504950" y="2800000"/>
-            <a:ext cx="3228500" cy="1100000"/>
+            <a:off x="1504950" y="3300000"/>
+            <a:ext cx="3228500" cy="2600000"/>
           </a:xfrm>
           <a:prstGeom prst="rect">
             <a:avLst/>
           </a:prstGeom>
         </p:spPr>
         <p:txBody>
-          <a:bodyPr anchor="t" wrap="square" rtlCol="false" tIns="0" lIns="0" bIns="0" rIns="0">
+          <a:bodyPr anchor="ctr" wrap="square" rtlCol="false" tIns="0" lIns="0" bIns="0" rIns="0">
             <a:noAutofit/>
           </a:bodyPr>
           <a:lstStyle/>
           <a:p>
-            <a:pPr algn="l">
+            <a:pPr algn="ctr">
               <a:lnSpc>
                 <a:spcPct val="100000"/>
               </a:lnSpc>
@@ -20538,7 +20538,7 @@
               </a:spcAft>
             </a:pPr>
             <a:r>
-              <a:rPr lang="uk-UA" sz="3200" b="1">
+              <a:rPr lang="uk-UA" sz="3400" b="1">
                 <a:solidFill>
                   <a:srgbClr val="FBFBF8"/>
                 </a:solidFill>
@@ -20554,48 +20554,47 @@
       </p:sp>
       <p:sp>
         <p:nvSpPr>
-          <p:cNvPr name="TextBox 5" id="5"/>
-          <p:cNvSpPr txBox="true"/>
+          <p:cNvPr name="Card 5" id="5"/>
+          <p:cNvSpPr/>
           <p:nvPr/>
         </p:nvSpPr>
         <p:spPr>
           <a:xfrm>
-            <a:off x="1504950" y="4000000"/>
-            <a:ext cx="3228500" cy="1800000"/>
+            <a:off x="7244000" y="3300000"/>
+            <a:ext cx="3800000" cy="2600000"/>
+          </a:xfrm>
+          <a:prstGeom prst="roundRect">
+            <a:avLst>
+              <a:gd name="adj" fmla="val 7000"/>
+            </a:avLst>
+          </a:prstGeom>
+          <a:solidFill>
+            <a:srgbClr val="135F45"/>
+          </a:solidFill>
+        </p:spPr>
+      </p:sp>
+      <p:sp>
+        <p:nvSpPr>
+          <p:cNvPr name="TextBox 6" id="6"/>
+          <p:cNvSpPr txBox="true"/>
+          <p:nvPr/>
+        </p:nvSpPr>
+        <p:spPr>
+          <a:xfrm>
+            <a:off x="7529750" y="3300000"/>
+            <a:ext cx="3228500" cy="2600000"/>
           </a:xfrm>
           <a:prstGeom prst="rect">
             <a:avLst/>
           </a:prstGeom>
         </p:spPr>
         <p:txBody>
-          <a:bodyPr anchor="t" wrap="square" rtlCol="false" tIns="0" lIns="0" bIns="0" rIns="0">
+          <a:bodyPr anchor="ctr" wrap="square" rtlCol="false" tIns="0" lIns="0" bIns="0" rIns="0">
             <a:noAutofit/>
           </a:bodyPr>
           <a:lstStyle/>
           <a:p>
-            <a:pPr algn="l">
-              <a:lnSpc>
-                <a:spcPct val="100000"/>
-              </a:lnSpc>
-              <a:spcAft>
-                <a:spcPts val="600"/>
-              </a:spcAft>
-            </a:pPr>
-            <a:r>
-              <a:rPr lang="uk-UA" sz="2200" b="1">
-                <a:solidFill>
-                  <a:srgbClr val="F4B6C8"/>
-                </a:solidFill>
-                <a:latin typeface="Fira Sans Extra Condensed Bold"/>
-                <a:ea typeface="Fira Sans Extra Condensed Bold"/>
-                <a:cs typeface="Fira Sans Extra Condensed Bold"/>
-                <a:sym typeface="Fira Sans Extra Condensed Bold"/>
-              </a:rPr>
-              <a:t>Роль</a:t>
-            </a:r>
-          </a:p>
-          <a:p>
-            <a:pPr algn="l">
+            <a:pPr algn="ctr">
               <a:lnSpc>
                 <a:spcPct val="100000"/>
               </a:lnSpc>
@@ -20604,82 +20603,16 @@
               </a:spcAft>
             </a:pPr>
             <a:r>
-              <a:rPr lang="uk-UA" sz="2400" b="0">
+              <a:rPr lang="uk-UA" sz="3400" b="1">
                 <a:solidFill>
                   <a:srgbClr val="FBFBF8"/>
-                </a:solidFill>
-                <a:latin typeface="Fira Sans Extra Condensed"/>
-                <a:ea typeface="Fira Sans Extra Condensed"/>
-                <a:cs typeface="Fira Sans Extra Condensed"/>
-                <a:sym typeface="Fira Sans Extra Condensed"/>
-              </a:rPr>
-              <a:t>Фінансує відкриття пекарні</a:t>
-            </a:r>
-          </a:p>
-        </p:txBody>
-      </p:sp>
-      <p:sp>
-        <p:nvSpPr>
-          <p:cNvPr name="TextBox 6" id="6"/>
-          <p:cNvSpPr txBox="true"/>
-          <p:nvPr/>
-        </p:nvSpPr>
-        <p:spPr>
-          <a:xfrm>
-            <a:off x="1504950" y="6000000"/>
-            <a:ext cx="3228500" cy="2200000"/>
-          </a:xfrm>
-          <a:prstGeom prst="rect">
-            <a:avLst/>
-          </a:prstGeom>
-        </p:spPr>
-        <p:txBody>
-          <a:bodyPr anchor="t" wrap="square" rtlCol="false" tIns="0" lIns="0" bIns="0" rIns="0">
-            <a:noAutofit/>
-          </a:bodyPr>
-          <a:lstStyle/>
-          <a:p>
-            <a:pPr algn="l">
-              <a:lnSpc>
-                <a:spcPct val="100000"/>
-              </a:lnSpc>
-              <a:spcAft>
-                <a:spcPts val="600"/>
-              </a:spcAft>
-            </a:pPr>
-            <a:r>
-              <a:rPr lang="uk-UA" sz="2200" b="1">
-                <a:solidFill>
-                  <a:srgbClr val="F4B6C8"/>
                 </a:solidFill>
                 <a:latin typeface="Fira Sans Extra Condensed Bold"/>
                 <a:ea typeface="Fira Sans Extra Condensed Bold"/>
                 <a:cs typeface="Fira Sans Extra Condensed Bold"/>
                 <a:sym typeface="Fira Sans Extra Condensed Bold"/>
               </a:rPr>
-              <a:t>Підпорядкування</a:t>
-            </a:r>
-          </a:p>
-          <a:p>
-            <a:pPr algn="l">
-              <a:lnSpc>
-                <a:spcPct val="100000"/>
-              </a:lnSpc>
-              <a:spcAft>
-                <a:spcPts val="0"/>
-              </a:spcAft>
-            </a:pPr>
-            <a:r>
-              <a:rPr lang="uk-UA" sz="2400" b="0">
-                <a:solidFill>
-                  <a:srgbClr val="FBFBF8"/>
-                </a:solidFill>
-                <a:latin typeface="Fira Sans Extra Condensed"/>
-                <a:ea typeface="Fira Sans Extra Condensed"/>
-                <a:cs typeface="Fira Sans Extra Condensed"/>
-                <a:sym typeface="Fira Sans Extra Condensed"/>
-              </a:rPr>
-              <a:t>Звертається лише до Lviv Croissants</a:t>
+              <a:t>Lviv Croissants</a:t>
             </a:r>
           </a:p>
         </p:txBody>
@@ -20692,8 +20625,8 @@
         </p:nvSpPr>
         <p:spPr>
           <a:xfrm>
-            <a:off x="7244000" y="2500000"/>
-            <a:ext cx="3800000" cy="5900000"/>
+            <a:off x="13268800" y="3300000"/>
+            <a:ext cx="3800000" cy="2600000"/>
           </a:xfrm>
           <a:prstGeom prst="roundRect">
             <a:avLst>
@@ -20713,20 +20646,20 @@
         </p:nvSpPr>
         <p:spPr>
           <a:xfrm>
-            <a:off x="7529750" y="2800000"/>
-            <a:ext cx="3228500" cy="1100000"/>
+            <a:off x="13554550" y="3300000"/>
+            <a:ext cx="3228500" cy="2600000"/>
           </a:xfrm>
           <a:prstGeom prst="rect">
             <a:avLst/>
           </a:prstGeom>
         </p:spPr>
         <p:txBody>
-          <a:bodyPr anchor="t" wrap="square" rtlCol="false" tIns="0" lIns="0" bIns="0" rIns="0">
+          <a:bodyPr anchor="ctr" wrap="square" rtlCol="false" tIns="0" lIns="0" bIns="0" rIns="0">
             <a:noAutofit/>
           </a:bodyPr>
           <a:lstStyle/>
           <a:p>
-            <a:pPr algn="l">
+            <a:pPr algn="ctr">
               <a:lnSpc>
                 <a:spcPct val="100000"/>
               </a:lnSpc>
@@ -20735,204 +20668,7 @@
               </a:spcAft>
             </a:pPr>
             <a:r>
-              <a:rPr lang="uk-UA" sz="3200" b="1">
-                <a:solidFill>
-                  <a:srgbClr val="FBFBF8"/>
-                </a:solidFill>
-                <a:latin typeface="Fira Sans Extra Condensed Bold"/>
-                <a:ea typeface="Fira Sans Extra Condensed Bold"/>
-                <a:cs typeface="Fira Sans Extra Condensed Bold"/>
-                <a:sym typeface="Fira Sans Extra Condensed Bold"/>
-              </a:rPr>
-              <a:t>Lviv Croissants</a:t>
-            </a:r>
-          </a:p>
-        </p:txBody>
-      </p:sp>
-      <p:sp>
-        <p:nvSpPr>
-          <p:cNvPr name="TextBox 9" id="9"/>
-          <p:cNvSpPr txBox="true"/>
-          <p:nvPr/>
-        </p:nvSpPr>
-        <p:spPr>
-          <a:xfrm>
-            <a:off x="7529750" y="4000000"/>
-            <a:ext cx="3228500" cy="1800000"/>
-          </a:xfrm>
-          <a:prstGeom prst="rect">
-            <a:avLst/>
-          </a:prstGeom>
-        </p:spPr>
-        <p:txBody>
-          <a:bodyPr anchor="t" wrap="square" rtlCol="false" tIns="0" lIns="0" bIns="0" rIns="0">
-            <a:noAutofit/>
-          </a:bodyPr>
-          <a:lstStyle/>
-          <a:p>
-            <a:pPr algn="l">
-              <a:lnSpc>
-                <a:spcPct val="100000"/>
-              </a:lnSpc>
-              <a:spcAft>
-                <a:spcPts val="600"/>
-              </a:spcAft>
-            </a:pPr>
-            <a:r>
-              <a:rPr lang="uk-UA" sz="2200" b="1">
-                <a:solidFill>
-                  <a:srgbClr val="F4B6C8"/>
-                </a:solidFill>
-                <a:latin typeface="Fira Sans Extra Condensed Bold"/>
-                <a:ea typeface="Fira Sans Extra Condensed Bold"/>
-                <a:cs typeface="Fira Sans Extra Condensed Bold"/>
-                <a:sym typeface="Fira Sans Extra Condensed Bold"/>
-              </a:rPr>
-              <a:t>Роль</a:t>
-            </a:r>
-          </a:p>
-          <a:p>
-            <a:pPr algn="l">
-              <a:lnSpc>
-                <a:spcPct val="100000"/>
-              </a:lnSpc>
-              <a:spcAft>
-                <a:spcPts val="0"/>
-              </a:spcAft>
-            </a:pPr>
-            <a:r>
-              <a:rPr lang="uk-UA" sz="2400" b="0">
-                <a:solidFill>
-                  <a:srgbClr val="FBFBF8"/>
-                </a:solidFill>
-                <a:latin typeface="Fira Sans Extra Condensed"/>
-                <a:ea typeface="Fira Sans Extra Condensed"/>
-                <a:cs typeface="Fira Sans Extra Condensed"/>
-                <a:sym typeface="Fira Sans Extra Condensed"/>
-              </a:rPr>
-              <a:t>Франчайзер: бренд, стандарти, навчання, системи</a:t>
-            </a:r>
-          </a:p>
-        </p:txBody>
-      </p:sp>
-      <p:sp>
-        <p:nvSpPr>
-          <p:cNvPr name="TextBox 10" id="10"/>
-          <p:cNvSpPr txBox="true"/>
-          <p:nvPr/>
-        </p:nvSpPr>
-        <p:spPr>
-          <a:xfrm>
-            <a:off x="7529750" y="6000000"/>
-            <a:ext cx="3228500" cy="2200000"/>
-          </a:xfrm>
-          <a:prstGeom prst="rect">
-            <a:avLst/>
-          </a:prstGeom>
-        </p:spPr>
-        <p:txBody>
-          <a:bodyPr anchor="t" wrap="square" rtlCol="false" tIns="0" lIns="0" bIns="0" rIns="0">
-            <a:noAutofit/>
-          </a:bodyPr>
-          <a:lstStyle/>
-          <a:p>
-            <a:pPr algn="l">
-              <a:lnSpc>
-                <a:spcPct val="100000"/>
-              </a:lnSpc>
-              <a:spcAft>
-                <a:spcPts val="600"/>
-              </a:spcAft>
-            </a:pPr>
-            <a:r>
-              <a:rPr lang="uk-UA" sz="2200" b="1">
-                <a:solidFill>
-                  <a:srgbClr val="F4B6C8"/>
-                </a:solidFill>
-                <a:latin typeface="Fira Sans Extra Condensed Bold"/>
-                <a:ea typeface="Fira Sans Extra Condensed Bold"/>
-                <a:cs typeface="Fira Sans Extra Condensed Bold"/>
-                <a:sym typeface="Fira Sans Extra Condensed Bold"/>
-              </a:rPr>
-              <a:t>Підпорядкування</a:t>
-            </a:r>
-          </a:p>
-          <a:p>
-            <a:pPr algn="l">
-              <a:lnSpc>
-                <a:spcPct val="100000"/>
-              </a:lnSpc>
-              <a:spcAft>
-                <a:spcPts val="0"/>
-              </a:spcAft>
-            </a:pPr>
-            <a:r>
-              <a:rPr lang="uk-UA" sz="2400" b="0">
-                <a:solidFill>
-                  <a:srgbClr val="FBFBF8"/>
-                </a:solidFill>
-                <a:latin typeface="Fira Sans Extra Condensed"/>
-                <a:ea typeface="Fira Sans Extra Condensed"/>
-                <a:cs typeface="Fira Sans Extra Condensed"/>
-                <a:sym typeface="Fira Sans Extra Condensed"/>
-              </a:rPr>
-              <a:t>Центральна ланка між інвестором і оператором</a:t>
-            </a:r>
-          </a:p>
-        </p:txBody>
-      </p:sp>
-      <p:sp>
-        <p:nvSpPr>
-          <p:cNvPr name="Card 11" id="11"/>
-          <p:cNvSpPr/>
-          <p:nvPr/>
-        </p:nvSpPr>
-        <p:spPr>
-          <a:xfrm>
-            <a:off x="13268800" y="2500000"/>
-            <a:ext cx="3800000" cy="5900000"/>
-          </a:xfrm>
-          <a:prstGeom prst="roundRect">
-            <a:avLst>
-              <a:gd name="adj" fmla="val 7000"/>
-            </a:avLst>
-          </a:prstGeom>
-          <a:solidFill>
-            <a:srgbClr val="135F45"/>
-          </a:solidFill>
-        </p:spPr>
-      </p:sp>
-      <p:sp>
-        <p:nvSpPr>
-          <p:cNvPr name="TextBox 12" id="12"/>
-          <p:cNvSpPr txBox="true"/>
-          <p:nvPr/>
-        </p:nvSpPr>
-        <p:spPr>
-          <a:xfrm>
-            <a:off x="13554550" y="2800000"/>
-            <a:ext cx="3228500" cy="1100000"/>
-          </a:xfrm>
-          <a:prstGeom prst="rect">
-            <a:avLst/>
-          </a:prstGeom>
-        </p:spPr>
-        <p:txBody>
-          <a:bodyPr anchor="t" wrap="square" rtlCol="false" tIns="0" lIns="0" bIns="0" rIns="0">
-            <a:noAutofit/>
-          </a:bodyPr>
-          <a:lstStyle/>
-          <a:p>
-            <a:pPr algn="l">
-              <a:lnSpc>
-                <a:spcPct val="100000"/>
-              </a:lnSpc>
-              <a:spcAft>
-                <a:spcPts val="0"/>
-              </a:spcAft>
-            </a:pPr>
-            <a:r>
-              <a:rPr lang="uk-UA" sz="3200" b="1">
+              <a:rPr lang="uk-UA" sz="3400" b="1">
                 <a:solidFill>
                   <a:srgbClr val="FBFBF8"/>
                 </a:solidFill>
@@ -20946,147 +20682,15 @@
           </a:p>
         </p:txBody>
       </p:sp>
-      <p:sp>
-        <p:nvSpPr>
-          <p:cNvPr name="TextBox 13" id="13"/>
-          <p:cNvSpPr txBox="true"/>
-          <p:nvPr/>
-        </p:nvSpPr>
-        <p:spPr>
-          <a:xfrm>
-            <a:off x="13554550" y="4000000"/>
-            <a:ext cx="3228500" cy="1800000"/>
-          </a:xfrm>
-          <a:prstGeom prst="rect">
-            <a:avLst/>
-          </a:prstGeom>
-        </p:spPr>
-        <p:txBody>
-          <a:bodyPr anchor="t" wrap="square" rtlCol="false" tIns="0" lIns="0" bIns="0" rIns="0">
-            <a:noAutofit/>
-          </a:bodyPr>
-          <a:lstStyle/>
-          <a:p>
-            <a:pPr algn="l">
-              <a:lnSpc>
-                <a:spcPct val="100000"/>
-              </a:lnSpc>
-              <a:spcAft>
-                <a:spcPts val="600"/>
-              </a:spcAft>
-            </a:pPr>
-            <a:r>
-              <a:rPr lang="uk-UA" sz="2200" b="1">
-                <a:solidFill>
-                  <a:srgbClr val="F4B6C8"/>
-                </a:solidFill>
-                <a:latin typeface="Fira Sans Extra Condensed Bold"/>
-                <a:ea typeface="Fira Sans Extra Condensed Bold"/>
-                <a:cs typeface="Fira Sans Extra Condensed Bold"/>
-                <a:sym typeface="Fira Sans Extra Condensed Bold"/>
-              </a:rPr>
-              <a:t>Роль</a:t>
-            </a:r>
-          </a:p>
-          <a:p>
-            <a:pPr algn="l">
-              <a:lnSpc>
-                <a:spcPct val="100000"/>
-              </a:lnSpc>
-              <a:spcAft>
-                <a:spcPts val="0"/>
-              </a:spcAft>
-            </a:pPr>
-            <a:r>
-              <a:rPr lang="uk-UA" sz="2400" b="0">
-                <a:solidFill>
-                  <a:srgbClr val="FBFBF8"/>
-                </a:solidFill>
-                <a:latin typeface="Fira Sans Extra Condensed"/>
-                <a:ea typeface="Fira Sans Extra Condensed"/>
-                <a:cs typeface="Fira Sans Extra Condensed"/>
-                <a:sym typeface="Fira Sans Extra Condensed"/>
-              </a:rPr>
-              <a:t>Щодня керує пекарнею і командою</a:t>
-            </a:r>
-          </a:p>
-        </p:txBody>
-      </p:sp>
-      <p:sp>
-        <p:nvSpPr>
-          <p:cNvPr name="TextBox 14" id="14"/>
-          <p:cNvSpPr txBox="true"/>
-          <p:nvPr/>
-        </p:nvSpPr>
-        <p:spPr>
-          <a:xfrm>
-            <a:off x="13554550" y="6000000"/>
-            <a:ext cx="3228500" cy="2200000"/>
-          </a:xfrm>
-          <a:prstGeom prst="rect">
-            <a:avLst/>
-          </a:prstGeom>
-        </p:spPr>
-        <p:txBody>
-          <a:bodyPr anchor="t" wrap="square" rtlCol="false" tIns="0" lIns="0" bIns="0" rIns="0">
-            <a:noAutofit/>
-          </a:bodyPr>
-          <a:lstStyle/>
-          <a:p>
-            <a:pPr algn="l">
-              <a:lnSpc>
-                <a:spcPct val="100000"/>
-              </a:lnSpc>
-              <a:spcAft>
-                <a:spcPts val="600"/>
-              </a:spcAft>
-            </a:pPr>
-            <a:r>
-              <a:rPr lang="uk-UA" sz="2200" b="1">
-                <a:solidFill>
-                  <a:srgbClr val="F4B6C8"/>
-                </a:solidFill>
-                <a:latin typeface="Fira Sans Extra Condensed Bold"/>
-                <a:ea typeface="Fira Sans Extra Condensed Bold"/>
-                <a:cs typeface="Fira Sans Extra Condensed Bold"/>
-                <a:sym typeface="Fira Sans Extra Condensed Bold"/>
-              </a:rPr>
-              <a:t>Підпорядкування</a:t>
-            </a:r>
-          </a:p>
-          <a:p>
-            <a:pPr algn="l">
-              <a:lnSpc>
-                <a:spcPct val="100000"/>
-              </a:lnSpc>
-              <a:spcAft>
-                <a:spcPts val="0"/>
-              </a:spcAft>
-            </a:pPr>
-            <a:r>
-              <a:rPr lang="uk-UA" sz="2400" b="0">
-                <a:solidFill>
-                  <a:srgbClr val="FBFBF8"/>
-                </a:solidFill>
-                <a:latin typeface="Fira Sans Extra Condensed"/>
-                <a:ea typeface="Fira Sans Extra Condensed"/>
-                <a:cs typeface="Fira Sans Extra Condensed"/>
-                <a:sym typeface="Fira Sans Extra Condensed"/>
-              </a:rPr>
-              <a:t>Підпорядковується Lviv Croissants</a:t>
-            </a:r>
-          </a:p>
-        </p:txBody>
-      </p:sp>
       <p:cxnSp>
         <p:nvCxnSpPr>
-          <p:cNvPr name="Arrow 15" id="15"/>
+          <p:cNvPr name="Arrow 9" id="9"/>
           <p:cNvCxnSpPr/>
           <p:nvPr/>
         </p:nvCxnSpPr>
         <p:spPr>
           <a:xfrm>
-            <a:off x="5169200" y="5000000"/>
+            <a:off x="5169200" y="4600000"/>
             <a:ext cx="1924800" cy="0"/>
           </a:xfrm>
           <a:prstGeom prst="line">
@@ -21103,13 +20707,13 @@
       </p:cxnSp>
       <p:sp>
         <p:nvSpPr>
-          <p:cNvPr name="TextBox 16" id="16"/>
+          <p:cNvPr name="TextBox 10" id="10"/>
           <p:cNvSpPr txBox="true"/>
           <p:nvPr/>
         </p:nvSpPr>
         <p:spPr>
           <a:xfrm>
-            <a:off x="5169200" y="4300000"/>
+            <a:off x="5169200" y="3900000"/>
             <a:ext cx="1924800" cy="500000"/>
           </a:xfrm>
           <a:prstGeom prst="rect">
@@ -21147,13 +20751,13 @@
       </p:sp>
       <p:cxnSp>
         <p:nvCxnSpPr>
-          <p:cNvPr name="Arrow 17" id="17"/>
+          <p:cNvPr name="Arrow 11" id="11"/>
           <p:cNvCxnSpPr/>
           <p:nvPr/>
         </p:nvCxnSpPr>
         <p:spPr>
           <a:xfrm>
-            <a:off x="11194000" y="5000000"/>
+            <a:off x="11194000" y="4600000"/>
             <a:ext cx="1924800" cy="0"/>
           </a:xfrm>
           <a:prstGeom prst="line">
@@ -21170,13 +20774,13 @@
       </p:cxnSp>
       <p:sp>
         <p:nvSpPr>
-          <p:cNvPr name="TextBox 18" id="18"/>
+          <p:cNvPr name="TextBox 12" id="12"/>
           <p:cNvSpPr txBox="true"/>
           <p:nvPr/>
         </p:nvSpPr>
         <p:spPr>
           <a:xfrm>
-            <a:off x="11194000" y="4300000"/>
+            <a:off x="11194000" y="3900000"/>
             <a:ext cx="1924800" cy="500000"/>
           </a:xfrm>
           <a:prstGeom prst="rect">
@@ -21214,7 +20818,7 @@
       </p:sp>
       <p:sp>
         <p:nvSpPr>
-          <p:cNvPr name="Note 19" id="19"/>
+          <p:cNvPr name="Note 13" id="13"/>
           <p:cNvSpPr/>
           <p:nvPr/>
         </p:nvSpPr>
@@ -21235,7 +20839,7 @@
       </p:sp>
       <p:sp>
         <p:nvSpPr>
-          <p:cNvPr name="TextBox 20" id="20"/>
+          <p:cNvPr name="TextBox 14" id="14"/>
           <p:cNvSpPr txBox="true"/>
           <p:nvPr/>
         </p:nvSpPr>

</xml_diff>

<commit_message>
Rebuild responsibility zones slide
Co-Authored-By: Claude Sonnet 5.5 <noreply@anthropic.com>
Claude-Session: https://claude.ai/code/session_01SVoKafBmW5nnvB217TvhV6
</commit_message>
<xml_diff>
--- a/presentation_with_contract.pptx
+++ b/presentation_with_contract.pptx
@@ -19717,27 +19717,30 @@
           <p:nvPr/>
         </p:nvSpPr>
         <p:spPr>
-          <a:xfrm rot="0">
-            <a:off x="6120937" y="665797"/>
-            <a:ext cx="6046126" cy="773430"/>
+          <a:xfrm>
+            <a:off x="981456" y="1000000"/>
+            <a:ext cx="16325088" cy="900000"/>
           </a:xfrm>
           <a:prstGeom prst="rect">
             <a:avLst/>
           </a:prstGeom>
         </p:spPr>
         <p:txBody>
-          <a:bodyPr anchor="t" rtlCol="false" tIns="0" lIns="0" bIns="0" rIns="0">
-            <a:spAutoFit/>
+          <a:bodyPr anchor="t" wrap="square" rtlCol="false" tIns="0" lIns="0" bIns="0" rIns="0">
+            <a:noAutofit/>
           </a:bodyPr>
           <a:lstStyle/>
           <a:p>
             <a:pPr algn="ctr">
               <a:lnSpc>
-                <a:spcPts val="5940"/>
+                <a:spcPct val="100000"/>
               </a:lnSpc>
+              <a:spcAft>
+                <a:spcPts val="0"/>
+              </a:spcAft>
             </a:pPr>
             <a:r>
-              <a:rPr lang="en-US" sz="5400" b="true">
+              <a:rPr lang="uk-UA" sz="5400" b="1">
                 <a:solidFill>
                   <a:srgbClr val="FBFBF8"/>
                 </a:solidFill>
@@ -19746,7 +19749,19 @@
                 <a:cs typeface="Fira Sans Extra Condensed Bold"/>
                 <a:sym typeface="Fira Sans Extra Condensed Bold"/>
               </a:rPr>
-              <a:t>Зони відповідальності</a:t>
+              <a:t>Зони </a:t>
+            </a:r>
+            <a:r>
+              <a:rPr lang="uk-UA" sz="5400" b="1">
+                <a:solidFill>
+                  <a:srgbClr val="F4B6C8"/>
+                </a:solidFill>
+                <a:latin typeface="Fira Sans Extra Condensed Bold"/>
+                <a:ea typeface="Fira Sans Extra Condensed Bold"/>
+                <a:cs typeface="Fira Sans Extra Condensed Bold"/>
+                <a:sym typeface="Fira Sans Extra Condensed Bold"/>
+              </a:rPr>
+              <a:t>відповідальності</a:t>
             </a:r>
           </a:p>
         </p:txBody>
@@ -19758,29 +19773,32 @@
           <p:nvPr/>
         </p:nvSpPr>
         <p:spPr>
-          <a:xfrm rot="0">
-            <a:off x="2847941" y="2071344"/>
-            <a:ext cx="3504578" cy="768688"/>
+          <a:xfrm>
+            <a:off x="3769200" y="1850000"/>
+            <a:ext cx="6524800" cy="500000"/>
           </a:xfrm>
           <a:prstGeom prst="rect">
             <a:avLst/>
           </a:prstGeom>
         </p:spPr>
         <p:txBody>
-          <a:bodyPr anchor="t" rtlCol="false" tIns="0" lIns="0" bIns="0" rIns="0">
-            <a:spAutoFit/>
+          <a:bodyPr anchor="t" wrap="square" rtlCol="false" tIns="0" lIns="0" bIns="0" rIns="0">
+            <a:noAutofit/>
           </a:bodyPr>
           <a:lstStyle/>
           <a:p>
-            <a:pPr algn="l">
+            <a:pPr algn="ctr">
               <a:lnSpc>
-                <a:spcPts val="5950"/>
+                <a:spcPct val="100000"/>
               </a:lnSpc>
+              <a:spcAft>
+                <a:spcPts val="0"/>
+              </a:spcAft>
             </a:pPr>
             <a:r>
-              <a:rPr lang="en-US" sz="5409" b="true">
-                <a:solidFill>
-                  <a:srgbClr val="FBFBF8"/>
+              <a:rPr lang="uk-UA" sz="3000" b="1">
+                <a:solidFill>
+                  <a:srgbClr val="F4B6C8"/>
                 </a:solidFill>
                 <a:latin typeface="Fira Sans Extra Condensed Bold"/>
                 <a:ea typeface="Fira Sans Extra Condensed Bold"/>
@@ -19799,29 +19817,32 @@
           <p:nvPr/>
         </p:nvSpPr>
         <p:spPr>
-          <a:xfrm rot="0">
-            <a:off x="11030792" y="2071344"/>
-            <a:ext cx="4253314" cy="768688"/>
+          <a:xfrm>
+            <a:off x="10544000" y="1850000"/>
+            <a:ext cx="6524800" cy="500000"/>
           </a:xfrm>
           <a:prstGeom prst="rect">
             <a:avLst/>
           </a:prstGeom>
         </p:spPr>
         <p:txBody>
-          <a:bodyPr anchor="t" rtlCol="false" tIns="0" lIns="0" bIns="0" rIns="0">
-            <a:spAutoFit/>
+          <a:bodyPr anchor="t" wrap="square" rtlCol="false" tIns="0" lIns="0" bIns="0" rIns="0">
+            <a:noAutofit/>
           </a:bodyPr>
           <a:lstStyle/>
           <a:p>
-            <a:pPr algn="l">
+            <a:pPr algn="ctr">
               <a:lnSpc>
-                <a:spcPts val="5950"/>
+                <a:spcPct val="100000"/>
               </a:lnSpc>
+              <a:spcAft>
+                <a:spcPts val="0"/>
+              </a:spcAft>
             </a:pPr>
             <a:r>
-              <a:rPr lang="en-US" sz="5409" b="true">
-                <a:solidFill>
-                  <a:srgbClr val="FBFBF8"/>
+              <a:rPr lang="uk-UA" sz="3000" b="1">
+                <a:solidFill>
+                  <a:srgbClr val="F4B6C8"/>
                 </a:solidFill>
                 <a:latin typeface="Fira Sans Extra Condensed Bold"/>
                 <a:ea typeface="Fira Sans Extra Condensed Bold"/>
@@ -19833,191 +19854,65 @@
           </a:p>
         </p:txBody>
       </p:sp>
-      <p:grpSp>
-        <p:nvGrpSpPr>
-          <p:cNvPr name="Group 5" id="5"/>
-          <p:cNvGrpSpPr/>
-          <p:nvPr/>
-        </p:nvGrpSpPr>
-        <p:grpSpPr>
-          <a:xfrm rot="0">
-            <a:off x="9411875" y="3177825"/>
-            <a:ext cx="8261440" cy="6610484"/>
-            <a:chOff x="0" y="0"/>
-            <a:chExt cx="11015253" cy="8813979"/>
-          </a:xfrm>
-        </p:grpSpPr>
-        <p:sp>
-          <p:nvSpPr>
-            <p:cNvPr name="Freeform 6" id="6"/>
-            <p:cNvSpPr/>
-            <p:nvPr/>
-          </p:nvSpPr>
-          <p:spPr>
-            <a:xfrm flipH="false" flipV="false" rot="0">
-              <a:off x="0" y="0"/>
-              <a:ext cx="11015290" cy="8813979"/>
-            </a:xfrm>
-            <a:custGeom>
-              <a:avLst/>
-              <a:gdLst/>
-              <a:ahLst/>
-              <a:cxnLst/>
-              <a:rect r="r" b="b" t="t" l="l"/>
-              <a:pathLst>
-                <a:path h="8813979" w="11015290">
-                  <a:moveTo>
-                    <a:pt x="0" y="813598"/>
-                  </a:moveTo>
-                  <a:cubicBezTo>
-                    <a:pt x="0" y="364424"/>
-                    <a:pt x="219828" y="0"/>
-                    <a:pt x="490778" y="0"/>
-                  </a:cubicBezTo>
-                  <a:lnTo>
-                    <a:pt x="10524536" y="0"/>
-                  </a:lnTo>
-                  <a:cubicBezTo>
-                    <a:pt x="10795691" y="0"/>
-                    <a:pt x="11015290" y="364424"/>
-                    <a:pt x="11015290" y="813598"/>
-                  </a:cubicBezTo>
-                  <a:lnTo>
-                    <a:pt x="11015290" y="8000381"/>
-                  </a:lnTo>
-                  <a:cubicBezTo>
-                    <a:pt x="11015290" y="8449894"/>
-                    <a:pt x="10795486" y="8813979"/>
-                    <a:pt x="10524536" y="8813979"/>
-                  </a:cubicBezTo>
-                  <a:lnTo>
-                    <a:pt x="490778" y="8813979"/>
-                  </a:lnTo>
-                  <a:cubicBezTo>
-                    <a:pt x="219623" y="8813979"/>
-                    <a:pt x="0" y="8449555"/>
-                    <a:pt x="0" y="8000381"/>
-                  </a:cubicBezTo>
-                  <a:close/>
-                </a:path>
-              </a:pathLst>
-            </a:custGeom>
-            <a:solidFill>
-              <a:srgbClr val="135F45"/>
-            </a:solidFill>
-          </p:spPr>
-        </p:sp>
-      </p:grpSp>
-      <p:grpSp>
-        <p:nvGrpSpPr>
-          <p:cNvPr name="Group 7" id="7"/>
-          <p:cNvGrpSpPr/>
-          <p:nvPr/>
-        </p:nvGrpSpPr>
-        <p:grpSpPr>
-          <a:xfrm rot="0">
-            <a:off x="469510" y="3177825"/>
-            <a:ext cx="8261440" cy="6610484"/>
-            <a:chOff x="0" y="0"/>
-            <a:chExt cx="11015253" cy="8813979"/>
-          </a:xfrm>
-        </p:grpSpPr>
-        <p:sp>
-          <p:nvSpPr>
-            <p:cNvPr name="Freeform 8" id="8"/>
-            <p:cNvSpPr/>
-            <p:nvPr/>
-          </p:nvSpPr>
-          <p:spPr>
-            <a:xfrm flipH="false" flipV="false" rot="0">
-              <a:off x="0" y="0"/>
-              <a:ext cx="11015290" cy="8813979"/>
-            </a:xfrm>
-            <a:custGeom>
-              <a:avLst/>
-              <a:gdLst/>
-              <a:ahLst/>
-              <a:cxnLst/>
-              <a:rect r="r" b="b" t="t" l="l"/>
-              <a:pathLst>
-                <a:path h="8813979" w="11015290">
-                  <a:moveTo>
-                    <a:pt x="0" y="813598"/>
-                  </a:moveTo>
-                  <a:cubicBezTo>
-                    <a:pt x="0" y="364424"/>
-                    <a:pt x="219828" y="0"/>
-                    <a:pt x="490778" y="0"/>
-                  </a:cubicBezTo>
-                  <a:lnTo>
-                    <a:pt x="10524536" y="0"/>
-                  </a:lnTo>
-                  <a:cubicBezTo>
-                    <a:pt x="10795691" y="0"/>
-                    <a:pt x="11015290" y="364424"/>
-                    <a:pt x="11015290" y="813598"/>
-                  </a:cubicBezTo>
-                  <a:lnTo>
-                    <a:pt x="11015290" y="8000381"/>
-                  </a:lnTo>
-                  <a:cubicBezTo>
-                    <a:pt x="11015290" y="8449894"/>
-                    <a:pt x="10795486" y="8813979"/>
-                    <a:pt x="10524536" y="8813979"/>
-                  </a:cubicBezTo>
-                  <a:lnTo>
-                    <a:pt x="490778" y="8813979"/>
-                  </a:lnTo>
-                  <a:cubicBezTo>
-                    <a:pt x="219623" y="8813979"/>
-                    <a:pt x="0" y="8449555"/>
-                    <a:pt x="0" y="8000381"/>
-                  </a:cubicBezTo>
-                  <a:close/>
-                </a:path>
-              </a:pathLst>
-            </a:custGeom>
-            <a:solidFill>
-              <a:srgbClr val="135F45"/>
-            </a:solidFill>
-          </p:spPr>
-        </p:sp>
-      </p:grpSp>
-      <p:sp>
-        <p:nvSpPr>
-          <p:cNvPr name="TextBox 9" id="9"/>
+      <p:sp>
+        <p:nvSpPr>
+          <p:cNvPr name="Role 5" id="5"/>
+          <p:cNvSpPr/>
+          <p:nvPr/>
+        </p:nvSpPr>
+        <p:spPr>
+          <a:xfrm>
+            <a:off x="1219200" y="2450000"/>
+            <a:ext cx="2300000" cy="2150000"/>
+          </a:xfrm>
+          <a:prstGeom prst="roundRect">
+            <a:avLst>
+              <a:gd name="adj" fmla="val 7000"/>
+            </a:avLst>
+          </a:prstGeom>
+          <a:solidFill>
+            <a:srgbClr val="F4B6C8"/>
+          </a:solidFill>
+        </p:spPr>
+      </p:sp>
+      <p:sp>
+        <p:nvSpPr>
+          <p:cNvPr name="TextBox 6" id="6"/>
           <p:cNvSpPr txBox="true"/>
           <p:nvPr/>
         </p:nvSpPr>
         <p:spPr>
-          <a:xfrm rot="0">
-            <a:off x="3873729" y="3282795"/>
-            <a:ext cx="1453001" cy="476250"/>
+          <a:xfrm>
+            <a:off x="1369200" y="2450000"/>
+            <a:ext cx="2000000" cy="2150000"/>
           </a:xfrm>
           <a:prstGeom prst="rect">
             <a:avLst/>
           </a:prstGeom>
         </p:spPr>
         <p:txBody>
-          <a:bodyPr anchor="t" rtlCol="false" tIns="0" lIns="0" bIns="0" rIns="0">
-            <a:spAutoFit/>
+          <a:bodyPr anchor="ctr" wrap="square" rtlCol="false" tIns="0" lIns="0" bIns="0" rIns="0">
+            <a:noAutofit/>
           </a:bodyPr>
           <a:lstStyle/>
           <a:p>
-            <a:pPr algn="l">
+            <a:pPr algn="ctr">
               <a:lnSpc>
-                <a:spcPts val="3750"/>
+                <a:spcPct val="100000"/>
               </a:lnSpc>
+              <a:spcAft>
+                <a:spcPts val="0"/>
+              </a:spcAft>
             </a:pPr>
             <a:r>
-              <a:rPr lang="en-US" sz="3000">
-                <a:solidFill>
-                  <a:srgbClr val="F4B6C8"/>
-                </a:solidFill>
-                <a:latin typeface="Fira Sans Extra Condensed"/>
-                <a:ea typeface="Fira Sans Extra Condensed"/>
-                <a:cs typeface="Fira Sans Extra Condensed"/>
-                <a:sym typeface="Fira Sans Extra Condensed"/>
+              <a:rPr lang="uk-UA" sz="2600" b="1">
+                <a:solidFill>
+                  <a:srgbClr val="0E4D38"/>
+                </a:solidFill>
+                <a:latin typeface="Fira Sans Extra Condensed Bold"/>
+                <a:ea typeface="Fira Sans Extra Condensed Bold"/>
+                <a:cs typeface="Fira Sans Extra Condensed Bold"/>
+                <a:sym typeface="Fira Sans Extra Condensed Bold"/>
               </a:rPr>
               <a:t>Інвестор</a:t>
             </a:r>
@@ -20026,126 +19921,242 @@
       </p:sp>
       <p:sp>
         <p:nvSpPr>
-          <p:cNvPr name="TextBox 10" id="10"/>
+          <p:cNvPr name="Card 7" id="7"/>
+          <p:cNvSpPr/>
+          <p:nvPr/>
+        </p:nvSpPr>
+        <p:spPr>
+          <a:xfrm>
+            <a:off x="3769200" y="2450000"/>
+            <a:ext cx="6524800" cy="2150000"/>
+          </a:xfrm>
+          <a:prstGeom prst="roundRect">
+            <a:avLst>
+              <a:gd name="adj" fmla="val 7000"/>
+            </a:avLst>
+          </a:prstGeom>
+          <a:solidFill>
+            <a:srgbClr val="135F45"/>
+          </a:solidFill>
+        </p:spPr>
+      </p:sp>
+      <p:sp>
+        <p:nvSpPr>
+          <p:cNvPr name="TextBox 8" id="8"/>
           <p:cNvSpPr txBox="true"/>
           <p:nvPr/>
         </p:nvSpPr>
         <p:spPr>
-          <a:xfrm rot="0">
-            <a:off x="469510" y="3749520"/>
-            <a:ext cx="8261440" cy="1439761"/>
+          <a:xfrm>
+            <a:off x="4019200" y="2600000"/>
+            <a:ext cx="6024800" cy="1850000"/>
           </a:xfrm>
           <a:prstGeom prst="rect">
             <a:avLst/>
           </a:prstGeom>
         </p:spPr>
         <p:txBody>
-          <a:bodyPr anchor="t" rtlCol="false" tIns="0" lIns="0" bIns="0" rIns="0">
-            <a:spAutoFit/>
+          <a:bodyPr anchor="ctr" wrap="square" rtlCol="false" tIns="0" lIns="0" bIns="0" rIns="0">
+            <a:noAutofit/>
           </a:bodyPr>
           <a:lstStyle/>
           <a:p>
-            <a:pPr algn="l" marL="491192" indent="-245596" lvl="1">
+            <a:pPr algn="l">
               <a:lnSpc>
-                <a:spcPts val="2843"/>
+                <a:spcPct val="100000"/>
               </a:lnSpc>
-              <a:buAutoNum type="arabicPeriod" startAt="1"/>
+              <a:spcAft>
+                <a:spcPts val="600"/>
+              </a:spcAft>
             </a:pPr>
             <a:r>
-              <a:rPr lang="en-US" sz="2275">
-                <a:solidFill>
-                  <a:srgbClr val="F4B6C8"/>
+              <a:rPr lang="uk-UA" sz="2000" b="0">
+                <a:solidFill>
+                  <a:srgbClr val="FBFBF8"/>
                 </a:solidFill>
                 <a:latin typeface="Fira Sans Extra Condensed"/>
                 <a:ea typeface="Fira Sans Extra Condensed"/>
                 <a:cs typeface="Fira Sans Extra Condensed"/>
                 <a:sym typeface="Fira Sans Extra Condensed"/>
               </a:rPr>
-              <a:t>Профінансувати закріплені за роллю витрати.</a:t>
-            </a:r>
-          </a:p>
-          <a:p>
-            <a:pPr algn="l" marL="491192" indent="-245596" lvl="1">
+              <a:t>— Профінансувати закріплені за роллю витрати</a:t>
+            </a:r>
+          </a:p>
+          <a:p>
+            <a:pPr algn="l">
               <a:lnSpc>
-                <a:spcPts val="2843"/>
+                <a:spcPct val="100000"/>
               </a:lnSpc>
-              <a:buAutoNum type="arabicPeriod" startAt="1"/>
+              <a:spcAft>
+                <a:spcPts val="600"/>
+              </a:spcAft>
             </a:pPr>
             <a:r>
-              <a:rPr lang="en-US" sz="2275">
-                <a:solidFill>
-                  <a:srgbClr val="F4B6C8"/>
+              <a:rPr lang="uk-UA" sz="2000" b="0">
+                <a:solidFill>
+                  <a:srgbClr val="FBFBF8"/>
                 </a:solidFill>
                 <a:latin typeface="Fira Sans Extra Condensed"/>
                 <a:ea typeface="Fira Sans Extra Condensed"/>
                 <a:cs typeface="Fira Sans Extra Condensed"/>
                 <a:sym typeface="Fira Sans Extra Condensed"/>
               </a:rPr>
-              <a:t>Провести ремонтні роботи, оздоблення приміщення згідно з архітектурним планом.</a:t>
-            </a:r>
-          </a:p>
-          <a:p>
-            <a:pPr algn="l" marL="491192" indent="-245596" lvl="1">
+              <a:t>— Провести ремонт і оздоблення за архітектурним планом</a:t>
+            </a:r>
+          </a:p>
+          <a:p>
+            <a:pPr algn="l">
               <a:lnSpc>
-                <a:spcPts val="2843"/>
+                <a:spcPct val="100000"/>
               </a:lnSpc>
-              <a:buAutoNum type="arabicPeriod" startAt="1"/>
+              <a:spcAft>
+                <a:spcPts val="600"/>
+              </a:spcAft>
             </a:pPr>
             <a:r>
-              <a:rPr lang="en-US" sz="2275">
-                <a:solidFill>
-                  <a:srgbClr val="F4B6C8"/>
+              <a:rPr lang="uk-UA" sz="2000" b="0">
+                <a:solidFill>
+                  <a:srgbClr val="FBFBF8"/>
                 </a:solidFill>
                 <a:latin typeface="Fira Sans Extra Condensed"/>
                 <a:ea typeface="Fira Sans Extra Condensed"/>
                 <a:cs typeface="Fira Sans Extra Condensed"/>
                 <a:sym typeface="Fira Sans Extra Condensed"/>
               </a:rPr>
-              <a:t>Підписання договору оренди та оформлення ліцензій/дозволів</a:t>
+              <a:t>— Підписати договір оренди, оформити ліцензії та дозволи</a:t>
             </a:r>
           </a:p>
         </p:txBody>
       </p:sp>
       <p:sp>
         <p:nvSpPr>
-          <p:cNvPr name="TextBox 11" id="11"/>
+          <p:cNvPr name="Card 9" id="9"/>
+          <p:cNvSpPr/>
+          <p:nvPr/>
+        </p:nvSpPr>
+        <p:spPr>
+          <a:xfrm>
+            <a:off x="10544000" y="2450000"/>
+            <a:ext cx="6524800" cy="2150000"/>
+          </a:xfrm>
+          <a:prstGeom prst="roundRect">
+            <a:avLst>
+              <a:gd name="adj" fmla="val 7000"/>
+            </a:avLst>
+          </a:prstGeom>
+          <a:solidFill>
+            <a:srgbClr val="135F45"/>
+          </a:solidFill>
+        </p:spPr>
+      </p:sp>
+      <p:sp>
+        <p:nvSpPr>
+          <p:cNvPr name="TextBox 10" id="10"/>
           <p:cNvSpPr txBox="true"/>
           <p:nvPr/>
         </p:nvSpPr>
         <p:spPr>
-          <a:xfrm rot="0">
-            <a:off x="3801385" y="5242576"/>
-            <a:ext cx="1597691" cy="476250"/>
+          <a:xfrm>
+            <a:off x="10794000" y="2600000"/>
+            <a:ext cx="6024800" cy="1850000"/>
           </a:xfrm>
           <a:prstGeom prst="rect">
             <a:avLst/>
           </a:prstGeom>
         </p:spPr>
         <p:txBody>
-          <a:bodyPr anchor="t" rtlCol="false" tIns="0" lIns="0" bIns="0" rIns="0">
-            <a:spAutoFit/>
+          <a:bodyPr anchor="ctr" wrap="square" rtlCol="false" tIns="0" lIns="0" bIns="0" rIns="0">
+            <a:noAutofit/>
           </a:bodyPr>
           <a:lstStyle/>
           <a:p>
             <a:pPr algn="l">
               <a:lnSpc>
-                <a:spcPts val="3750"/>
+                <a:spcPct val="100000"/>
               </a:lnSpc>
+              <a:spcAft>
+                <a:spcPts val="600"/>
+              </a:spcAft>
             </a:pPr>
             <a:r>
-              <a:rPr lang="en-US" sz="3000">
-                <a:solidFill>
-                  <a:srgbClr val="F4B6C8"/>
+              <a:rPr lang="uk-UA" sz="2000" b="0">
+                <a:solidFill>
+                  <a:srgbClr val="FBFBF8"/>
                 </a:solidFill>
                 <a:latin typeface="Fira Sans Extra Condensed"/>
                 <a:ea typeface="Fira Sans Extra Condensed"/>
                 <a:cs typeface="Fira Sans Extra Condensed"/>
                 <a:sym typeface="Fira Sans Extra Condensed"/>
               </a:rPr>
-              <a:t>Оператор</a:t>
+              <a:t>— Отримувати частку прибутку за шкалою</a:t>
+            </a:r>
+          </a:p>
+          <a:p>
+            <a:pPr algn="l">
+              <a:lnSpc>
+                <a:spcPct val="100000"/>
+              </a:lnSpc>
+              <a:spcAft>
+                <a:spcPts val="600"/>
+              </a:spcAft>
+            </a:pPr>
+            <a:r>
+              <a:rPr lang="uk-UA" sz="2000" b="0">
+                <a:solidFill>
+                  <a:srgbClr val="FBFBF8"/>
+                </a:solidFill>
+                <a:latin typeface="Fira Sans Extra Condensed"/>
+                <a:ea typeface="Fira Sans Extra Condensed"/>
+                <a:cs typeface="Fira Sans Extra Condensed"/>
+                <a:sym typeface="Fira Sans Extra Condensed"/>
+              </a:rPr>
+              <a:t>— Звертатися щодо роботи пекарні через Lviv Croissants</a:t>
+            </a:r>
+          </a:p>
+          <a:p>
+            <a:pPr algn="l">
+              <a:lnSpc>
+                <a:spcPct val="100000"/>
+              </a:lnSpc>
+              <a:spcAft>
+                <a:spcPts val="600"/>
+              </a:spcAft>
+            </a:pPr>
+            <a:r>
+              <a:rPr lang="uk-UA" sz="2000" b="0">
+                <a:solidFill>
+                  <a:srgbClr val="FBFBF8"/>
+                </a:solidFill>
+                <a:latin typeface="Fira Sans Extra Condensed"/>
+                <a:ea typeface="Fira Sans Extra Condensed"/>
+                <a:cs typeface="Fira Sans Extra Condensed"/>
+                <a:sym typeface="Fira Sans Extra Condensed"/>
+              </a:rPr>
+              <a:t>— Розглядати запити на дофінансування та вагомі зміни</a:t>
             </a:r>
           </a:p>
         </p:txBody>
+      </p:sp>
+      <p:sp>
+        <p:nvSpPr>
+          <p:cNvPr name="Role 11" id="11"/>
+          <p:cNvSpPr/>
+          <p:nvPr/>
+        </p:nvSpPr>
+        <p:spPr>
+          <a:xfrm>
+            <a:off x="1219200" y="4800000"/>
+            <a:ext cx="2300000" cy="2150000"/>
+          </a:xfrm>
+          <a:prstGeom prst="roundRect">
+            <a:avLst>
+              <a:gd name="adj" fmla="val 7000"/>
+            </a:avLst>
+          </a:prstGeom>
+          <a:solidFill>
+            <a:srgbClr val="F4B6C8"/>
+          </a:solidFill>
+        </p:spPr>
       </p:sp>
       <p:sp>
         <p:nvSpPr>
@@ -20154,248 +20165,541 @@
           <p:nvPr/>
         </p:nvSpPr>
         <p:spPr>
-          <a:xfrm rot="0">
-            <a:off x="469510" y="5781645"/>
-            <a:ext cx="8261440" cy="1439761"/>
+          <a:xfrm>
+            <a:off x="1369200" y="4800000"/>
+            <a:ext cx="2000000" cy="2150000"/>
           </a:xfrm>
           <a:prstGeom prst="rect">
             <a:avLst/>
           </a:prstGeom>
         </p:spPr>
         <p:txBody>
-          <a:bodyPr anchor="t" rtlCol="false" tIns="0" lIns="0" bIns="0" rIns="0">
-            <a:spAutoFit/>
+          <a:bodyPr anchor="ctr" wrap="square" rtlCol="false" tIns="0" lIns="0" bIns="0" rIns="0">
+            <a:noAutofit/>
           </a:bodyPr>
           <a:lstStyle/>
           <a:p>
-            <a:pPr algn="l" marL="491192" indent="-245596" lvl="1">
+            <a:pPr algn="ctr">
               <a:lnSpc>
-                <a:spcPts val="2843"/>
+                <a:spcPct val="100000"/>
               </a:lnSpc>
-              <a:buAutoNum type="arabicPeriod" startAt="1"/>
+              <a:spcAft>
+                <a:spcPts val="0"/>
+              </a:spcAft>
             </a:pPr>
             <a:r>
-              <a:rPr lang="en-US" sz="2275">
-                <a:solidFill>
-                  <a:srgbClr val="F4B6C8"/>
-                </a:solidFill>
-                <a:latin typeface="Fira Sans Extra Condensed"/>
-                <a:ea typeface="Fira Sans Extra Condensed"/>
-                <a:cs typeface="Fira Sans Extra Condensed"/>
-                <a:sym typeface="Fira Sans Extra Condensed"/>
-              </a:rPr>
-              <a:t>Профінансувати закріплені за роллю витрати.</a:t>
-            </a:r>
-          </a:p>
-          <a:p>
-            <a:pPr algn="l" marL="491192" indent="-245596" lvl="1">
-              <a:lnSpc>
-                <a:spcPts val="2843"/>
-              </a:lnSpc>
-              <a:buAutoNum type="arabicPeriod" startAt="1"/>
-            </a:pPr>
-            <a:r>
-              <a:rPr lang="en-US" sz="2275">
-                <a:solidFill>
-                  <a:srgbClr val="F4B6C8"/>
-                </a:solidFill>
-                <a:latin typeface="Fira Sans Extra Condensed"/>
-                <a:ea typeface="Fira Sans Extra Condensed"/>
-                <a:cs typeface="Fira Sans Extra Condensed"/>
-                <a:sym typeface="Fira Sans Extra Condensed"/>
-              </a:rPr>
-              <a:t>Пройти навчання операційного директора</a:t>
-            </a:r>
-          </a:p>
-          <a:p>
-            <a:pPr algn="l" marL="491192" indent="-245596" lvl="1">
-              <a:lnSpc>
-                <a:spcPts val="2843"/>
-              </a:lnSpc>
-              <a:buAutoNum type="arabicPeriod" startAt="1"/>
-            </a:pPr>
-            <a:r>
-              <a:rPr lang="en-US" sz="2275">
-                <a:solidFill>
-                  <a:srgbClr val="F4B6C8"/>
-                </a:solidFill>
-                <a:latin typeface="Fira Sans Extra Condensed"/>
-                <a:ea typeface="Fira Sans Extra Condensed"/>
-                <a:cs typeface="Fira Sans Extra Condensed"/>
-                <a:sym typeface="Fira Sans Extra Condensed"/>
-              </a:rPr>
-              <a:t>Укомплектувати команду</a:t>
-            </a:r>
-          </a:p>
-          <a:p>
-            <a:pPr algn="l" marL="491192" indent="-245596" lvl="1">
-              <a:lnSpc>
-                <a:spcPts val="2843"/>
-              </a:lnSpc>
-              <a:buAutoNum type="arabicPeriod" startAt="1"/>
-            </a:pPr>
-            <a:r>
-              <a:rPr lang="en-US" sz="2275">
-                <a:solidFill>
-                  <a:srgbClr val="F4B6C8"/>
-                </a:solidFill>
-                <a:latin typeface="Fira Sans Extra Condensed"/>
-                <a:ea typeface="Fira Sans Extra Condensed"/>
-                <a:cs typeface="Fira Sans Extra Condensed"/>
-                <a:sym typeface="Fira Sans Extra Condensed"/>
-              </a:rPr>
-              <a:t>Замовити необхідне по сухому складу та заморозці </a:t>
+              <a:rPr lang="uk-UA" sz="2600" b="1">
+                <a:solidFill>
+                  <a:srgbClr val="0E4D38"/>
+                </a:solidFill>
+                <a:latin typeface="Fira Sans Extra Condensed Bold"/>
+                <a:ea typeface="Fira Sans Extra Condensed Bold"/>
+                <a:cs typeface="Fira Sans Extra Condensed Bold"/>
+                <a:sym typeface="Fira Sans Extra Condensed Bold"/>
+              </a:rPr>
+              <a:t>Оператор</a:t>
             </a:r>
           </a:p>
         </p:txBody>
       </p:sp>
       <p:sp>
         <p:nvSpPr>
-          <p:cNvPr name="TextBox 13" id="13"/>
+          <p:cNvPr name="Card 13" id="13"/>
+          <p:cNvSpPr/>
+          <p:nvPr/>
+        </p:nvSpPr>
+        <p:spPr>
+          <a:xfrm>
+            <a:off x="3769200" y="4800000"/>
+            <a:ext cx="6524800" cy="2150000"/>
+          </a:xfrm>
+          <a:prstGeom prst="roundRect">
+            <a:avLst>
+              <a:gd name="adj" fmla="val 7000"/>
+            </a:avLst>
+          </a:prstGeom>
+          <a:solidFill>
+            <a:srgbClr val="135F45"/>
+          </a:solidFill>
+        </p:spPr>
+      </p:sp>
+      <p:sp>
+        <p:nvSpPr>
+          <p:cNvPr name="TextBox 14" id="14"/>
           <p:cNvSpPr txBox="true"/>
           <p:nvPr/>
         </p:nvSpPr>
         <p:spPr>
-          <a:xfrm rot="0">
-            <a:off x="3615355" y="7334927"/>
-            <a:ext cx="1969749" cy="476250"/>
+          <a:xfrm>
+            <a:off x="4019200" y="4950000"/>
+            <a:ext cx="6024800" cy="1850000"/>
           </a:xfrm>
           <a:prstGeom prst="rect">
             <a:avLst/>
           </a:prstGeom>
         </p:spPr>
         <p:txBody>
-          <a:bodyPr anchor="t" rtlCol="false" tIns="0" lIns="0" bIns="0" rIns="0">
-            <a:spAutoFit/>
+          <a:bodyPr anchor="ctr" wrap="square" rtlCol="false" tIns="0" lIns="0" bIns="0" rIns="0">
+            <a:noAutofit/>
           </a:bodyPr>
           <a:lstStyle/>
           <a:p>
             <a:pPr algn="l">
               <a:lnSpc>
-                <a:spcPts val="3750"/>
+                <a:spcPct val="100000"/>
               </a:lnSpc>
+              <a:spcAft>
+                <a:spcPts val="600"/>
+              </a:spcAft>
             </a:pPr>
             <a:r>
-              <a:rPr lang="en-US" sz="3000">
-                <a:solidFill>
-                  <a:srgbClr val="F4B6C8"/>
+              <a:rPr lang="uk-UA" sz="2000" b="0">
+                <a:solidFill>
+                  <a:srgbClr val="FBFBF8"/>
                 </a:solidFill>
                 <a:latin typeface="Fira Sans Extra Condensed"/>
                 <a:ea typeface="Fira Sans Extra Condensed"/>
                 <a:cs typeface="Fira Sans Extra Condensed"/>
                 <a:sym typeface="Fira Sans Extra Condensed"/>
               </a:rPr>
-              <a:t>Франчайзер</a:t>
+              <a:t>— Профінансувати закріплені за роллю витрати</a:t>
+            </a:r>
+          </a:p>
+          <a:p>
+            <a:pPr algn="l">
+              <a:lnSpc>
+                <a:spcPct val="100000"/>
+              </a:lnSpc>
+              <a:spcAft>
+                <a:spcPts val="600"/>
+              </a:spcAft>
+            </a:pPr>
+            <a:r>
+              <a:rPr lang="uk-UA" sz="2000" b="0">
+                <a:solidFill>
+                  <a:srgbClr val="FBFBF8"/>
+                </a:solidFill>
+                <a:latin typeface="Fira Sans Extra Condensed"/>
+                <a:ea typeface="Fira Sans Extra Condensed"/>
+                <a:cs typeface="Fira Sans Extra Condensed"/>
+                <a:sym typeface="Fira Sans Extra Condensed"/>
+              </a:rPr>
+              <a:t>— Пройти навчання операційного директора</a:t>
+            </a:r>
+          </a:p>
+          <a:p>
+            <a:pPr algn="l">
+              <a:lnSpc>
+                <a:spcPct val="100000"/>
+              </a:lnSpc>
+              <a:spcAft>
+                <a:spcPts val="600"/>
+              </a:spcAft>
+            </a:pPr>
+            <a:r>
+              <a:rPr lang="uk-UA" sz="2000" b="0">
+                <a:solidFill>
+                  <a:srgbClr val="FBFBF8"/>
+                </a:solidFill>
+                <a:latin typeface="Fira Sans Extra Condensed"/>
+                <a:ea typeface="Fira Sans Extra Condensed"/>
+                <a:cs typeface="Fira Sans Extra Condensed"/>
+                <a:sym typeface="Fira Sans Extra Condensed"/>
+              </a:rPr>
+              <a:t>— Укомплектувати команду, замовити сухий склад і заморозку</a:t>
             </a:r>
           </a:p>
         </p:txBody>
       </p:sp>
       <p:sp>
         <p:nvSpPr>
-          <p:cNvPr name="TextBox 14" id="14"/>
+          <p:cNvPr name="Card 15" id="15"/>
+          <p:cNvSpPr/>
+          <p:nvPr/>
+        </p:nvSpPr>
+        <p:spPr>
+          <a:xfrm>
+            <a:off x="10544000" y="4800000"/>
+            <a:ext cx="6524800" cy="2150000"/>
+          </a:xfrm>
+          <a:prstGeom prst="roundRect">
+            <a:avLst>
+              <a:gd name="adj" fmla="val 7000"/>
+            </a:avLst>
+          </a:prstGeom>
+          <a:solidFill>
+            <a:srgbClr val="135F45"/>
+          </a:solidFill>
+        </p:spPr>
+      </p:sp>
+      <p:sp>
+        <p:nvSpPr>
+          <p:cNvPr name="TextBox 16" id="16"/>
           <p:cNvSpPr txBox="true"/>
           <p:nvPr/>
         </p:nvSpPr>
         <p:spPr>
-          <a:xfrm rot="0">
-            <a:off x="469510" y="7877852"/>
-            <a:ext cx="8261440" cy="1800932"/>
+          <a:xfrm>
+            <a:off x="10794000" y="4950000"/>
+            <a:ext cx="6024800" cy="1850000"/>
           </a:xfrm>
           <a:prstGeom prst="rect">
             <a:avLst/>
           </a:prstGeom>
         </p:spPr>
         <p:txBody>
-          <a:bodyPr anchor="t" rtlCol="false" tIns="0" lIns="0" bIns="0" rIns="0">
-            <a:spAutoFit/>
+          <a:bodyPr anchor="ctr" wrap="square" rtlCol="false" tIns="0" lIns="0" bIns="0" rIns="0">
+            <a:noAutofit/>
           </a:bodyPr>
           <a:lstStyle/>
           <a:p>
-            <a:pPr algn="l" marL="491192" indent="-245596" lvl="1">
+            <a:pPr algn="l">
               <a:lnSpc>
-                <a:spcPts val="2843"/>
+                <a:spcPct val="100000"/>
               </a:lnSpc>
-              <a:buAutoNum type="arabicPeriod" startAt="1"/>
+              <a:spcAft>
+                <a:spcPts val="600"/>
+              </a:spcAft>
             </a:pPr>
             <a:r>
-              <a:rPr lang="en-US" sz="2275">
-                <a:solidFill>
-                  <a:srgbClr val="F4B6C8"/>
+              <a:rPr lang="uk-UA" sz="2000" b="0">
+                <a:solidFill>
+                  <a:srgbClr val="FBFBF8"/>
                 </a:solidFill>
                 <a:latin typeface="Fira Sans Extra Condensed"/>
                 <a:ea typeface="Fira Sans Extra Condensed"/>
                 <a:cs typeface="Fira Sans Extra Condensed"/>
                 <a:sym typeface="Fira Sans Extra Condensed"/>
               </a:rPr>
-              <a:t>Профінансувати закріплені за роллю витрати.</a:t>
-            </a:r>
-          </a:p>
-          <a:p>
-            <a:pPr algn="l" marL="491192" indent="-245596" lvl="1">
+              <a:t>— Щодня керувати пекарнею й командою</a:t>
+            </a:r>
+          </a:p>
+          <a:p>
+            <a:pPr algn="l">
               <a:lnSpc>
-                <a:spcPts val="2843"/>
+                <a:spcPct val="100000"/>
               </a:lnSpc>
-              <a:buAutoNum type="arabicPeriod" startAt="1"/>
+              <a:spcAft>
+                <a:spcPts val="600"/>
+              </a:spcAft>
             </a:pPr>
             <a:r>
-              <a:rPr lang="en-US" sz="2275">
-                <a:solidFill>
-                  <a:srgbClr val="F4B6C8"/>
+              <a:rPr lang="uk-UA" sz="2000" b="0">
+                <a:solidFill>
+                  <a:srgbClr val="FBFBF8"/>
                 </a:solidFill>
                 <a:latin typeface="Fira Sans Extra Condensed"/>
                 <a:ea typeface="Fira Sans Extra Condensed"/>
                 <a:cs typeface="Fira Sans Extra Condensed"/>
                 <a:sym typeface="Fira Sans Extra Condensed"/>
               </a:rPr>
-              <a:t>Пройти навчання операційного директора</a:t>
-            </a:r>
-          </a:p>
-          <a:p>
-            <a:pPr algn="l" marL="491192" indent="-245596" lvl="1">
+              <a:t>— Дотримуватися стандартів бренду</a:t>
+            </a:r>
+          </a:p>
+          <a:p>
+            <a:pPr algn="l">
               <a:lnSpc>
-                <a:spcPts val="2843"/>
+                <a:spcPct val="100000"/>
               </a:lnSpc>
-              <a:buAutoNum type="arabicPeriod" startAt="1"/>
+              <a:spcAft>
+                <a:spcPts val="600"/>
+              </a:spcAft>
             </a:pPr>
             <a:r>
-              <a:rPr lang="en-US" sz="2275">
-                <a:solidFill>
-                  <a:srgbClr val="F4B6C8"/>
+              <a:rPr lang="uk-UA" sz="2000" b="0">
+                <a:solidFill>
+                  <a:srgbClr val="FBFBF8"/>
                 </a:solidFill>
                 <a:latin typeface="Fira Sans Extra Condensed"/>
                 <a:ea typeface="Fira Sans Extra Condensed"/>
                 <a:cs typeface="Fira Sans Extra Condensed"/>
                 <a:sym typeface="Fira Sans Extra Condensed"/>
               </a:rPr>
-              <a:t>Укомплектувати команду</a:t>
-            </a:r>
-          </a:p>
-          <a:p>
-            <a:pPr algn="l" marL="491192" indent="-245596" lvl="1">
+              <a:t>— Отримувати свою частку прибутку за шкалою</a:t>
+            </a:r>
+          </a:p>
+        </p:txBody>
+      </p:sp>
+      <p:sp>
+        <p:nvSpPr>
+          <p:cNvPr name="Role 17" id="17"/>
+          <p:cNvSpPr/>
+          <p:nvPr/>
+        </p:nvSpPr>
+        <p:spPr>
+          <a:xfrm>
+            <a:off x="1219200" y="7150000"/>
+            <a:ext cx="2300000" cy="2150000"/>
+          </a:xfrm>
+          <a:prstGeom prst="roundRect">
+            <a:avLst>
+              <a:gd name="adj" fmla="val 7000"/>
+            </a:avLst>
+          </a:prstGeom>
+          <a:solidFill>
+            <a:srgbClr val="F4B6C8"/>
+          </a:solidFill>
+        </p:spPr>
+      </p:sp>
+      <p:sp>
+        <p:nvSpPr>
+          <p:cNvPr name="TextBox 18" id="18"/>
+          <p:cNvSpPr txBox="true"/>
+          <p:nvPr/>
+        </p:nvSpPr>
+        <p:spPr>
+          <a:xfrm>
+            <a:off x="1369200" y="7150000"/>
+            <a:ext cx="2000000" cy="2150000"/>
+          </a:xfrm>
+          <a:prstGeom prst="rect">
+            <a:avLst/>
+          </a:prstGeom>
+        </p:spPr>
+        <p:txBody>
+          <a:bodyPr anchor="ctr" wrap="square" rtlCol="false" tIns="0" lIns="0" bIns="0" rIns="0">
+            <a:noAutofit/>
+          </a:bodyPr>
+          <a:lstStyle/>
+          <a:p>
+            <a:pPr algn="ctr">
               <a:lnSpc>
-                <a:spcPts val="2843"/>
+                <a:spcPct val="100000"/>
               </a:lnSpc>
-              <a:buAutoNum type="arabicPeriod" startAt="1"/>
+              <a:spcAft>
+                <a:spcPts val="0"/>
+              </a:spcAft>
             </a:pPr>
             <a:r>
-              <a:rPr lang="en-US" sz="2275">
-                <a:solidFill>
-                  <a:srgbClr val="F4B6C8"/>
+              <a:rPr lang="uk-UA" sz="2600" b="1">
+                <a:solidFill>
+                  <a:srgbClr val="0E4D38"/>
+                </a:solidFill>
+                <a:latin typeface="Fira Sans Extra Condensed Bold"/>
+                <a:ea typeface="Fira Sans Extra Condensed Bold"/>
+                <a:cs typeface="Fira Sans Extra Condensed Bold"/>
+                <a:sym typeface="Fira Sans Extra Condensed Bold"/>
+              </a:rPr>
+              <a:t>Lviv Croissants</a:t>
+            </a:r>
+          </a:p>
+        </p:txBody>
+      </p:sp>
+      <p:sp>
+        <p:nvSpPr>
+          <p:cNvPr name="Card 19" id="19"/>
+          <p:cNvSpPr/>
+          <p:nvPr/>
+        </p:nvSpPr>
+        <p:spPr>
+          <a:xfrm>
+            <a:off x="3769200" y="7150000"/>
+            <a:ext cx="6524800" cy="2150000"/>
+          </a:xfrm>
+          <a:prstGeom prst="roundRect">
+            <a:avLst>
+              <a:gd name="adj" fmla="val 7000"/>
+            </a:avLst>
+          </a:prstGeom>
+          <a:solidFill>
+            <a:srgbClr val="135F45"/>
+          </a:solidFill>
+        </p:spPr>
+      </p:sp>
+      <p:sp>
+        <p:nvSpPr>
+          <p:cNvPr name="TextBox 20" id="20"/>
+          <p:cNvSpPr txBox="true"/>
+          <p:nvPr/>
+        </p:nvSpPr>
+        <p:spPr>
+          <a:xfrm>
+            <a:off x="4019200" y="7300000"/>
+            <a:ext cx="6024800" cy="1850000"/>
+          </a:xfrm>
+          <a:prstGeom prst="rect">
+            <a:avLst/>
+          </a:prstGeom>
+        </p:spPr>
+        <p:txBody>
+          <a:bodyPr anchor="ctr" wrap="square" rtlCol="false" tIns="0" lIns="0" bIns="0" rIns="0">
+            <a:noAutofit/>
+          </a:bodyPr>
+          <a:lstStyle/>
+          <a:p>
+            <a:pPr algn="l">
+              <a:lnSpc>
+                <a:spcPct val="100000"/>
+              </a:lnSpc>
+              <a:spcAft>
+                <a:spcPts val="600"/>
+              </a:spcAft>
+            </a:pPr>
+            <a:r>
+              <a:rPr lang="uk-UA" sz="2000" b="0">
+                <a:solidFill>
+                  <a:srgbClr val="FBFBF8"/>
                 </a:solidFill>
                 <a:latin typeface="Fira Sans Extra Condensed"/>
                 <a:ea typeface="Fira Sans Extra Condensed"/>
                 <a:cs typeface="Fira Sans Extra Condensed"/>
                 <a:sym typeface="Fira Sans Extra Condensed"/>
               </a:rPr>
-              <a:t>Замовити необхідне по сухому складу та заморозці</a:t>
+              <a:t>— Профінансувати закріплені за роллю витрати</a:t>
             </a:r>
           </a:p>
           <a:p>
             <a:pPr algn="l">
               <a:lnSpc>
-                <a:spcPts val="2843"/>
+                <a:spcPct val="100000"/>
               </a:lnSpc>
+              <a:spcAft>
+                <a:spcPts val="600"/>
+              </a:spcAft>
             </a:pPr>
+            <a:r>
+              <a:rPr lang="uk-UA" sz="2000" b="0">
+                <a:solidFill>
+                  <a:srgbClr val="FBFBF8"/>
+                </a:solidFill>
+                <a:latin typeface="Fira Sans Extra Condensed"/>
+                <a:ea typeface="Fira Sans Extra Condensed"/>
+                <a:cs typeface="Fira Sans Extra Condensed"/>
+                <a:sym typeface="Fira Sans Extra Condensed"/>
+              </a:rPr>
+              <a:t>— Навчити операційного директора й команду</a:t>
+            </a:r>
+          </a:p>
+          <a:p>
+            <a:pPr algn="l">
+              <a:lnSpc>
+                <a:spcPct val="100000"/>
+              </a:lnSpc>
+              <a:spcAft>
+                <a:spcPts val="600"/>
+              </a:spcAft>
+            </a:pPr>
+            <a:r>
+              <a:rPr lang="uk-UA" sz="2000" b="0">
+                <a:solidFill>
+                  <a:srgbClr val="FBFBF8"/>
+                </a:solidFill>
+                <a:latin typeface="Fira Sans Extra Condensed"/>
+                <a:ea typeface="Fira Sans Extra Condensed"/>
+                <a:cs typeface="Fira Sans Extra Condensed"/>
+                <a:sym typeface="Fira Sans Extra Condensed"/>
+              </a:rPr>
+              <a:t>— Надати бренд, стандарти, Internal Systems</a:t>
+            </a:r>
+          </a:p>
+        </p:txBody>
+      </p:sp>
+      <p:sp>
+        <p:nvSpPr>
+          <p:cNvPr name="Card 21" id="21"/>
+          <p:cNvSpPr/>
+          <p:nvPr/>
+        </p:nvSpPr>
+        <p:spPr>
+          <a:xfrm>
+            <a:off x="10544000" y="7150000"/>
+            <a:ext cx="6524800" cy="2150000"/>
+          </a:xfrm>
+          <a:prstGeom prst="roundRect">
+            <a:avLst>
+              <a:gd name="adj" fmla="val 7000"/>
+            </a:avLst>
+          </a:prstGeom>
+          <a:solidFill>
+            <a:srgbClr val="135F45"/>
+          </a:solidFill>
+        </p:spPr>
+      </p:sp>
+      <p:sp>
+        <p:nvSpPr>
+          <p:cNvPr name="TextBox 22" id="22"/>
+          <p:cNvSpPr txBox="true"/>
+          <p:nvPr/>
+        </p:nvSpPr>
+        <p:spPr>
+          <a:xfrm>
+            <a:off x="10794000" y="7300000"/>
+            <a:ext cx="6024800" cy="1850000"/>
+          </a:xfrm>
+          <a:prstGeom prst="rect">
+            <a:avLst/>
+          </a:prstGeom>
+        </p:spPr>
+        <p:txBody>
+          <a:bodyPr anchor="ctr" wrap="square" rtlCol="false" tIns="0" lIns="0" bIns="0" rIns="0">
+            <a:noAutofit/>
+          </a:bodyPr>
+          <a:lstStyle/>
+          <a:p>
+            <a:pPr algn="l">
+              <a:lnSpc>
+                <a:spcPct val="100000"/>
+              </a:lnSpc>
+              <a:spcAft>
+                <a:spcPts val="600"/>
+              </a:spcAft>
+            </a:pPr>
+            <a:r>
+              <a:rPr lang="uk-UA" sz="2000" b="0">
+                <a:solidFill>
+                  <a:srgbClr val="FBFBF8"/>
+                </a:solidFill>
+                <a:latin typeface="Fira Sans Extra Condensed"/>
+                <a:ea typeface="Fira Sans Extra Condensed"/>
+                <a:cs typeface="Fira Sans Extra Condensed"/>
+                <a:sym typeface="Fira Sans Extra Condensed"/>
+              </a:rPr>
+              <a:t>— Підтримувати оператора і стандарти бренду</a:t>
+            </a:r>
+          </a:p>
+          <a:p>
+            <a:pPr algn="l">
+              <a:lnSpc>
+                <a:spcPct val="100000"/>
+              </a:lnSpc>
+              <a:spcAft>
+                <a:spcPts val="600"/>
+              </a:spcAft>
+            </a:pPr>
+            <a:r>
+              <a:rPr lang="uk-UA" sz="2000" b="0">
+                <a:solidFill>
+                  <a:srgbClr val="FBFBF8"/>
+                </a:solidFill>
+                <a:latin typeface="Fira Sans Extra Condensed"/>
+                <a:ea typeface="Fira Sans Extra Condensed"/>
+                <a:cs typeface="Fira Sans Extra Condensed"/>
+                <a:sym typeface="Fira Sans Extra Condensed"/>
+              </a:rPr>
+              <a:t>— Передавати запити між інвестором і оператором</a:t>
+            </a:r>
+          </a:p>
+          <a:p>
+            <a:pPr algn="l">
+              <a:lnSpc>
+                <a:spcPct val="100000"/>
+              </a:lnSpc>
+              <a:spcAft>
+                <a:spcPts val="600"/>
+              </a:spcAft>
+            </a:pPr>
+            <a:r>
+              <a:rPr lang="uk-UA" sz="2000" b="0">
+                <a:solidFill>
+                  <a:srgbClr val="FBFBF8"/>
+                </a:solidFill>
+                <a:latin typeface="Fira Sans Extra Condensed"/>
+                <a:ea typeface="Fira Sans Extra Condensed"/>
+                <a:cs typeface="Fira Sans Extra Condensed"/>
+                <a:sym typeface="Fira Sans Extra Condensed"/>
+              </a:rPr>
+              <a:t>— Отримувати 3% від прибутку та 1% від доходу</a:t>
+            </a:r>
           </a:p>
         </p:txBody>
       </p:sp>

</xml_diff>

<commit_message>
Align responsibility zones with HQ/franchisee stage matrix
Co-Authored-By: Claude Sonnet 5.5 <noreply@anthropic.com>
Claude-Session: https://claude.ai/code/session_01SVoKafBmW5nnvB217TvhV6
</commit_message>
<xml_diff>
--- a/presentation_with_contract.pptx
+++ b/presentation_with_contract.pptx
@@ -19979,7 +19979,7 @@
                 <a:cs typeface="Fira Sans Extra Condensed"/>
                 <a:sym typeface="Fira Sans Extra Condensed"/>
               </a:rPr>
-              <a:t>— Профінансувати закріплені за роллю витрати</a:t>
+              <a:t>— Профінансувати закріплені за роллю витрати, зокрема відрядження команди HQ</a:t>
             </a:r>
           </a:p>
           <a:p>
@@ -20262,7 +20262,7 @@
                 <a:cs typeface="Fira Sans Extra Condensed"/>
                 <a:sym typeface="Fira Sans Extra Condensed"/>
               </a:rPr>
-              <a:t>— Профінансувати закріплені за роллю витрати</a:t>
+              <a:t>— Бути присутнім як операційний директор і пройти навчання</a:t>
             </a:r>
           </a:p>
           <a:p>
@@ -20284,7 +20284,7 @@
                 <a:cs typeface="Fira Sans Extra Condensed"/>
                 <a:sym typeface="Fira Sans Extra Condensed"/>
               </a:rPr>
-              <a:t>— Пройти навчання операційного директора</a:t>
+              <a:t>— Підібрати та оформити персонал, постачальників</a:t>
             </a:r>
           </a:p>
           <a:p>
@@ -20306,7 +20306,7 @@
                 <a:cs typeface="Fira Sans Extra Condensed"/>
                 <a:sym typeface="Fira Sans Extra Condensed"/>
               </a:rPr>
-              <a:t>— Укомплектувати команду, замовити сухий склад і заморозку</a:t>
+              <a:t>— Замовити сухий склад і заморозку, провести навчання команди</a:t>
             </a:r>
           </a:p>
         </p:txBody>
@@ -20371,7 +20371,7 @@
                 <a:cs typeface="Fira Sans Extra Condensed"/>
                 <a:sym typeface="Fira Sans Extra Condensed"/>
               </a:rPr>
-              <a:t>— Щодня керувати пекарнею й командою</a:t>
+              <a:t>— Щодня керувати пекарнею, персоналом і закупівлями</a:t>
             </a:r>
           </a:p>
           <a:p>
@@ -20393,7 +20393,7 @@
                 <a:cs typeface="Fira Sans Extra Condensed"/>
                 <a:sym typeface="Fira Sans Extra Condensed"/>
               </a:rPr>
-              <a:t>— Дотримуватися стандартів бренду</a:t>
+              <a:t>— Вести Odoo, інвентаризацію, P&amp;L та ABC звіти</a:t>
             </a:r>
           </a:p>
           <a:p>
@@ -20415,7 +20415,7 @@
                 <a:cs typeface="Fira Sans Extra Condensed"/>
                 <a:sym typeface="Fira Sans Extra Condensed"/>
               </a:rPr>
-              <a:t>— Отримувати свою частку прибутку за шкалою</a:t>
+              <a:t>— Розвивати додаткові канали збуту; отримувати частку прибутку</a:t>
             </a:r>
           </a:p>
         </p:txBody>
@@ -20545,7 +20545,7 @@
                 <a:cs typeface="Fira Sans Extra Condensed"/>
                 <a:sym typeface="Fira Sans Extra Condensed"/>
               </a:rPr>
-              <a:t>— Профінансувати закріплені за роллю витрати</a:t>
+              <a:t>— Навчити операційного директора (~30 днів) і команду</a:t>
             </a:r>
           </a:p>
           <a:p>
@@ -20567,7 +20567,7 @@
                 <a:cs typeface="Fira Sans Extra Condensed"/>
                 <a:sym typeface="Fira Sans Extra Condensed"/>
               </a:rPr>
-              <a:t>— Навчити операційного директора й команду</a:t>
+              <a:t>— Дистанційно вести ремонт, обладнання, меню, кошторис</a:t>
             </a:r>
           </a:p>
           <a:p>
@@ -20589,7 +20589,7 @@
                 <a:cs typeface="Fira Sans Extra Condensed"/>
                 <a:sym typeface="Fira Sans Extra Condensed"/>
               </a:rPr>
-              <a:t>— Надати бренд, стандарти, Internal Systems</a:t>
+              <a:t>— Команда HQ на місці за 14 днів: запуск, тестування, відкриття</a:t>
             </a:r>
           </a:p>
         </p:txBody>
@@ -20654,7 +20654,7 @@
                 <a:cs typeface="Fira Sans Extra Condensed"/>
                 <a:sym typeface="Fira Sans Extra Condensed"/>
               </a:rPr>
-              <a:t>— Підтримувати оператора і стандарти бренду</a:t>
+              <a:t>— Менеджер проєкту на місці ~5 тижнів: від стабілізації до автономії</a:t>
             </a:r>
           </a:p>
           <a:p>
@@ -20676,7 +20676,7 @@
                 <a:cs typeface="Fira Sans Extra Condensed"/>
                 <a:sym typeface="Fira Sans Extra Condensed"/>
               </a:rPr>
-              <a:t>— Передавати запити між інвестором і оператором</a:t>
+              <a:t>— Контролювати Стандарти Мережі, звітність, меню</a:t>
             </a:r>
           </a:p>
           <a:p>

</xml_diff>

<commit_message>
Fill contract section slides and add legal questions slide
Co-Authored-By: Claude Sonnet 5.5 <noreply@anthropic.com>
Claude-Session: https://claude.ai/code/session_01SVoKafBmW5nnvB217TvhV6
</commit_message>
<xml_diff>
--- a/presentation_with_contract.pptx
+++ b/presentation_with_contract.pptx
@@ -41,6 +41,7 @@
     <p:sldId id="289" r:id="rId41"/>
     <p:sldId id="290" r:id="rId42"/>
     <p:sldId id="291" r:id="rId43"/>
+    <p:sldId id="292" r:id="rId44"/>
   </p:sldIdLst>
   <p:sldSz cx="18288000" cy="10287000"/>
   <p:notesSz cx="6858000" cy="9144000"/>
@@ -22650,6 +22651,421 @@
           </a:p>
         </p:txBody>
       </p:sp>
+      <p:sp>
+        <p:nvSpPr>
+          <p:cNvPr name="Card 3" id="3"/>
+          <p:cNvSpPr/>
+          <p:nvPr/>
+        </p:nvSpPr>
+        <p:spPr>
+          <a:xfrm>
+            <a:off x="1219200" y="2200000"/>
+            <a:ext cx="7774800" cy="6200000"/>
+          </a:xfrm>
+          <a:prstGeom prst="roundRect">
+            <a:avLst>
+              <a:gd name="adj" fmla="val 7000"/>
+            </a:avLst>
+          </a:prstGeom>
+          <a:solidFill>
+            <a:srgbClr val="135F45"/>
+          </a:solidFill>
+        </p:spPr>
+      </p:sp>
+      <p:sp>
+        <p:nvSpPr>
+          <p:cNvPr name="TextBox 4" id="4"/>
+          <p:cNvSpPr txBox="true"/>
+          <p:nvPr/>
+        </p:nvSpPr>
+        <p:spPr>
+          <a:xfrm>
+            <a:off x="1519200" y="2450000"/>
+            <a:ext cx="7174800" cy="700000"/>
+          </a:xfrm>
+          <a:prstGeom prst="rect">
+            <a:avLst/>
+          </a:prstGeom>
+        </p:spPr>
+        <p:txBody>
+          <a:bodyPr anchor="t" wrap="square" rtlCol="false" tIns="0" lIns="0" bIns="0" rIns="0">
+            <a:noAutofit/>
+          </a:bodyPr>
+          <a:lstStyle/>
+          <a:p>
+            <a:pPr algn="l">
+              <a:lnSpc>
+                <a:spcPct val="100000"/>
+              </a:lnSpc>
+              <a:spcAft>
+                <a:spcPts val="0"/>
+              </a:spcAft>
+            </a:pPr>
+            <a:r>
+              <a:rPr lang="uk-UA" sz="2800" b="1">
+                <a:solidFill>
+                  <a:srgbClr val="F4B6C8"/>
+                </a:solidFill>
+                <a:latin typeface="Fira Sans Extra Condensed Bold"/>
+                <a:ea typeface="Fira Sans Extra Condensed Bold"/>
+                <a:cs typeface="Fira Sans Extra Condensed Bold"/>
+                <a:sym typeface="Fira Sans Extra Condensed Bold"/>
+              </a:rPr>
+              <a:t>Договір 1: інвестор</a:t>
+            </a:r>
+          </a:p>
+        </p:txBody>
+      </p:sp>
+      <p:sp>
+        <p:nvSpPr>
+          <p:cNvPr name="TextBox 5" id="5"/>
+          <p:cNvSpPr txBox="true"/>
+          <p:nvPr/>
+        </p:nvSpPr>
+        <p:spPr>
+          <a:xfrm>
+            <a:off x="1519200" y="3350000"/>
+            <a:ext cx="7174800" cy="4900000"/>
+          </a:xfrm>
+          <a:prstGeom prst="rect">
+            <a:avLst/>
+          </a:prstGeom>
+        </p:spPr>
+        <p:txBody>
+          <a:bodyPr anchor="t" wrap="square" rtlCol="false" tIns="0" lIns="0" bIns="0" rIns="0">
+            <a:noAutofit/>
+          </a:bodyPr>
+          <a:lstStyle/>
+          <a:p>
+            <a:pPr algn="l">
+              <a:lnSpc>
+                <a:spcPct val="100000"/>
+              </a:lnSpc>
+              <a:spcAft>
+                <a:spcPts val="1600"/>
+              </a:spcAft>
+            </a:pPr>
+            <a:r>
+              <a:rPr lang="uk-UA" sz="2400" b="0">
+                <a:solidFill>
+                  <a:srgbClr val="FBFBF8"/>
+                </a:solidFill>
+                <a:latin typeface="Fira Sans Extra Condensed"/>
+                <a:ea typeface="Fira Sans Extra Condensed"/>
+                <a:cs typeface="Fira Sans Extra Condensed"/>
+                <a:sym typeface="Fira Sans Extra Condensed"/>
+              </a:rPr>
+              <a:t>— Тип: інвестиційний договір (кваліфікацію визначає юрист)</a:t>
+            </a:r>
+          </a:p>
+          <a:p>
+            <a:pPr algn="l">
+              <a:lnSpc>
+                <a:spcPct val="100000"/>
+              </a:lnSpc>
+              <a:spcAft>
+                <a:spcPts val="1600"/>
+              </a:spcAft>
+            </a:pPr>
+            <a:r>
+              <a:rPr lang="uk-UA" sz="2400" b="0">
+                <a:solidFill>
+                  <a:srgbClr val="FBFBF8"/>
+                </a:solidFill>
+                <a:latin typeface="Fira Sans Extra Condensed"/>
+                <a:ea typeface="Fira Sans Extra Condensed"/>
+                <a:cs typeface="Fira Sans Extra Condensed"/>
+                <a:sym typeface="Fira Sans Extra Condensed"/>
+              </a:rPr>
+              <a:t>— Предмет: фінансування відкриття пекарні</a:t>
+            </a:r>
+          </a:p>
+          <a:p>
+            <a:pPr algn="l">
+              <a:lnSpc>
+                <a:spcPct val="100000"/>
+              </a:lnSpc>
+              <a:spcAft>
+                <a:spcPts val="1600"/>
+              </a:spcAft>
+            </a:pPr>
+            <a:r>
+              <a:rPr lang="uk-UA" sz="2400" b="0">
+                <a:solidFill>
+                  <a:srgbClr val="FBFBF8"/>
+                </a:solidFill>
+                <a:latin typeface="Fira Sans Extra Condensed"/>
+                <a:ea typeface="Fira Sans Extra Condensed"/>
+                <a:cs typeface="Fira Sans Extra Condensed"/>
+                <a:sym typeface="Fira Sans Extra Condensed"/>
+              </a:rPr>
+              <a:t>— Інвестор не керує пекарнею й не підпорядковується оператору</a:t>
+            </a:r>
+          </a:p>
+          <a:p>
+            <a:pPr algn="l">
+              <a:lnSpc>
+                <a:spcPct val="100000"/>
+              </a:lnSpc>
+              <a:spcAft>
+                <a:spcPts val="1600"/>
+              </a:spcAft>
+            </a:pPr>
+            <a:r>
+              <a:rPr lang="uk-UA" sz="2400" b="0">
+                <a:solidFill>
+                  <a:srgbClr val="FBFBF8"/>
+                </a:solidFill>
+                <a:latin typeface="Fira Sans Extra Condensed"/>
+                <a:ea typeface="Fira Sans Extra Condensed"/>
+                <a:cs typeface="Fira Sans Extra Condensed"/>
+                <a:sym typeface="Fira Sans Extra Condensed"/>
+              </a:rPr>
+              <a:t>— Окремо визначити, хто орендар приміщення</a:t>
+            </a:r>
+          </a:p>
+        </p:txBody>
+      </p:sp>
+      <p:sp>
+        <p:nvSpPr>
+          <p:cNvPr name="Card 6" id="6"/>
+          <p:cNvSpPr/>
+          <p:nvPr/>
+        </p:nvSpPr>
+        <p:spPr>
+          <a:xfrm>
+            <a:off x="9294000" y="2200000"/>
+            <a:ext cx="7774800" cy="6200000"/>
+          </a:xfrm>
+          <a:prstGeom prst="roundRect">
+            <a:avLst>
+              <a:gd name="adj" fmla="val 7000"/>
+            </a:avLst>
+          </a:prstGeom>
+          <a:solidFill>
+            <a:srgbClr val="135F45"/>
+          </a:solidFill>
+        </p:spPr>
+      </p:sp>
+      <p:sp>
+        <p:nvSpPr>
+          <p:cNvPr name="TextBox 7" id="7"/>
+          <p:cNvSpPr txBox="true"/>
+          <p:nvPr/>
+        </p:nvSpPr>
+        <p:spPr>
+          <a:xfrm>
+            <a:off x="9594000" y="2450000"/>
+            <a:ext cx="7174800" cy="700000"/>
+          </a:xfrm>
+          <a:prstGeom prst="rect">
+            <a:avLst/>
+          </a:prstGeom>
+        </p:spPr>
+        <p:txBody>
+          <a:bodyPr anchor="t" wrap="square" rtlCol="false" tIns="0" lIns="0" bIns="0" rIns="0">
+            <a:noAutofit/>
+          </a:bodyPr>
+          <a:lstStyle/>
+          <a:p>
+            <a:pPr algn="l">
+              <a:lnSpc>
+                <a:spcPct val="100000"/>
+              </a:lnSpc>
+              <a:spcAft>
+                <a:spcPts val="0"/>
+              </a:spcAft>
+            </a:pPr>
+            <a:r>
+              <a:rPr lang="uk-UA" sz="2800" b="1">
+                <a:solidFill>
+                  <a:srgbClr val="F4B6C8"/>
+                </a:solidFill>
+                <a:latin typeface="Fira Sans Extra Condensed Bold"/>
+                <a:ea typeface="Fira Sans Extra Condensed Bold"/>
+                <a:cs typeface="Fira Sans Extra Condensed Bold"/>
+                <a:sym typeface="Fira Sans Extra Condensed Bold"/>
+              </a:rPr>
+              <a:t>Договір 2: оператор</a:t>
+            </a:r>
+          </a:p>
+        </p:txBody>
+      </p:sp>
+      <p:sp>
+        <p:nvSpPr>
+          <p:cNvPr name="TextBox 8" id="8"/>
+          <p:cNvSpPr txBox="true"/>
+          <p:nvPr/>
+        </p:nvSpPr>
+        <p:spPr>
+          <a:xfrm>
+            <a:off x="9594000" y="3350000"/>
+            <a:ext cx="7174800" cy="4900000"/>
+          </a:xfrm>
+          <a:prstGeom prst="rect">
+            <a:avLst/>
+          </a:prstGeom>
+        </p:spPr>
+        <p:txBody>
+          <a:bodyPr anchor="t" wrap="square" rtlCol="false" tIns="0" lIns="0" bIns="0" rIns="0">
+            <a:noAutofit/>
+          </a:bodyPr>
+          <a:lstStyle/>
+          <a:p>
+            <a:pPr algn="l">
+              <a:lnSpc>
+                <a:spcPct val="100000"/>
+              </a:lnSpc>
+              <a:spcAft>
+                <a:spcPts val="1600"/>
+              </a:spcAft>
+            </a:pPr>
+            <a:r>
+              <a:rPr lang="uk-UA" sz="2400" b="0">
+                <a:solidFill>
+                  <a:srgbClr val="FBFBF8"/>
+                </a:solidFill>
+                <a:latin typeface="Fira Sans Extra Condensed"/>
+                <a:ea typeface="Fira Sans Extra Condensed"/>
+                <a:cs typeface="Fira Sans Extra Condensed"/>
+                <a:sym typeface="Fira Sans Extra Condensed"/>
+              </a:rPr>
+              <a:t>— Тип: франчайзинговий договір</a:t>
+            </a:r>
+          </a:p>
+          <a:p>
+            <a:pPr algn="l">
+              <a:lnSpc>
+                <a:spcPct val="100000"/>
+              </a:lnSpc>
+              <a:spcAft>
+                <a:spcPts val="1600"/>
+              </a:spcAft>
+            </a:pPr>
+            <a:r>
+              <a:rPr lang="uk-UA" sz="2400" b="0">
+                <a:solidFill>
+                  <a:srgbClr val="FBFBF8"/>
+                </a:solidFill>
+                <a:latin typeface="Fira Sans Extra Condensed"/>
+                <a:ea typeface="Fira Sans Extra Condensed"/>
+                <a:cs typeface="Fira Sans Extra Condensed"/>
+                <a:sym typeface="Fira Sans Extra Condensed"/>
+              </a:rPr>
+              <a:t>— Предмет: право вести пекарню під брендом за Стандартами Мережі</a:t>
+            </a:r>
+          </a:p>
+          <a:p>
+            <a:pPr algn="l">
+              <a:lnSpc>
+                <a:spcPct val="100000"/>
+              </a:lnSpc>
+              <a:spcAft>
+                <a:spcPts val="1600"/>
+              </a:spcAft>
+            </a:pPr>
+            <a:r>
+              <a:rPr lang="uk-UA" sz="2400" b="0">
+                <a:solidFill>
+                  <a:srgbClr val="FBFBF8"/>
+                </a:solidFill>
+                <a:latin typeface="Fira Sans Extra Condensed"/>
+                <a:ea typeface="Fira Sans Extra Condensed"/>
+                <a:cs typeface="Fira Sans Extra Condensed"/>
+                <a:sym typeface="Fira Sans Extra Condensed"/>
+              </a:rPr>
+              <a:t>— Оператор керує щодня й підпорядковується Lviv Croissants</a:t>
+            </a:r>
+          </a:p>
+          <a:p>
+            <a:pPr algn="l">
+              <a:lnSpc>
+                <a:spcPct val="100000"/>
+              </a:lnSpc>
+              <a:spcAft>
+                <a:spcPts val="1600"/>
+              </a:spcAft>
+            </a:pPr>
+            <a:r>
+              <a:rPr lang="uk-UA" sz="2400" b="0">
+                <a:solidFill>
+                  <a:srgbClr val="FBFBF8"/>
+                </a:solidFill>
+                <a:latin typeface="Fira Sans Extra Condensed"/>
+                <a:ea typeface="Fira Sans Extra Condensed"/>
+                <a:cs typeface="Fira Sans Extra Condensed"/>
+                <a:sym typeface="Fira Sans Extra Condensed"/>
+              </a:rPr>
+              <a:t>— Пекарня: адреса, формат, територія</a:t>
+            </a:r>
+          </a:p>
+        </p:txBody>
+      </p:sp>
+      <p:sp>
+        <p:nvSpPr>
+          <p:cNvPr name="Note 9" id="9"/>
+          <p:cNvSpPr/>
+          <p:nvPr/>
+        </p:nvSpPr>
+        <p:spPr>
+          <a:xfrm>
+            <a:off x="1219200" y="8750000"/>
+            <a:ext cx="15849600" cy="1000000"/>
+          </a:xfrm>
+          <a:prstGeom prst="roundRect">
+            <a:avLst>
+              <a:gd name="adj" fmla="val 7000"/>
+            </a:avLst>
+          </a:prstGeom>
+          <a:solidFill>
+            <a:srgbClr val="F4B6C8"/>
+          </a:solidFill>
+        </p:spPr>
+      </p:sp>
+      <p:sp>
+        <p:nvSpPr>
+          <p:cNvPr name="TextBox 10" id="10"/>
+          <p:cNvSpPr txBox="true"/>
+          <p:nvPr/>
+        </p:nvSpPr>
+        <p:spPr>
+          <a:xfrm>
+            <a:off x="1500000" y="8750000"/>
+            <a:ext cx="15286000" cy="1000000"/>
+          </a:xfrm>
+          <a:prstGeom prst="rect">
+            <a:avLst/>
+          </a:prstGeom>
+        </p:spPr>
+        <p:txBody>
+          <a:bodyPr anchor="ctr" wrap="square" rtlCol="false" tIns="0" lIns="0" bIns="0" rIns="0">
+            <a:noAutofit/>
+          </a:bodyPr>
+          <a:lstStyle/>
+          <a:p>
+            <a:pPr algn="ctr">
+              <a:lnSpc>
+                <a:spcPct val="100000"/>
+              </a:lnSpc>
+              <a:spcAft>
+                <a:spcPts val="0"/>
+              </a:spcAft>
+            </a:pPr>
+            <a:r>
+              <a:rPr lang="uk-UA" sz="2600" b="1">
+                <a:solidFill>
+                  <a:srgbClr val="0E4D38"/>
+                </a:solidFill>
+                <a:latin typeface="Fira Sans Extra Condensed Bold"/>
+                <a:ea typeface="Fira Sans Extra Condensed Bold"/>
+                <a:cs typeface="Fira Sans Extra Condensed Bold"/>
+                <a:sym typeface="Fira Sans Extra Condensed Bold"/>
+              </a:rPr>
+              <a:t>Дві окремі угоди з одним центром: усі запити йдуть через Lviv Croissants</a:t>
+            </a:r>
+          </a:p>
+        </p:txBody>
+      </p:sp>
     </p:spTree>
   </p:cSld>
   <p:clrMapOvr>
@@ -24010,6 +24426,421 @@
           </a:p>
         </p:txBody>
       </p:sp>
+      <p:sp>
+        <p:nvSpPr>
+          <p:cNvPr name="Card 3" id="3"/>
+          <p:cNvSpPr/>
+          <p:nvPr/>
+        </p:nvSpPr>
+        <p:spPr>
+          <a:xfrm>
+            <a:off x="1219200" y="2200000"/>
+            <a:ext cx="7774800" cy="6200000"/>
+          </a:xfrm>
+          <a:prstGeom prst="roundRect">
+            <a:avLst>
+              <a:gd name="adj" fmla="val 7000"/>
+            </a:avLst>
+          </a:prstGeom>
+          <a:solidFill>
+            <a:srgbClr val="135F45"/>
+          </a:solidFill>
+        </p:spPr>
+      </p:sp>
+      <p:sp>
+        <p:nvSpPr>
+          <p:cNvPr name="TextBox 4" id="4"/>
+          <p:cNvSpPr txBox="true"/>
+          <p:nvPr/>
+        </p:nvSpPr>
+        <p:spPr>
+          <a:xfrm>
+            <a:off x="1519200" y="2450000"/>
+            <a:ext cx="7174800" cy="700000"/>
+          </a:xfrm>
+          <a:prstGeom prst="rect">
+            <a:avLst/>
+          </a:prstGeom>
+        </p:spPr>
+        <p:txBody>
+          <a:bodyPr anchor="t" wrap="square" rtlCol="false" tIns="0" lIns="0" bIns="0" rIns="0">
+            <a:noAutofit/>
+          </a:bodyPr>
+          <a:lstStyle/>
+          <a:p>
+            <a:pPr algn="l">
+              <a:lnSpc>
+                <a:spcPct val="100000"/>
+              </a:lnSpc>
+              <a:spcAft>
+                <a:spcPts val="0"/>
+              </a:spcAft>
+            </a:pPr>
+            <a:r>
+              <a:rPr lang="uk-UA" sz="2800" b="1">
+                <a:solidFill>
+                  <a:srgbClr val="F4B6C8"/>
+                </a:solidFill>
+                <a:latin typeface="Fira Sans Extra Condensed Bold"/>
+                <a:ea typeface="Fira Sans Extra Condensed Bold"/>
+                <a:cs typeface="Fira Sans Extra Condensed Bold"/>
+                <a:sym typeface="Fira Sans Extra Condensed Bold"/>
+              </a:rPr>
+              <a:t>Договір 1: інвестор</a:t>
+            </a:r>
+          </a:p>
+        </p:txBody>
+      </p:sp>
+      <p:sp>
+        <p:nvSpPr>
+          <p:cNvPr name="TextBox 5" id="5"/>
+          <p:cNvSpPr txBox="true"/>
+          <p:nvPr/>
+        </p:nvSpPr>
+        <p:spPr>
+          <a:xfrm>
+            <a:off x="1519200" y="3350000"/>
+            <a:ext cx="7174800" cy="4900000"/>
+          </a:xfrm>
+          <a:prstGeom prst="rect">
+            <a:avLst/>
+          </a:prstGeom>
+        </p:spPr>
+        <p:txBody>
+          <a:bodyPr anchor="t" wrap="square" rtlCol="false" tIns="0" lIns="0" bIns="0" rIns="0">
+            <a:noAutofit/>
+          </a:bodyPr>
+          <a:lstStyle/>
+          <a:p>
+            <a:pPr algn="l">
+              <a:lnSpc>
+                <a:spcPct val="100000"/>
+              </a:lnSpc>
+              <a:spcAft>
+                <a:spcPts val="1600"/>
+              </a:spcAft>
+            </a:pPr>
+            <a:r>
+              <a:rPr lang="uk-UA" sz="2400" b="0">
+                <a:solidFill>
+                  <a:srgbClr val="FBFBF8"/>
+                </a:solidFill>
+                <a:latin typeface="Fira Sans Extra Condensed"/>
+                <a:ea typeface="Fira Sans Extra Condensed"/>
+                <a:cs typeface="Fira Sans Extra Condensed"/>
+                <a:sym typeface="Fira Sans Extra Condensed"/>
+              </a:rPr>
+              <a:t>— Обов'язок: профінансувати свою частину вкладень</a:t>
+            </a:r>
+          </a:p>
+          <a:p>
+            <a:pPr algn="l">
+              <a:lnSpc>
+                <a:spcPct val="100000"/>
+              </a:lnSpc>
+              <a:spcAft>
+                <a:spcPts val="1600"/>
+              </a:spcAft>
+            </a:pPr>
+            <a:r>
+              <a:rPr lang="uk-UA" sz="2400" b="0">
+                <a:solidFill>
+                  <a:srgbClr val="FBFBF8"/>
+                </a:solidFill>
+                <a:latin typeface="Fira Sans Extra Condensed"/>
+                <a:ea typeface="Fira Sans Extra Condensed"/>
+                <a:cs typeface="Fira Sans Extra Condensed"/>
+                <a:sym typeface="Fira Sans Extra Condensed"/>
+              </a:rPr>
+              <a:t>— Обов'язок: оренда, ліцензії та дозволи щодо приміщення</a:t>
+            </a:r>
+          </a:p>
+          <a:p>
+            <a:pPr algn="l">
+              <a:lnSpc>
+                <a:spcPct val="100000"/>
+              </a:lnSpc>
+              <a:spcAft>
+                <a:spcPts val="1600"/>
+              </a:spcAft>
+            </a:pPr>
+            <a:r>
+              <a:rPr lang="uk-UA" sz="2400" b="0">
+                <a:solidFill>
+                  <a:srgbClr val="FBFBF8"/>
+                </a:solidFill>
+                <a:latin typeface="Fira Sans Extra Condensed"/>
+                <a:ea typeface="Fira Sans Extra Condensed"/>
+                <a:cs typeface="Fira Sans Extra Condensed"/>
+                <a:sym typeface="Fira Sans Extra Condensed"/>
+              </a:rPr>
+              <a:t>— Право: частка прибутку і звіти про результати</a:t>
+            </a:r>
+          </a:p>
+          <a:p>
+            <a:pPr algn="l">
+              <a:lnSpc>
+                <a:spcPct val="100000"/>
+              </a:lnSpc>
+              <a:spcAft>
+                <a:spcPts val="1600"/>
+              </a:spcAft>
+            </a:pPr>
+            <a:r>
+              <a:rPr lang="uk-UA" sz="2400" b="0">
+                <a:solidFill>
+                  <a:srgbClr val="FBFBF8"/>
+                </a:solidFill>
+                <a:latin typeface="Fira Sans Extra Condensed"/>
+                <a:ea typeface="Fira Sans Extra Condensed"/>
+                <a:cs typeface="Fira Sans Extra Condensed"/>
+                <a:sym typeface="Fira Sans Extra Condensed"/>
+              </a:rPr>
+              <a:t>— Право: розглядати запити на дофінансування й вагомі зміни</a:t>
+            </a:r>
+          </a:p>
+        </p:txBody>
+      </p:sp>
+      <p:sp>
+        <p:nvSpPr>
+          <p:cNvPr name="Card 6" id="6"/>
+          <p:cNvSpPr/>
+          <p:nvPr/>
+        </p:nvSpPr>
+        <p:spPr>
+          <a:xfrm>
+            <a:off x="9294000" y="2200000"/>
+            <a:ext cx="7774800" cy="6200000"/>
+          </a:xfrm>
+          <a:prstGeom prst="roundRect">
+            <a:avLst>
+              <a:gd name="adj" fmla="val 7000"/>
+            </a:avLst>
+          </a:prstGeom>
+          <a:solidFill>
+            <a:srgbClr val="135F45"/>
+          </a:solidFill>
+        </p:spPr>
+      </p:sp>
+      <p:sp>
+        <p:nvSpPr>
+          <p:cNvPr name="TextBox 7" id="7"/>
+          <p:cNvSpPr txBox="true"/>
+          <p:nvPr/>
+        </p:nvSpPr>
+        <p:spPr>
+          <a:xfrm>
+            <a:off x="9594000" y="2450000"/>
+            <a:ext cx="7174800" cy="700000"/>
+          </a:xfrm>
+          <a:prstGeom prst="rect">
+            <a:avLst/>
+          </a:prstGeom>
+        </p:spPr>
+        <p:txBody>
+          <a:bodyPr anchor="t" wrap="square" rtlCol="false" tIns="0" lIns="0" bIns="0" rIns="0">
+            <a:noAutofit/>
+          </a:bodyPr>
+          <a:lstStyle/>
+          <a:p>
+            <a:pPr algn="l">
+              <a:lnSpc>
+                <a:spcPct val="100000"/>
+              </a:lnSpc>
+              <a:spcAft>
+                <a:spcPts val="0"/>
+              </a:spcAft>
+            </a:pPr>
+            <a:r>
+              <a:rPr lang="uk-UA" sz="2800" b="1">
+                <a:solidFill>
+                  <a:srgbClr val="F4B6C8"/>
+                </a:solidFill>
+                <a:latin typeface="Fira Sans Extra Condensed Bold"/>
+                <a:ea typeface="Fira Sans Extra Condensed Bold"/>
+                <a:cs typeface="Fira Sans Extra Condensed Bold"/>
+                <a:sym typeface="Fira Sans Extra Condensed Bold"/>
+              </a:rPr>
+              <a:t>Договір 2: оператор</a:t>
+            </a:r>
+          </a:p>
+        </p:txBody>
+      </p:sp>
+      <p:sp>
+        <p:nvSpPr>
+          <p:cNvPr name="TextBox 8" id="8"/>
+          <p:cNvSpPr txBox="true"/>
+          <p:nvPr/>
+        </p:nvSpPr>
+        <p:spPr>
+          <a:xfrm>
+            <a:off x="9594000" y="3350000"/>
+            <a:ext cx="7174800" cy="4900000"/>
+          </a:xfrm>
+          <a:prstGeom prst="rect">
+            <a:avLst/>
+          </a:prstGeom>
+        </p:spPr>
+        <p:txBody>
+          <a:bodyPr anchor="t" wrap="square" rtlCol="false" tIns="0" lIns="0" bIns="0" rIns="0">
+            <a:noAutofit/>
+          </a:bodyPr>
+          <a:lstStyle/>
+          <a:p>
+            <a:pPr algn="l">
+              <a:lnSpc>
+                <a:spcPct val="100000"/>
+              </a:lnSpc>
+              <a:spcAft>
+                <a:spcPts val="1600"/>
+              </a:spcAft>
+            </a:pPr>
+            <a:r>
+              <a:rPr lang="uk-UA" sz="2400" b="0">
+                <a:solidFill>
+                  <a:srgbClr val="FBFBF8"/>
+                </a:solidFill>
+                <a:latin typeface="Fira Sans Extra Condensed"/>
+                <a:ea typeface="Fira Sans Extra Condensed"/>
+                <a:cs typeface="Fira Sans Extra Condensed"/>
+                <a:sym typeface="Fira Sans Extra Condensed"/>
+              </a:rPr>
+              <a:t>— Обов'язок: профінансувати свою частину, укомплектувати команду</a:t>
+            </a:r>
+          </a:p>
+          <a:p>
+            <a:pPr algn="l">
+              <a:lnSpc>
+                <a:spcPct val="100000"/>
+              </a:lnSpc>
+              <a:spcAft>
+                <a:spcPts val="1600"/>
+              </a:spcAft>
+            </a:pPr>
+            <a:r>
+              <a:rPr lang="uk-UA" sz="2400" b="0">
+                <a:solidFill>
+                  <a:srgbClr val="FBFBF8"/>
+                </a:solidFill>
+                <a:latin typeface="Fira Sans Extra Condensed"/>
+                <a:ea typeface="Fira Sans Extra Condensed"/>
+                <a:cs typeface="Fira Sans Extra Condensed"/>
+                <a:sym typeface="Fira Sans Extra Condensed"/>
+              </a:rPr>
+              <a:t>— Обов'язок: працювати за Стандартами, вести облік в Odoo</a:t>
+            </a:r>
+          </a:p>
+          <a:p>
+            <a:pPr algn="l">
+              <a:lnSpc>
+                <a:spcPct val="100000"/>
+              </a:lnSpc>
+              <a:spcAft>
+                <a:spcPts val="1600"/>
+              </a:spcAft>
+            </a:pPr>
+            <a:r>
+              <a:rPr lang="uk-UA" sz="2400" b="0">
+                <a:solidFill>
+                  <a:srgbClr val="FBFBF8"/>
+                </a:solidFill>
+                <a:latin typeface="Fira Sans Extra Condensed"/>
+                <a:ea typeface="Fira Sans Extra Condensed"/>
+                <a:cs typeface="Fira Sans Extra Condensed"/>
+                <a:sym typeface="Fira Sans Extra Condensed"/>
+              </a:rPr>
+              <a:t>— Право: бренд, навчання, підтримка команди HQ</a:t>
+            </a:r>
+          </a:p>
+          <a:p>
+            <a:pPr algn="l">
+              <a:lnSpc>
+                <a:spcPct val="100000"/>
+              </a:lnSpc>
+              <a:spcAft>
+                <a:spcPts val="1600"/>
+              </a:spcAft>
+            </a:pPr>
+            <a:r>
+              <a:rPr lang="uk-UA" sz="2400" b="0">
+                <a:solidFill>
+                  <a:srgbClr val="FBFBF8"/>
+                </a:solidFill>
+                <a:latin typeface="Fira Sans Extra Condensed"/>
+                <a:ea typeface="Fira Sans Extra Condensed"/>
+                <a:cs typeface="Fira Sans Extra Condensed"/>
+                <a:sym typeface="Fira Sans Extra Condensed"/>
+              </a:rPr>
+              <a:t>— Право: частка прибутку за правилом розподілу</a:t>
+            </a:r>
+          </a:p>
+        </p:txBody>
+      </p:sp>
+      <p:sp>
+        <p:nvSpPr>
+          <p:cNvPr name="Note 9" id="9"/>
+          <p:cNvSpPr/>
+          <p:nvPr/>
+        </p:nvSpPr>
+        <p:spPr>
+          <a:xfrm>
+            <a:off x="1219200" y="8750000"/>
+            <a:ext cx="15849600" cy="1000000"/>
+          </a:xfrm>
+          <a:prstGeom prst="roundRect">
+            <a:avLst>
+              <a:gd name="adj" fmla="val 7000"/>
+            </a:avLst>
+          </a:prstGeom>
+          <a:solidFill>
+            <a:srgbClr val="F4B6C8"/>
+          </a:solidFill>
+        </p:spPr>
+      </p:sp>
+      <p:sp>
+        <p:nvSpPr>
+          <p:cNvPr name="TextBox 10" id="10"/>
+          <p:cNvSpPr txBox="true"/>
+          <p:nvPr/>
+        </p:nvSpPr>
+        <p:spPr>
+          <a:xfrm>
+            <a:off x="1500000" y="8750000"/>
+            <a:ext cx="15286000" cy="1000000"/>
+          </a:xfrm>
+          <a:prstGeom prst="rect">
+            <a:avLst/>
+          </a:prstGeom>
+        </p:spPr>
+        <p:txBody>
+          <a:bodyPr anchor="ctr" wrap="square" rtlCol="false" tIns="0" lIns="0" bIns="0" rIns="0">
+            <a:noAutofit/>
+          </a:bodyPr>
+          <a:lstStyle/>
+          <a:p>
+            <a:pPr algn="ctr">
+              <a:lnSpc>
+                <a:spcPct val="100000"/>
+              </a:lnSpc>
+              <a:spcAft>
+                <a:spcPts val="0"/>
+              </a:spcAft>
+            </a:pPr>
+            <a:r>
+              <a:rPr lang="uk-UA" sz="2600" b="1">
+                <a:solidFill>
+                  <a:srgbClr val="0E4D38"/>
+                </a:solidFill>
+                <a:latin typeface="Fira Sans Extra Condensed Bold"/>
+                <a:ea typeface="Fira Sans Extra Condensed Bold"/>
+                <a:cs typeface="Fira Sans Extra Condensed Bold"/>
+                <a:sym typeface="Fira Sans Extra Condensed Bold"/>
+              </a:rPr>
+              <a:t>Повні переліки до і після відкриття: у «Зонах відповідальності»</a:t>
+            </a:r>
+          </a:p>
+        </p:txBody>
+      </p:sp>
     </p:spTree>
   </p:cSld>
   <p:clrMapOvr>
@@ -24098,6 +24929,421 @@
           </a:p>
         </p:txBody>
       </p:sp>
+      <p:sp>
+        <p:nvSpPr>
+          <p:cNvPr name="Card 3" id="3"/>
+          <p:cNvSpPr/>
+          <p:nvPr/>
+        </p:nvSpPr>
+        <p:spPr>
+          <a:xfrm>
+            <a:off x="1219200" y="2200000"/>
+            <a:ext cx="7774800" cy="6200000"/>
+          </a:xfrm>
+          <a:prstGeom prst="roundRect">
+            <a:avLst>
+              <a:gd name="adj" fmla="val 7000"/>
+            </a:avLst>
+          </a:prstGeom>
+          <a:solidFill>
+            <a:srgbClr val="135F45"/>
+          </a:solidFill>
+        </p:spPr>
+      </p:sp>
+      <p:sp>
+        <p:nvSpPr>
+          <p:cNvPr name="TextBox 4" id="4"/>
+          <p:cNvSpPr txBox="true"/>
+          <p:nvPr/>
+        </p:nvSpPr>
+        <p:spPr>
+          <a:xfrm>
+            <a:off x="1519200" y="2450000"/>
+            <a:ext cx="7174800" cy="700000"/>
+          </a:xfrm>
+          <a:prstGeom prst="rect">
+            <a:avLst/>
+          </a:prstGeom>
+        </p:spPr>
+        <p:txBody>
+          <a:bodyPr anchor="t" wrap="square" rtlCol="false" tIns="0" lIns="0" bIns="0" rIns="0">
+            <a:noAutofit/>
+          </a:bodyPr>
+          <a:lstStyle/>
+          <a:p>
+            <a:pPr algn="l">
+              <a:lnSpc>
+                <a:spcPct val="100000"/>
+              </a:lnSpc>
+              <a:spcAft>
+                <a:spcPts val="0"/>
+              </a:spcAft>
+            </a:pPr>
+            <a:r>
+              <a:rPr lang="uk-UA" sz="2800" b="1">
+                <a:solidFill>
+                  <a:srgbClr val="F4B6C8"/>
+                </a:solidFill>
+                <a:latin typeface="Fira Sans Extra Condensed Bold"/>
+                <a:ea typeface="Fira Sans Extra Condensed Bold"/>
+                <a:cs typeface="Fira Sans Extra Condensed Bold"/>
+                <a:sym typeface="Fira Sans Extra Condensed Bold"/>
+              </a:rPr>
+              <a:t>Договір 1: інвестор</a:t>
+            </a:r>
+          </a:p>
+        </p:txBody>
+      </p:sp>
+      <p:sp>
+        <p:nvSpPr>
+          <p:cNvPr name="TextBox 5" id="5"/>
+          <p:cNvSpPr txBox="true"/>
+          <p:nvPr/>
+        </p:nvSpPr>
+        <p:spPr>
+          <a:xfrm>
+            <a:off x="1519200" y="3350000"/>
+            <a:ext cx="7174800" cy="4900000"/>
+          </a:xfrm>
+          <a:prstGeom prst="rect">
+            <a:avLst/>
+          </a:prstGeom>
+        </p:spPr>
+        <p:txBody>
+          <a:bodyPr anchor="t" wrap="square" rtlCol="false" tIns="0" lIns="0" bIns="0" rIns="0">
+            <a:noAutofit/>
+          </a:bodyPr>
+          <a:lstStyle/>
+          <a:p>
+            <a:pPr algn="l">
+              <a:lnSpc>
+                <a:spcPct val="100000"/>
+              </a:lnSpc>
+              <a:spcAft>
+                <a:spcPts val="1600"/>
+              </a:spcAft>
+            </a:pPr>
+            <a:r>
+              <a:rPr lang="uk-UA" sz="2400" b="0">
+                <a:solidFill>
+                  <a:srgbClr val="FBFBF8"/>
+                </a:solidFill>
+                <a:latin typeface="Fira Sans Extra Condensed"/>
+                <a:ea typeface="Fira Sans Extra Condensed"/>
+                <a:cs typeface="Fira Sans Extra Condensed"/>
+                <a:sym typeface="Fira Sans Extra Condensed"/>
+              </a:rPr>
+              <a:t>— Вклад інвестора: ~166 тис. €</a:t>
+            </a:r>
+          </a:p>
+          <a:p>
+            <a:pPr algn="l">
+              <a:lnSpc>
+                <a:spcPct val="100000"/>
+              </a:lnSpc>
+              <a:spcAft>
+                <a:spcPts val="1600"/>
+              </a:spcAft>
+            </a:pPr>
+            <a:r>
+              <a:rPr lang="uk-UA" sz="2400" b="0">
+                <a:solidFill>
+                  <a:srgbClr val="FBFBF8"/>
+                </a:solidFill>
+                <a:latin typeface="Fira Sans Extra Condensed"/>
+                <a:ea typeface="Fira Sans Extra Condensed"/>
+                <a:cs typeface="Fira Sans Extra Condensed"/>
+                <a:sym typeface="Fira Sans Extra Condensed"/>
+              </a:rPr>
+              <a:t>— Прибуток до 2 000 €: 1 000 € інвестору, решта оператору</a:t>
+            </a:r>
+          </a:p>
+          <a:p>
+            <a:pPr algn="l">
+              <a:lnSpc>
+                <a:spcPct val="100000"/>
+              </a:lnSpc>
+              <a:spcAft>
+                <a:spcPts val="1600"/>
+              </a:spcAft>
+            </a:pPr>
+            <a:r>
+              <a:rPr lang="uk-UA" sz="2400" b="0">
+                <a:solidFill>
+                  <a:srgbClr val="FBFBF8"/>
+                </a:solidFill>
+                <a:latin typeface="Fira Sans Extra Condensed"/>
+                <a:ea typeface="Fira Sans Extra Condensed"/>
+                <a:cs typeface="Fira Sans Extra Condensed"/>
+                <a:sym typeface="Fira Sans Extra Condensed"/>
+              </a:rPr>
+              <a:t>— Прибуток від 2 000 €: 50/50</a:t>
+            </a:r>
+          </a:p>
+          <a:p>
+            <a:pPr algn="l">
+              <a:lnSpc>
+                <a:spcPct val="100000"/>
+              </a:lnSpc>
+              <a:spcAft>
+                <a:spcPts val="1600"/>
+              </a:spcAft>
+            </a:pPr>
+            <a:r>
+              <a:rPr lang="uk-UA" sz="2400" b="0">
+                <a:solidFill>
+                  <a:srgbClr val="FBFBF8"/>
+                </a:solidFill>
+                <a:latin typeface="Fira Sans Extra Condensed"/>
+                <a:ea typeface="Fira Sans Extra Condensed"/>
+                <a:cs typeface="Fira Sans Extra Condensed"/>
+                <a:sym typeface="Fira Sans Extra Condensed"/>
+              </a:rPr>
+              <a:t>— Націнка за оренду 2 500–3 000 € (уточнити: разово чи щомісяця)</a:t>
+            </a:r>
+          </a:p>
+        </p:txBody>
+      </p:sp>
+      <p:sp>
+        <p:nvSpPr>
+          <p:cNvPr name="Card 6" id="6"/>
+          <p:cNvSpPr/>
+          <p:nvPr/>
+        </p:nvSpPr>
+        <p:spPr>
+          <a:xfrm>
+            <a:off x="9294000" y="2200000"/>
+            <a:ext cx="7774800" cy="6200000"/>
+          </a:xfrm>
+          <a:prstGeom prst="roundRect">
+            <a:avLst>
+              <a:gd name="adj" fmla="val 7000"/>
+            </a:avLst>
+          </a:prstGeom>
+          <a:solidFill>
+            <a:srgbClr val="135F45"/>
+          </a:solidFill>
+        </p:spPr>
+      </p:sp>
+      <p:sp>
+        <p:nvSpPr>
+          <p:cNvPr name="TextBox 7" id="7"/>
+          <p:cNvSpPr txBox="true"/>
+          <p:nvPr/>
+        </p:nvSpPr>
+        <p:spPr>
+          <a:xfrm>
+            <a:off x="9594000" y="2450000"/>
+            <a:ext cx="7174800" cy="700000"/>
+          </a:xfrm>
+          <a:prstGeom prst="rect">
+            <a:avLst/>
+          </a:prstGeom>
+        </p:spPr>
+        <p:txBody>
+          <a:bodyPr anchor="t" wrap="square" rtlCol="false" tIns="0" lIns="0" bIns="0" rIns="0">
+            <a:noAutofit/>
+          </a:bodyPr>
+          <a:lstStyle/>
+          <a:p>
+            <a:pPr algn="l">
+              <a:lnSpc>
+                <a:spcPct val="100000"/>
+              </a:lnSpc>
+              <a:spcAft>
+                <a:spcPts val="0"/>
+              </a:spcAft>
+            </a:pPr>
+            <a:r>
+              <a:rPr lang="uk-UA" sz="2800" b="1">
+                <a:solidFill>
+                  <a:srgbClr val="F4B6C8"/>
+                </a:solidFill>
+                <a:latin typeface="Fira Sans Extra Condensed Bold"/>
+                <a:ea typeface="Fira Sans Extra Condensed Bold"/>
+                <a:cs typeface="Fira Sans Extra Condensed Bold"/>
+                <a:sym typeface="Fira Sans Extra Condensed Bold"/>
+              </a:rPr>
+              <a:t>Договір 2: оператор</a:t>
+            </a:r>
+          </a:p>
+        </p:txBody>
+      </p:sp>
+      <p:sp>
+        <p:nvSpPr>
+          <p:cNvPr name="TextBox 8" id="8"/>
+          <p:cNvSpPr txBox="true"/>
+          <p:nvPr/>
+        </p:nvSpPr>
+        <p:spPr>
+          <a:xfrm>
+            <a:off x="9594000" y="3350000"/>
+            <a:ext cx="7174800" cy="4900000"/>
+          </a:xfrm>
+          <a:prstGeom prst="rect">
+            <a:avLst/>
+          </a:prstGeom>
+        </p:spPr>
+        <p:txBody>
+          <a:bodyPr anchor="t" wrap="square" rtlCol="false" tIns="0" lIns="0" bIns="0" rIns="0">
+            <a:noAutofit/>
+          </a:bodyPr>
+          <a:lstStyle/>
+          <a:p>
+            <a:pPr algn="l">
+              <a:lnSpc>
+                <a:spcPct val="100000"/>
+              </a:lnSpc>
+              <a:spcAft>
+                <a:spcPts val="1600"/>
+              </a:spcAft>
+            </a:pPr>
+            <a:r>
+              <a:rPr lang="uk-UA" sz="2400" b="0">
+                <a:solidFill>
+                  <a:srgbClr val="FBFBF8"/>
+                </a:solidFill>
+                <a:latin typeface="Fira Sans Extra Condensed"/>
+                <a:ea typeface="Fira Sans Extra Condensed"/>
+                <a:cs typeface="Fira Sans Extra Condensed"/>
+                <a:sym typeface="Fira Sans Extra Condensed"/>
+              </a:rPr>
+              <a:t>— Вклад оператора: ~65 тис. €</a:t>
+            </a:r>
+          </a:p>
+          <a:p>
+            <a:pPr algn="l">
+              <a:lnSpc>
+                <a:spcPct val="100000"/>
+              </a:lnSpc>
+              <a:spcAft>
+                <a:spcPts val="1600"/>
+              </a:spcAft>
+            </a:pPr>
+            <a:r>
+              <a:rPr lang="uk-UA" sz="2400" b="0">
+                <a:solidFill>
+                  <a:srgbClr val="FBFBF8"/>
+                </a:solidFill>
+                <a:latin typeface="Fira Sans Extra Condensed"/>
+                <a:ea typeface="Fira Sans Extra Condensed"/>
+                <a:cs typeface="Fira Sans Extra Condensed"/>
+                <a:sym typeface="Fira Sans Extra Condensed"/>
+              </a:rPr>
+              <a:t>— Франчайзеру: 3% чистого виторгу + 1% маркетинговий збір</a:t>
+            </a:r>
+          </a:p>
+          <a:p>
+            <a:pPr algn="l">
+              <a:lnSpc>
+                <a:spcPct val="100000"/>
+              </a:lnSpc>
+              <a:spcAft>
+                <a:spcPts val="1600"/>
+              </a:spcAft>
+            </a:pPr>
+            <a:r>
+              <a:rPr lang="uk-UA" sz="2400" b="0">
+                <a:solidFill>
+                  <a:srgbClr val="FBFBF8"/>
+                </a:solidFill>
+                <a:latin typeface="Fira Sans Extra Condensed"/>
+                <a:ea typeface="Fira Sans Extra Condensed"/>
+                <a:cs typeface="Fira Sans Extra Condensed"/>
+                <a:sym typeface="Fira Sans Extra Condensed"/>
+              </a:rPr>
+              <a:t>— Оператор: 50% прибутку від 2 000 €, 0–1 000 € при меншому</a:t>
+            </a:r>
+          </a:p>
+          <a:p>
+            <a:pPr algn="l">
+              <a:lnSpc>
+                <a:spcPct val="100000"/>
+              </a:lnSpc>
+              <a:spcAft>
+                <a:spcPts val="1600"/>
+              </a:spcAft>
+            </a:pPr>
+            <a:r>
+              <a:rPr lang="uk-UA" sz="2400" b="0">
+                <a:solidFill>
+                  <a:srgbClr val="FBFBF8"/>
+                </a:solidFill>
+                <a:latin typeface="Fira Sans Extra Condensed"/>
+                <a:ea typeface="Fira Sans Extra Condensed"/>
+                <a:cs typeface="Fira Sans Extra Condensed"/>
+                <a:sym typeface="Fira Sans Extra Condensed"/>
+              </a:rPr>
+              <a:t>— Порядок, строки й перерахунок виплат: до деталізації</a:t>
+            </a:r>
+          </a:p>
+        </p:txBody>
+      </p:sp>
+      <p:sp>
+        <p:nvSpPr>
+          <p:cNvPr name="Note 9" id="9"/>
+          <p:cNvSpPr/>
+          <p:nvPr/>
+        </p:nvSpPr>
+        <p:spPr>
+          <a:xfrm>
+            <a:off x="1219200" y="8750000"/>
+            <a:ext cx="15849600" cy="1000000"/>
+          </a:xfrm>
+          <a:prstGeom prst="roundRect">
+            <a:avLst>
+              <a:gd name="adj" fmla="val 7000"/>
+            </a:avLst>
+          </a:prstGeom>
+          <a:solidFill>
+            <a:srgbClr val="F4B6C8"/>
+          </a:solidFill>
+        </p:spPr>
+      </p:sp>
+      <p:sp>
+        <p:nvSpPr>
+          <p:cNvPr name="TextBox 10" id="10"/>
+          <p:cNvSpPr txBox="true"/>
+          <p:nvPr/>
+        </p:nvSpPr>
+        <p:spPr>
+          <a:xfrm>
+            <a:off x="1500000" y="8750000"/>
+            <a:ext cx="15286000" cy="1000000"/>
+          </a:xfrm>
+          <a:prstGeom prst="rect">
+            <a:avLst/>
+          </a:prstGeom>
+        </p:spPr>
+        <p:txBody>
+          <a:bodyPr anchor="ctr" wrap="square" rtlCol="false" tIns="0" lIns="0" bIns="0" rIns="0">
+            <a:noAutofit/>
+          </a:bodyPr>
+          <a:lstStyle/>
+          <a:p>
+            <a:pPr algn="ctr">
+              <a:lnSpc>
+                <a:spcPct val="100000"/>
+              </a:lnSpc>
+              <a:spcAft>
+                <a:spcPts val="0"/>
+              </a:spcAft>
+            </a:pPr>
+            <a:r>
+              <a:rPr lang="uk-UA" sz="2600" b="1">
+                <a:solidFill>
+                  <a:srgbClr val="0E4D38"/>
+                </a:solidFill>
+                <a:latin typeface="Fira Sans Extra Condensed Bold"/>
+                <a:ea typeface="Fira Sans Extra Condensed Bold"/>
+                <a:cs typeface="Fira Sans Extra Condensed Bold"/>
+                <a:sym typeface="Fira Sans Extra Condensed Bold"/>
+              </a:rPr>
+              <a:t>Прописати, що саме вважається прибутком: від цього залежить розподіл</a:t>
+            </a:r>
+          </a:p>
+        </p:txBody>
+      </p:sp>
     </p:spTree>
   </p:cSld>
   <p:clrMapOvr>
@@ -24186,6 +25432,377 @@
           </a:p>
         </p:txBody>
       </p:sp>
+      <p:sp>
+        <p:nvSpPr>
+          <p:cNvPr name="Card 3" id="3"/>
+          <p:cNvSpPr/>
+          <p:nvPr/>
+        </p:nvSpPr>
+        <p:spPr>
+          <a:xfrm>
+            <a:off x="1219200" y="2200000"/>
+            <a:ext cx="7774800" cy="6200000"/>
+          </a:xfrm>
+          <a:prstGeom prst="roundRect">
+            <a:avLst>
+              <a:gd name="adj" fmla="val 7000"/>
+            </a:avLst>
+          </a:prstGeom>
+          <a:solidFill>
+            <a:srgbClr val="135F45"/>
+          </a:solidFill>
+        </p:spPr>
+      </p:sp>
+      <p:sp>
+        <p:nvSpPr>
+          <p:cNvPr name="TextBox 4" id="4"/>
+          <p:cNvSpPr txBox="true"/>
+          <p:nvPr/>
+        </p:nvSpPr>
+        <p:spPr>
+          <a:xfrm>
+            <a:off x="1519200" y="2450000"/>
+            <a:ext cx="7174800" cy="700000"/>
+          </a:xfrm>
+          <a:prstGeom prst="rect">
+            <a:avLst/>
+          </a:prstGeom>
+        </p:spPr>
+        <p:txBody>
+          <a:bodyPr anchor="t" wrap="square" rtlCol="false" tIns="0" lIns="0" bIns="0" rIns="0">
+            <a:noAutofit/>
+          </a:bodyPr>
+          <a:lstStyle/>
+          <a:p>
+            <a:pPr algn="l">
+              <a:lnSpc>
+                <a:spcPct val="100000"/>
+              </a:lnSpc>
+              <a:spcAft>
+                <a:spcPts val="0"/>
+              </a:spcAft>
+            </a:pPr>
+            <a:r>
+              <a:rPr lang="uk-UA" sz="2800" b="1">
+                <a:solidFill>
+                  <a:srgbClr val="F4B6C8"/>
+                </a:solidFill>
+                <a:latin typeface="Fira Sans Extra Condensed Bold"/>
+                <a:ea typeface="Fira Sans Extra Condensed Bold"/>
+                <a:cs typeface="Fira Sans Extra Condensed Bold"/>
+                <a:sym typeface="Fira Sans Extra Condensed Bold"/>
+              </a:rPr>
+              <a:t>Договір 1: інвестор</a:t>
+            </a:r>
+          </a:p>
+        </p:txBody>
+      </p:sp>
+      <p:sp>
+        <p:nvSpPr>
+          <p:cNvPr name="TextBox 5" id="5"/>
+          <p:cNvSpPr txBox="true"/>
+          <p:nvPr/>
+        </p:nvSpPr>
+        <p:spPr>
+          <a:xfrm>
+            <a:off x="1519200" y="3350000"/>
+            <a:ext cx="7174800" cy="4900000"/>
+          </a:xfrm>
+          <a:prstGeom prst="rect">
+            <a:avLst/>
+          </a:prstGeom>
+        </p:spPr>
+        <p:txBody>
+          <a:bodyPr anchor="t" wrap="square" rtlCol="false" tIns="0" lIns="0" bIns="0" rIns="0">
+            <a:noAutofit/>
+          </a:bodyPr>
+          <a:lstStyle/>
+          <a:p>
+            <a:pPr algn="l">
+              <a:lnSpc>
+                <a:spcPct val="100000"/>
+              </a:lnSpc>
+              <a:spcAft>
+                <a:spcPts val="1600"/>
+              </a:spcAft>
+            </a:pPr>
+            <a:r>
+              <a:rPr lang="uk-UA" sz="2400" b="0">
+                <a:solidFill>
+                  <a:srgbClr val="FBFBF8"/>
+                </a:solidFill>
+                <a:latin typeface="Fira Sans Extra Condensed"/>
+                <a:ea typeface="Fira Sans Extra Condensed"/>
+                <a:cs typeface="Fira Sans Extra Condensed"/>
+                <a:sym typeface="Fira Sans Extra Condensed"/>
+              </a:rPr>
+              <a:t>— Інвестор не отримує прав на бренд і рецептури</a:t>
+            </a:r>
+          </a:p>
+          <a:p>
+            <a:pPr algn="l">
+              <a:lnSpc>
+                <a:spcPct val="100000"/>
+              </a:lnSpc>
+              <a:spcAft>
+                <a:spcPts val="1600"/>
+              </a:spcAft>
+            </a:pPr>
+            <a:r>
+              <a:rPr lang="uk-UA" sz="2400" b="0">
+                <a:solidFill>
+                  <a:srgbClr val="FBFBF8"/>
+                </a:solidFill>
+                <a:latin typeface="Fira Sans Extra Condensed"/>
+                <a:ea typeface="Fira Sans Extra Condensed"/>
+                <a:cs typeface="Fira Sans Extra Condensed"/>
+                <a:sym typeface="Fira Sans Extra Condensed"/>
+              </a:rPr>
+              <a:t>— Бренд на пекарні використовується лише в межах договору</a:t>
+            </a:r>
+          </a:p>
+        </p:txBody>
+      </p:sp>
+      <p:sp>
+        <p:nvSpPr>
+          <p:cNvPr name="Card 6" id="6"/>
+          <p:cNvSpPr/>
+          <p:nvPr/>
+        </p:nvSpPr>
+        <p:spPr>
+          <a:xfrm>
+            <a:off x="9294000" y="2200000"/>
+            <a:ext cx="7774800" cy="6200000"/>
+          </a:xfrm>
+          <a:prstGeom prst="roundRect">
+            <a:avLst>
+              <a:gd name="adj" fmla="val 7000"/>
+            </a:avLst>
+          </a:prstGeom>
+          <a:solidFill>
+            <a:srgbClr val="135F45"/>
+          </a:solidFill>
+        </p:spPr>
+      </p:sp>
+      <p:sp>
+        <p:nvSpPr>
+          <p:cNvPr name="TextBox 7" id="7"/>
+          <p:cNvSpPr txBox="true"/>
+          <p:nvPr/>
+        </p:nvSpPr>
+        <p:spPr>
+          <a:xfrm>
+            <a:off x="9594000" y="2450000"/>
+            <a:ext cx="7174800" cy="700000"/>
+          </a:xfrm>
+          <a:prstGeom prst="rect">
+            <a:avLst/>
+          </a:prstGeom>
+        </p:spPr>
+        <p:txBody>
+          <a:bodyPr anchor="t" wrap="square" rtlCol="false" tIns="0" lIns="0" bIns="0" rIns="0">
+            <a:noAutofit/>
+          </a:bodyPr>
+          <a:lstStyle/>
+          <a:p>
+            <a:pPr algn="l">
+              <a:lnSpc>
+                <a:spcPct val="100000"/>
+              </a:lnSpc>
+              <a:spcAft>
+                <a:spcPts val="0"/>
+              </a:spcAft>
+            </a:pPr>
+            <a:r>
+              <a:rPr lang="uk-UA" sz="2800" b="1">
+                <a:solidFill>
+                  <a:srgbClr val="F4B6C8"/>
+                </a:solidFill>
+                <a:latin typeface="Fira Sans Extra Condensed Bold"/>
+                <a:ea typeface="Fira Sans Extra Condensed Bold"/>
+                <a:cs typeface="Fira Sans Extra Condensed Bold"/>
+                <a:sym typeface="Fira Sans Extra Condensed Bold"/>
+              </a:rPr>
+              <a:t>Договір 2: оператор</a:t>
+            </a:r>
+          </a:p>
+        </p:txBody>
+      </p:sp>
+      <p:sp>
+        <p:nvSpPr>
+          <p:cNvPr name="TextBox 8" id="8"/>
+          <p:cNvSpPr txBox="true"/>
+          <p:nvPr/>
+        </p:nvSpPr>
+        <p:spPr>
+          <a:xfrm>
+            <a:off x="9594000" y="3350000"/>
+            <a:ext cx="7174800" cy="4900000"/>
+          </a:xfrm>
+          <a:prstGeom prst="rect">
+            <a:avLst/>
+          </a:prstGeom>
+        </p:spPr>
+        <p:txBody>
+          <a:bodyPr anchor="t" wrap="square" rtlCol="false" tIns="0" lIns="0" bIns="0" rIns="0">
+            <a:noAutofit/>
+          </a:bodyPr>
+          <a:lstStyle/>
+          <a:p>
+            <a:pPr algn="l">
+              <a:lnSpc>
+                <a:spcPct val="100000"/>
+              </a:lnSpc>
+              <a:spcAft>
+                <a:spcPts val="1600"/>
+              </a:spcAft>
+            </a:pPr>
+            <a:r>
+              <a:rPr lang="uk-UA" sz="2400" b="0">
+                <a:solidFill>
+                  <a:srgbClr val="FBFBF8"/>
+                </a:solidFill>
+                <a:latin typeface="Fira Sans Extra Condensed"/>
+                <a:ea typeface="Fira Sans Extra Condensed"/>
+                <a:cs typeface="Fira Sans Extra Condensed"/>
+                <a:sym typeface="Fira Sans Extra Condensed"/>
+              </a:rPr>
+              <a:t>— Ліцензія на бренд для однієї пекарні (територія й ексклюзивність: відкрито)</a:t>
+            </a:r>
+          </a:p>
+          <a:p>
+            <a:pPr algn="l">
+              <a:lnSpc>
+                <a:spcPct val="100000"/>
+              </a:lnSpc>
+              <a:spcAft>
+                <a:spcPts val="1600"/>
+              </a:spcAft>
+            </a:pPr>
+            <a:r>
+              <a:rPr lang="uk-UA" sz="2400" b="0">
+                <a:solidFill>
+                  <a:srgbClr val="FBFBF8"/>
+                </a:solidFill>
+                <a:latin typeface="Fira Sans Extra Condensed"/>
+                <a:ea typeface="Fira Sans Extra Condensed"/>
+                <a:cs typeface="Fira Sans Extra Condensed"/>
+                <a:sym typeface="Fira Sans Extra Condensed"/>
+              </a:rPr>
+              <a:t>— Стандарти Мережі: меню, дизайн, процеси, якість</a:t>
+            </a:r>
+          </a:p>
+          <a:p>
+            <a:pPr algn="l">
+              <a:lnSpc>
+                <a:spcPct val="100000"/>
+              </a:lnSpc>
+              <a:spcAft>
+                <a:spcPts val="1600"/>
+              </a:spcAft>
+            </a:pPr>
+            <a:r>
+              <a:rPr lang="uk-UA" sz="2400" b="0">
+                <a:solidFill>
+                  <a:srgbClr val="FBFBF8"/>
+                </a:solidFill>
+                <a:latin typeface="Fira Sans Extra Condensed"/>
+                <a:ea typeface="Fira Sans Extra Condensed"/>
+                <a:cs typeface="Fira Sans Extra Condensed"/>
+                <a:sym typeface="Fira Sans Extra Condensed"/>
+              </a:rPr>
+              <a:t>— Зміни меню й дизайну лише за погодженням Lviv Croissants</a:t>
+            </a:r>
+          </a:p>
+          <a:p>
+            <a:pPr algn="l">
+              <a:lnSpc>
+                <a:spcPct val="100000"/>
+              </a:lnSpc>
+              <a:spcAft>
+                <a:spcPts val="1600"/>
+              </a:spcAft>
+            </a:pPr>
+            <a:r>
+              <a:rPr lang="uk-UA" sz="2400" b="0">
+                <a:solidFill>
+                  <a:srgbClr val="FBFBF8"/>
+                </a:solidFill>
+                <a:latin typeface="Fira Sans Extra Condensed"/>
+                <a:ea typeface="Fira Sans Extra Condensed"/>
+                <a:cs typeface="Fira Sans Extra Condensed"/>
+                <a:sym typeface="Fira Sans Extra Condensed"/>
+              </a:rPr>
+              <a:t>— Навчання операційного директора й команди (~30 днів)</a:t>
+            </a:r>
+          </a:p>
+        </p:txBody>
+      </p:sp>
+      <p:sp>
+        <p:nvSpPr>
+          <p:cNvPr name="Note 9" id="9"/>
+          <p:cNvSpPr/>
+          <p:nvPr/>
+        </p:nvSpPr>
+        <p:spPr>
+          <a:xfrm>
+            <a:off x="1219200" y="8750000"/>
+            <a:ext cx="15849600" cy="1000000"/>
+          </a:xfrm>
+          <a:prstGeom prst="roundRect">
+            <a:avLst>
+              <a:gd name="adj" fmla="val 7000"/>
+            </a:avLst>
+          </a:prstGeom>
+          <a:solidFill>
+            <a:srgbClr val="F4B6C8"/>
+          </a:solidFill>
+        </p:spPr>
+      </p:sp>
+      <p:sp>
+        <p:nvSpPr>
+          <p:cNvPr name="TextBox 10" id="10"/>
+          <p:cNvSpPr txBox="true"/>
+          <p:nvPr/>
+        </p:nvSpPr>
+        <p:spPr>
+          <a:xfrm>
+            <a:off x="1500000" y="8750000"/>
+            <a:ext cx="15286000" cy="1000000"/>
+          </a:xfrm>
+          <a:prstGeom prst="rect">
+            <a:avLst/>
+          </a:prstGeom>
+        </p:spPr>
+        <p:txBody>
+          <a:bodyPr anchor="ctr" wrap="square" rtlCol="false" tIns="0" lIns="0" bIns="0" rIns="0">
+            <a:noAutofit/>
+          </a:bodyPr>
+          <a:lstStyle/>
+          <a:p>
+            <a:pPr algn="ctr">
+              <a:lnSpc>
+                <a:spcPct val="100000"/>
+              </a:lnSpc>
+              <a:spcAft>
+                <a:spcPts val="0"/>
+              </a:spcAft>
+            </a:pPr>
+            <a:r>
+              <a:rPr lang="uk-UA" sz="2600" b="1">
+                <a:solidFill>
+                  <a:srgbClr val="0E4D38"/>
+                </a:solidFill>
+                <a:latin typeface="Fira Sans Extra Condensed Bold"/>
+                <a:ea typeface="Fira Sans Extra Condensed Bold"/>
+                <a:cs typeface="Fira Sans Extra Condensed Bold"/>
+                <a:sym typeface="Fira Sans Extra Condensed Bold"/>
+              </a:rPr>
+              <a:t>Бренд і стандарти належать Lviv Croissants, оператор лише користується</a:t>
+            </a:r>
+          </a:p>
+        </p:txBody>
+      </p:sp>
     </p:spTree>
   </p:cSld>
   <p:clrMapOvr>
@@ -24274,6 +25891,377 @@
           </a:p>
         </p:txBody>
       </p:sp>
+      <p:sp>
+        <p:nvSpPr>
+          <p:cNvPr name="Card 3" id="3"/>
+          <p:cNvSpPr/>
+          <p:nvPr/>
+        </p:nvSpPr>
+        <p:spPr>
+          <a:xfrm>
+            <a:off x="1219200" y="2200000"/>
+            <a:ext cx="7774800" cy="6200000"/>
+          </a:xfrm>
+          <a:prstGeom prst="roundRect">
+            <a:avLst>
+              <a:gd name="adj" fmla="val 7000"/>
+            </a:avLst>
+          </a:prstGeom>
+          <a:solidFill>
+            <a:srgbClr val="135F45"/>
+          </a:solidFill>
+        </p:spPr>
+      </p:sp>
+      <p:sp>
+        <p:nvSpPr>
+          <p:cNvPr name="TextBox 4" id="4"/>
+          <p:cNvSpPr txBox="true"/>
+          <p:nvPr/>
+        </p:nvSpPr>
+        <p:spPr>
+          <a:xfrm>
+            <a:off x="1519200" y="2450000"/>
+            <a:ext cx="7174800" cy="700000"/>
+          </a:xfrm>
+          <a:prstGeom prst="rect">
+            <a:avLst/>
+          </a:prstGeom>
+        </p:spPr>
+        <p:txBody>
+          <a:bodyPr anchor="t" wrap="square" rtlCol="false" tIns="0" lIns="0" bIns="0" rIns="0">
+            <a:noAutofit/>
+          </a:bodyPr>
+          <a:lstStyle/>
+          <a:p>
+            <a:pPr algn="l">
+              <a:lnSpc>
+                <a:spcPct val="100000"/>
+              </a:lnSpc>
+              <a:spcAft>
+                <a:spcPts val="0"/>
+              </a:spcAft>
+            </a:pPr>
+            <a:r>
+              <a:rPr lang="uk-UA" sz="2800" b="1">
+                <a:solidFill>
+                  <a:srgbClr val="F4B6C8"/>
+                </a:solidFill>
+                <a:latin typeface="Fira Sans Extra Condensed Bold"/>
+                <a:ea typeface="Fira Sans Extra Condensed Bold"/>
+                <a:cs typeface="Fira Sans Extra Condensed Bold"/>
+                <a:sym typeface="Fira Sans Extra Condensed Bold"/>
+              </a:rPr>
+              <a:t>Договір 1: інвестор</a:t>
+            </a:r>
+          </a:p>
+        </p:txBody>
+      </p:sp>
+      <p:sp>
+        <p:nvSpPr>
+          <p:cNvPr name="TextBox 5" id="5"/>
+          <p:cNvSpPr txBox="true"/>
+          <p:nvPr/>
+        </p:nvSpPr>
+        <p:spPr>
+          <a:xfrm>
+            <a:off x="1519200" y="3350000"/>
+            <a:ext cx="7174800" cy="4900000"/>
+          </a:xfrm>
+          <a:prstGeom prst="rect">
+            <a:avLst/>
+          </a:prstGeom>
+        </p:spPr>
+        <p:txBody>
+          <a:bodyPr anchor="t" wrap="square" rtlCol="false" tIns="0" lIns="0" bIns="0" rIns="0">
+            <a:noAutofit/>
+          </a:bodyPr>
+          <a:lstStyle/>
+          <a:p>
+            <a:pPr algn="l">
+              <a:lnSpc>
+                <a:spcPct val="100000"/>
+              </a:lnSpc>
+              <a:spcAft>
+                <a:spcPts val="1600"/>
+              </a:spcAft>
+            </a:pPr>
+            <a:r>
+              <a:rPr lang="uk-UA" sz="2400" b="0">
+                <a:solidFill>
+                  <a:srgbClr val="FBFBF8"/>
+                </a:solidFill>
+                <a:latin typeface="Fira Sans Extra Condensed"/>
+                <a:ea typeface="Fira Sans Extra Condensed"/>
+                <a:cs typeface="Fira Sans Extra Condensed"/>
+                <a:sym typeface="Fira Sans Extra Condensed"/>
+              </a:rPr>
+              <a:t>— Звіти про результати пекарні надходять через Lviv Croissants</a:t>
+            </a:r>
+          </a:p>
+          <a:p>
+            <a:pPr algn="l">
+              <a:lnSpc>
+                <a:spcPct val="100000"/>
+              </a:lnSpc>
+              <a:spcAft>
+                <a:spcPts val="1600"/>
+              </a:spcAft>
+            </a:pPr>
+            <a:r>
+              <a:rPr lang="uk-UA" sz="2400" b="0">
+                <a:solidFill>
+                  <a:srgbClr val="FBFBF8"/>
+                </a:solidFill>
+                <a:latin typeface="Fira Sans Extra Condensed"/>
+                <a:ea typeface="Fira Sans Extra Condensed"/>
+                <a:cs typeface="Fira Sans Extra Condensed"/>
+                <a:sym typeface="Fira Sans Extra Condensed"/>
+              </a:rPr>
+              <a:t>— Що бачить інвестор: виручка, P&amp;L, окупність (глибина деталізації: відкрито)</a:t>
+            </a:r>
+          </a:p>
+        </p:txBody>
+      </p:sp>
+      <p:sp>
+        <p:nvSpPr>
+          <p:cNvPr name="Card 6" id="6"/>
+          <p:cNvSpPr/>
+          <p:nvPr/>
+        </p:nvSpPr>
+        <p:spPr>
+          <a:xfrm>
+            <a:off x="9294000" y="2200000"/>
+            <a:ext cx="7774800" cy="6200000"/>
+          </a:xfrm>
+          <a:prstGeom prst="roundRect">
+            <a:avLst>
+              <a:gd name="adj" fmla="val 7000"/>
+            </a:avLst>
+          </a:prstGeom>
+          <a:solidFill>
+            <a:srgbClr val="135F45"/>
+          </a:solidFill>
+        </p:spPr>
+      </p:sp>
+      <p:sp>
+        <p:nvSpPr>
+          <p:cNvPr name="TextBox 7" id="7"/>
+          <p:cNvSpPr txBox="true"/>
+          <p:nvPr/>
+        </p:nvSpPr>
+        <p:spPr>
+          <a:xfrm>
+            <a:off x="9594000" y="2450000"/>
+            <a:ext cx="7174800" cy="700000"/>
+          </a:xfrm>
+          <a:prstGeom prst="rect">
+            <a:avLst/>
+          </a:prstGeom>
+        </p:spPr>
+        <p:txBody>
+          <a:bodyPr anchor="t" wrap="square" rtlCol="false" tIns="0" lIns="0" bIns="0" rIns="0">
+            <a:noAutofit/>
+          </a:bodyPr>
+          <a:lstStyle/>
+          <a:p>
+            <a:pPr algn="l">
+              <a:lnSpc>
+                <a:spcPct val="100000"/>
+              </a:lnSpc>
+              <a:spcAft>
+                <a:spcPts val="0"/>
+              </a:spcAft>
+            </a:pPr>
+            <a:r>
+              <a:rPr lang="uk-UA" sz="2800" b="1">
+                <a:solidFill>
+                  <a:srgbClr val="F4B6C8"/>
+                </a:solidFill>
+                <a:latin typeface="Fira Sans Extra Condensed Bold"/>
+                <a:ea typeface="Fira Sans Extra Condensed Bold"/>
+                <a:cs typeface="Fira Sans Extra Condensed Bold"/>
+                <a:sym typeface="Fira Sans Extra Condensed Bold"/>
+              </a:rPr>
+              <a:t>Договір 2: оператор</a:t>
+            </a:r>
+          </a:p>
+        </p:txBody>
+      </p:sp>
+      <p:sp>
+        <p:nvSpPr>
+          <p:cNvPr name="TextBox 8" id="8"/>
+          <p:cNvSpPr txBox="true"/>
+          <p:nvPr/>
+        </p:nvSpPr>
+        <p:spPr>
+          <a:xfrm>
+            <a:off x="9594000" y="3350000"/>
+            <a:ext cx="7174800" cy="4900000"/>
+          </a:xfrm>
+          <a:prstGeom prst="rect">
+            <a:avLst/>
+          </a:prstGeom>
+        </p:spPr>
+        <p:txBody>
+          <a:bodyPr anchor="t" wrap="square" rtlCol="false" tIns="0" lIns="0" bIns="0" rIns="0">
+            <a:noAutofit/>
+          </a:bodyPr>
+          <a:lstStyle/>
+          <a:p>
+            <a:pPr algn="l">
+              <a:lnSpc>
+                <a:spcPct val="100000"/>
+              </a:lnSpc>
+              <a:spcAft>
+                <a:spcPts val="1600"/>
+              </a:spcAft>
+            </a:pPr>
+            <a:r>
+              <a:rPr lang="uk-UA" sz="2400" b="0">
+                <a:solidFill>
+                  <a:srgbClr val="FBFBF8"/>
+                </a:solidFill>
+                <a:latin typeface="Fira Sans Extra Condensed"/>
+                <a:ea typeface="Fira Sans Extra Condensed"/>
+                <a:cs typeface="Fira Sans Extra Condensed"/>
+                <a:sym typeface="Fira Sans Extra Condensed"/>
+              </a:rPr>
+              <a:t>— Щомісячні P&amp;L і ABC звіти, інвентаризація</a:t>
+            </a:r>
+          </a:p>
+          <a:p>
+            <a:pPr algn="l">
+              <a:lnSpc>
+                <a:spcPct val="100000"/>
+              </a:lnSpc>
+              <a:spcAft>
+                <a:spcPts val="1600"/>
+              </a:spcAft>
+            </a:pPr>
+            <a:r>
+              <a:rPr lang="uk-UA" sz="2400" b="0">
+                <a:solidFill>
+                  <a:srgbClr val="FBFBF8"/>
+                </a:solidFill>
+                <a:latin typeface="Fira Sans Extra Condensed"/>
+                <a:ea typeface="Fira Sans Extra Condensed"/>
+                <a:cs typeface="Fira Sans Extra Condensed"/>
+                <a:sym typeface="Fira Sans Extra Condensed"/>
+              </a:rPr>
+              <a:t>— Онлайн-моніторинг продажів, облік в Odoo</a:t>
+            </a:r>
+          </a:p>
+          <a:p>
+            <a:pPr algn="l">
+              <a:lnSpc>
+                <a:spcPct val="100000"/>
+              </a:lnSpc>
+              <a:spcAft>
+                <a:spcPts val="1600"/>
+              </a:spcAft>
+            </a:pPr>
+            <a:r>
+              <a:rPr lang="uk-UA" sz="2400" b="0">
+                <a:solidFill>
+                  <a:srgbClr val="FBFBF8"/>
+                </a:solidFill>
+                <a:latin typeface="Fira Sans Extra Condensed"/>
+                <a:ea typeface="Fira Sans Extra Condensed"/>
+                <a:cs typeface="Fira Sans Extra Condensed"/>
+                <a:sym typeface="Fira Sans Extra Condensed"/>
+              </a:rPr>
+              <a:t>— Контроль Стандартів: чек-листи, фотозвіти, візити HQ</a:t>
+            </a:r>
+          </a:p>
+          <a:p>
+            <a:pPr algn="l">
+              <a:lnSpc>
+                <a:spcPct val="100000"/>
+              </a:lnSpc>
+              <a:spcAft>
+                <a:spcPts val="1600"/>
+              </a:spcAft>
+            </a:pPr>
+            <a:r>
+              <a:rPr lang="uk-UA" sz="2400" b="0">
+                <a:solidFill>
+                  <a:srgbClr val="FBFBF8"/>
+                </a:solidFill>
+                <a:latin typeface="Fira Sans Extra Condensed"/>
+                <a:ea typeface="Fira Sans Extra Condensed"/>
+                <a:cs typeface="Fira Sans Extra Condensed"/>
+                <a:sym typeface="Fira Sans Extra Condensed"/>
+              </a:rPr>
+              <a:t>— Право перевірки з боку Lviv Croissants</a:t>
+            </a:r>
+          </a:p>
+        </p:txBody>
+      </p:sp>
+      <p:sp>
+        <p:nvSpPr>
+          <p:cNvPr name="Note 9" id="9"/>
+          <p:cNvSpPr/>
+          <p:nvPr/>
+        </p:nvSpPr>
+        <p:spPr>
+          <a:xfrm>
+            <a:off x="1219200" y="8750000"/>
+            <a:ext cx="15849600" cy="1000000"/>
+          </a:xfrm>
+          <a:prstGeom prst="roundRect">
+            <a:avLst>
+              <a:gd name="adj" fmla="val 7000"/>
+            </a:avLst>
+          </a:prstGeom>
+          <a:solidFill>
+            <a:srgbClr val="F4B6C8"/>
+          </a:solidFill>
+        </p:spPr>
+      </p:sp>
+      <p:sp>
+        <p:nvSpPr>
+          <p:cNvPr name="TextBox 10" id="10"/>
+          <p:cNvSpPr txBox="true"/>
+          <p:nvPr/>
+        </p:nvSpPr>
+        <p:spPr>
+          <a:xfrm>
+            <a:off x="1500000" y="8750000"/>
+            <a:ext cx="15286000" cy="1000000"/>
+          </a:xfrm>
+          <a:prstGeom prst="rect">
+            <a:avLst/>
+          </a:prstGeom>
+        </p:spPr>
+        <p:txBody>
+          <a:bodyPr anchor="ctr" wrap="square" rtlCol="false" tIns="0" lIns="0" bIns="0" rIns="0">
+            <a:noAutofit/>
+          </a:bodyPr>
+          <a:lstStyle/>
+          <a:p>
+            <a:pPr algn="ctr">
+              <a:lnSpc>
+                <a:spcPct val="100000"/>
+              </a:lnSpc>
+              <a:spcAft>
+                <a:spcPts val="0"/>
+              </a:spcAft>
+            </a:pPr>
+            <a:r>
+              <a:rPr lang="uk-UA" sz="2600" b="1">
+                <a:solidFill>
+                  <a:srgbClr val="0E4D38"/>
+                </a:solidFill>
+                <a:latin typeface="Fira Sans Extra Condensed Bold"/>
+                <a:ea typeface="Fira Sans Extra Condensed Bold"/>
+                <a:cs typeface="Fira Sans Extra Condensed Bold"/>
+                <a:sym typeface="Fira Sans Extra Condensed Bold"/>
+              </a:rPr>
+              <a:t>Пропозиція: єдине джерело цифр, інвестор і оператор бачать однакові дані</a:t>
+            </a:r>
+          </a:p>
+        </p:txBody>
+      </p:sp>
     </p:spTree>
   </p:cSld>
   <p:clrMapOvr>
@@ -24362,6 +26350,333 @@
           </a:p>
         </p:txBody>
       </p:sp>
+      <p:sp>
+        <p:nvSpPr>
+          <p:cNvPr name="Card 3" id="3"/>
+          <p:cNvSpPr/>
+          <p:nvPr/>
+        </p:nvSpPr>
+        <p:spPr>
+          <a:xfrm>
+            <a:off x="1219200" y="2200000"/>
+            <a:ext cx="7774800" cy="6200000"/>
+          </a:xfrm>
+          <a:prstGeom prst="roundRect">
+            <a:avLst>
+              <a:gd name="adj" fmla="val 7000"/>
+            </a:avLst>
+          </a:prstGeom>
+          <a:solidFill>
+            <a:srgbClr val="135F45"/>
+          </a:solidFill>
+        </p:spPr>
+      </p:sp>
+      <p:sp>
+        <p:nvSpPr>
+          <p:cNvPr name="TextBox 4" id="4"/>
+          <p:cNvSpPr txBox="true"/>
+          <p:nvPr/>
+        </p:nvSpPr>
+        <p:spPr>
+          <a:xfrm>
+            <a:off x="1519200" y="2450000"/>
+            <a:ext cx="7174800" cy="700000"/>
+          </a:xfrm>
+          <a:prstGeom prst="rect">
+            <a:avLst/>
+          </a:prstGeom>
+        </p:spPr>
+        <p:txBody>
+          <a:bodyPr anchor="t" wrap="square" rtlCol="false" tIns="0" lIns="0" bIns="0" rIns="0">
+            <a:noAutofit/>
+          </a:bodyPr>
+          <a:lstStyle/>
+          <a:p>
+            <a:pPr algn="l">
+              <a:lnSpc>
+                <a:spcPct val="100000"/>
+              </a:lnSpc>
+              <a:spcAft>
+                <a:spcPts val="0"/>
+              </a:spcAft>
+            </a:pPr>
+            <a:r>
+              <a:rPr lang="uk-UA" sz="2800" b="1">
+                <a:solidFill>
+                  <a:srgbClr val="F4B6C8"/>
+                </a:solidFill>
+                <a:latin typeface="Fira Sans Extra Condensed Bold"/>
+                <a:ea typeface="Fira Sans Extra Condensed Bold"/>
+                <a:cs typeface="Fira Sans Extra Condensed Bold"/>
+                <a:sym typeface="Fira Sans Extra Condensed Bold"/>
+              </a:rPr>
+              <a:t>Договір 1: інвестор</a:t>
+            </a:r>
+          </a:p>
+        </p:txBody>
+      </p:sp>
+      <p:sp>
+        <p:nvSpPr>
+          <p:cNvPr name="TextBox 5" id="5"/>
+          <p:cNvSpPr txBox="true"/>
+          <p:nvPr/>
+        </p:nvSpPr>
+        <p:spPr>
+          <a:xfrm>
+            <a:off x="1519200" y="3350000"/>
+            <a:ext cx="7174800" cy="4900000"/>
+          </a:xfrm>
+          <a:prstGeom prst="rect">
+            <a:avLst/>
+          </a:prstGeom>
+        </p:spPr>
+        <p:txBody>
+          <a:bodyPr anchor="t" wrap="square" rtlCol="false" tIns="0" lIns="0" bIns="0" rIns="0">
+            <a:noAutofit/>
+          </a:bodyPr>
+          <a:lstStyle/>
+          <a:p>
+            <a:pPr algn="l">
+              <a:lnSpc>
+                <a:spcPct val="100000"/>
+              </a:lnSpc>
+              <a:spcAft>
+                <a:spcPts val="1600"/>
+              </a:spcAft>
+            </a:pPr>
+            <a:r>
+              <a:rPr lang="uk-UA" sz="2400" b="0">
+                <a:solidFill>
+                  <a:srgbClr val="FBFBF8"/>
+                </a:solidFill>
+                <a:latin typeface="Fira Sans Extra Condensed"/>
+                <a:ea typeface="Fira Sans Extra Condensed"/>
+                <a:cs typeface="Fira Sans Extra Condensed"/>
+                <a:sym typeface="Fira Sans Extra Condensed"/>
+              </a:rPr>
+              <a:t>— Строк має покривати окупність інвестора (3–3,5 роки)</a:t>
+            </a:r>
+          </a:p>
+          <a:p>
+            <a:pPr algn="l">
+              <a:lnSpc>
+                <a:spcPct val="100000"/>
+              </a:lnSpc>
+              <a:spcAft>
+                <a:spcPts val="1600"/>
+              </a:spcAft>
+            </a:pPr>
+            <a:r>
+              <a:rPr lang="uk-UA" sz="2400" b="0">
+                <a:solidFill>
+                  <a:srgbClr val="FBFBF8"/>
+                </a:solidFill>
+                <a:latin typeface="Fira Sans Extra Condensed"/>
+                <a:ea typeface="Fira Sans Extra Condensed"/>
+                <a:cs typeface="Fira Sans Extra Condensed"/>
+                <a:sym typeface="Fira Sans Extra Condensed"/>
+              </a:rPr>
+              <a:t>— Умови продовження: відкрито</a:t>
+            </a:r>
+          </a:p>
+        </p:txBody>
+      </p:sp>
+      <p:sp>
+        <p:nvSpPr>
+          <p:cNvPr name="Card 6" id="6"/>
+          <p:cNvSpPr/>
+          <p:nvPr/>
+        </p:nvSpPr>
+        <p:spPr>
+          <a:xfrm>
+            <a:off x="9294000" y="2200000"/>
+            <a:ext cx="7774800" cy="6200000"/>
+          </a:xfrm>
+          <a:prstGeom prst="roundRect">
+            <a:avLst>
+              <a:gd name="adj" fmla="val 7000"/>
+            </a:avLst>
+          </a:prstGeom>
+          <a:solidFill>
+            <a:srgbClr val="135F45"/>
+          </a:solidFill>
+        </p:spPr>
+      </p:sp>
+      <p:sp>
+        <p:nvSpPr>
+          <p:cNvPr name="TextBox 7" id="7"/>
+          <p:cNvSpPr txBox="true"/>
+          <p:nvPr/>
+        </p:nvSpPr>
+        <p:spPr>
+          <a:xfrm>
+            <a:off x="9594000" y="2450000"/>
+            <a:ext cx="7174800" cy="700000"/>
+          </a:xfrm>
+          <a:prstGeom prst="rect">
+            <a:avLst/>
+          </a:prstGeom>
+        </p:spPr>
+        <p:txBody>
+          <a:bodyPr anchor="t" wrap="square" rtlCol="false" tIns="0" lIns="0" bIns="0" rIns="0">
+            <a:noAutofit/>
+          </a:bodyPr>
+          <a:lstStyle/>
+          <a:p>
+            <a:pPr algn="l">
+              <a:lnSpc>
+                <a:spcPct val="100000"/>
+              </a:lnSpc>
+              <a:spcAft>
+                <a:spcPts val="0"/>
+              </a:spcAft>
+            </a:pPr>
+            <a:r>
+              <a:rPr lang="uk-UA" sz="2800" b="1">
+                <a:solidFill>
+                  <a:srgbClr val="F4B6C8"/>
+                </a:solidFill>
+                <a:latin typeface="Fira Sans Extra Condensed Bold"/>
+                <a:ea typeface="Fira Sans Extra Condensed Bold"/>
+                <a:cs typeface="Fira Sans Extra Condensed Bold"/>
+                <a:sym typeface="Fira Sans Extra Condensed Bold"/>
+              </a:rPr>
+              <a:t>Договір 2: оператор</a:t>
+            </a:r>
+          </a:p>
+        </p:txBody>
+      </p:sp>
+      <p:sp>
+        <p:nvSpPr>
+          <p:cNvPr name="TextBox 8" id="8"/>
+          <p:cNvSpPr txBox="true"/>
+          <p:nvPr/>
+        </p:nvSpPr>
+        <p:spPr>
+          <a:xfrm>
+            <a:off x="9594000" y="3350000"/>
+            <a:ext cx="7174800" cy="4900000"/>
+          </a:xfrm>
+          <a:prstGeom prst="rect">
+            <a:avLst/>
+          </a:prstGeom>
+        </p:spPr>
+        <p:txBody>
+          <a:bodyPr anchor="t" wrap="square" rtlCol="false" tIns="0" lIns="0" bIns="0" rIns="0">
+            <a:noAutofit/>
+          </a:bodyPr>
+          <a:lstStyle/>
+          <a:p>
+            <a:pPr algn="l">
+              <a:lnSpc>
+                <a:spcPct val="100000"/>
+              </a:lnSpc>
+              <a:spcAft>
+                <a:spcPts val="1600"/>
+              </a:spcAft>
+            </a:pPr>
+            <a:r>
+              <a:rPr lang="uk-UA" sz="2400" b="0">
+                <a:solidFill>
+                  <a:srgbClr val="FBFBF8"/>
+                </a:solidFill>
+                <a:latin typeface="Fira Sans Extra Condensed"/>
+                <a:ea typeface="Fira Sans Extra Condensed"/>
+                <a:cs typeface="Fira Sans Extra Condensed"/>
+                <a:sym typeface="Fira Sans Extra Condensed"/>
+              </a:rPr>
+              <a:t>— Строк франшизи: відкрито, пов'язати зі строком оренди</a:t>
+            </a:r>
+          </a:p>
+          <a:p>
+            <a:pPr algn="l">
+              <a:lnSpc>
+                <a:spcPct val="100000"/>
+              </a:lnSpc>
+              <a:spcAft>
+                <a:spcPts val="1600"/>
+              </a:spcAft>
+            </a:pPr>
+            <a:r>
+              <a:rPr lang="uk-UA" sz="2400" b="0">
+                <a:solidFill>
+                  <a:srgbClr val="FBFBF8"/>
+                </a:solidFill>
+                <a:latin typeface="Fira Sans Extra Condensed"/>
+                <a:ea typeface="Fira Sans Extra Condensed"/>
+                <a:cs typeface="Fira Sans Extra Condensed"/>
+                <a:sym typeface="Fira Sans Extra Condensed"/>
+              </a:rPr>
+              <a:t>— Умови продовження й перегляду частки прибутку: відкрито</a:t>
+            </a:r>
+          </a:p>
+        </p:txBody>
+      </p:sp>
+      <p:sp>
+        <p:nvSpPr>
+          <p:cNvPr name="Note 9" id="9"/>
+          <p:cNvSpPr/>
+          <p:nvPr/>
+        </p:nvSpPr>
+        <p:spPr>
+          <a:xfrm>
+            <a:off x="1219200" y="8750000"/>
+            <a:ext cx="15849600" cy="1000000"/>
+          </a:xfrm>
+          <a:prstGeom prst="roundRect">
+            <a:avLst>
+              <a:gd name="adj" fmla="val 7000"/>
+            </a:avLst>
+          </a:prstGeom>
+          <a:solidFill>
+            <a:srgbClr val="F4B6C8"/>
+          </a:solidFill>
+        </p:spPr>
+      </p:sp>
+      <p:sp>
+        <p:nvSpPr>
+          <p:cNvPr name="TextBox 10" id="10"/>
+          <p:cNvSpPr txBox="true"/>
+          <p:nvPr/>
+        </p:nvSpPr>
+        <p:spPr>
+          <a:xfrm>
+            <a:off x="1500000" y="8750000"/>
+            <a:ext cx="15286000" cy="1000000"/>
+          </a:xfrm>
+          <a:prstGeom prst="rect">
+            <a:avLst/>
+          </a:prstGeom>
+        </p:spPr>
+        <p:txBody>
+          <a:bodyPr anchor="ctr" wrap="square" rtlCol="false" tIns="0" lIns="0" bIns="0" rIns="0">
+            <a:noAutofit/>
+          </a:bodyPr>
+          <a:lstStyle/>
+          <a:p>
+            <a:pPr algn="ctr">
+              <a:lnSpc>
+                <a:spcPct val="100000"/>
+              </a:lnSpc>
+              <a:spcAft>
+                <a:spcPts val="0"/>
+              </a:spcAft>
+            </a:pPr>
+            <a:r>
+              <a:rPr lang="uk-UA" sz="2600" b="1">
+                <a:solidFill>
+                  <a:srgbClr val="0E4D38"/>
+                </a:solidFill>
+                <a:latin typeface="Fira Sans Extra Condensed Bold"/>
+                <a:ea typeface="Fira Sans Extra Condensed Bold"/>
+                <a:cs typeface="Fira Sans Extra Condensed Bold"/>
+                <a:sym typeface="Fira Sans Extra Condensed Bold"/>
+              </a:rPr>
+              <a:t>Строки обох договорів і оренди приміщення мають узгоджуватися</a:t>
+            </a:r>
+          </a:p>
+        </p:txBody>
+      </p:sp>
     </p:spTree>
   </p:cSld>
   <p:clrMapOvr>
@@ -24450,6 +26765,377 @@
           </a:p>
         </p:txBody>
       </p:sp>
+      <p:sp>
+        <p:nvSpPr>
+          <p:cNvPr name="Card 3" id="3"/>
+          <p:cNvSpPr/>
+          <p:nvPr/>
+        </p:nvSpPr>
+        <p:spPr>
+          <a:xfrm>
+            <a:off x="1219200" y="2200000"/>
+            <a:ext cx="7774800" cy="6200000"/>
+          </a:xfrm>
+          <a:prstGeom prst="roundRect">
+            <a:avLst>
+              <a:gd name="adj" fmla="val 7000"/>
+            </a:avLst>
+          </a:prstGeom>
+          <a:solidFill>
+            <a:srgbClr val="135F45"/>
+          </a:solidFill>
+        </p:spPr>
+      </p:sp>
+      <p:sp>
+        <p:nvSpPr>
+          <p:cNvPr name="TextBox 4" id="4"/>
+          <p:cNvSpPr txBox="true"/>
+          <p:nvPr/>
+        </p:nvSpPr>
+        <p:spPr>
+          <a:xfrm>
+            <a:off x="1519200" y="2450000"/>
+            <a:ext cx="7174800" cy="700000"/>
+          </a:xfrm>
+          <a:prstGeom prst="rect">
+            <a:avLst/>
+          </a:prstGeom>
+        </p:spPr>
+        <p:txBody>
+          <a:bodyPr anchor="t" wrap="square" rtlCol="false" tIns="0" lIns="0" bIns="0" rIns="0">
+            <a:noAutofit/>
+          </a:bodyPr>
+          <a:lstStyle/>
+          <a:p>
+            <a:pPr algn="l">
+              <a:lnSpc>
+                <a:spcPct val="100000"/>
+              </a:lnSpc>
+              <a:spcAft>
+                <a:spcPts val="0"/>
+              </a:spcAft>
+            </a:pPr>
+            <a:r>
+              <a:rPr lang="uk-UA" sz="2800" b="1">
+                <a:solidFill>
+                  <a:srgbClr val="F4B6C8"/>
+                </a:solidFill>
+                <a:latin typeface="Fira Sans Extra Condensed Bold"/>
+                <a:ea typeface="Fira Sans Extra Condensed Bold"/>
+                <a:cs typeface="Fira Sans Extra Condensed Bold"/>
+                <a:sym typeface="Fira Sans Extra Condensed Bold"/>
+              </a:rPr>
+              <a:t>Договір 1: інвестор</a:t>
+            </a:r>
+          </a:p>
+        </p:txBody>
+      </p:sp>
+      <p:sp>
+        <p:nvSpPr>
+          <p:cNvPr name="TextBox 5" id="5"/>
+          <p:cNvSpPr txBox="true"/>
+          <p:nvPr/>
+        </p:nvSpPr>
+        <p:spPr>
+          <a:xfrm>
+            <a:off x="1519200" y="3350000"/>
+            <a:ext cx="7174800" cy="4900000"/>
+          </a:xfrm>
+          <a:prstGeom prst="rect">
+            <a:avLst/>
+          </a:prstGeom>
+        </p:spPr>
+        <p:txBody>
+          <a:bodyPr anchor="t" wrap="square" rtlCol="false" tIns="0" lIns="0" bIns="0" rIns="0">
+            <a:noAutofit/>
+          </a:bodyPr>
+          <a:lstStyle/>
+          <a:p>
+            <a:pPr algn="l">
+              <a:lnSpc>
+                <a:spcPct val="100000"/>
+              </a:lnSpc>
+              <a:spcAft>
+                <a:spcPts val="1600"/>
+              </a:spcAft>
+            </a:pPr>
+            <a:r>
+              <a:rPr lang="uk-UA" sz="2400" b="0">
+                <a:solidFill>
+                  <a:srgbClr val="FBFBF8"/>
+                </a:solidFill>
+                <a:latin typeface="Fira Sans Extra Condensed"/>
+                <a:ea typeface="Fira Sans Extra Condensed"/>
+                <a:cs typeface="Fira Sans Extra Condensed"/>
+                <a:sym typeface="Fira Sans Extra Condensed"/>
+              </a:rPr>
+              <a:t>— Вихід інвестора: відкрито (викуп частки, новий інвестор?)</a:t>
+            </a:r>
+          </a:p>
+          <a:p>
+            <a:pPr algn="l">
+              <a:lnSpc>
+                <a:spcPct val="100000"/>
+              </a:lnSpc>
+              <a:spcAft>
+                <a:spcPts val="1600"/>
+              </a:spcAft>
+            </a:pPr>
+            <a:r>
+              <a:rPr lang="uk-UA" sz="2400" b="0">
+                <a:solidFill>
+                  <a:srgbClr val="FBFBF8"/>
+                </a:solidFill>
+                <a:latin typeface="Fira Sans Extra Condensed"/>
+                <a:ea typeface="Fira Sans Extra Condensed"/>
+                <a:cs typeface="Fira Sans Extra Condensed"/>
+                <a:sym typeface="Fira Sans Extra Condensed"/>
+              </a:rPr>
+              <a:t>— Умови зміни й передачі прав третій особі: відкрито</a:t>
+            </a:r>
+          </a:p>
+        </p:txBody>
+      </p:sp>
+      <p:sp>
+        <p:nvSpPr>
+          <p:cNvPr name="Card 6" id="6"/>
+          <p:cNvSpPr/>
+          <p:nvPr/>
+        </p:nvSpPr>
+        <p:spPr>
+          <a:xfrm>
+            <a:off x="9294000" y="2200000"/>
+            <a:ext cx="7774800" cy="6200000"/>
+          </a:xfrm>
+          <a:prstGeom prst="roundRect">
+            <a:avLst>
+              <a:gd name="adj" fmla="val 7000"/>
+            </a:avLst>
+          </a:prstGeom>
+          <a:solidFill>
+            <a:srgbClr val="135F45"/>
+          </a:solidFill>
+        </p:spPr>
+      </p:sp>
+      <p:sp>
+        <p:nvSpPr>
+          <p:cNvPr name="TextBox 7" id="7"/>
+          <p:cNvSpPr txBox="true"/>
+          <p:nvPr/>
+        </p:nvSpPr>
+        <p:spPr>
+          <a:xfrm>
+            <a:off x="9594000" y="2450000"/>
+            <a:ext cx="7174800" cy="700000"/>
+          </a:xfrm>
+          <a:prstGeom prst="rect">
+            <a:avLst/>
+          </a:prstGeom>
+        </p:spPr>
+        <p:txBody>
+          <a:bodyPr anchor="t" wrap="square" rtlCol="false" tIns="0" lIns="0" bIns="0" rIns="0">
+            <a:noAutofit/>
+          </a:bodyPr>
+          <a:lstStyle/>
+          <a:p>
+            <a:pPr algn="l">
+              <a:lnSpc>
+                <a:spcPct val="100000"/>
+              </a:lnSpc>
+              <a:spcAft>
+                <a:spcPts val="0"/>
+              </a:spcAft>
+            </a:pPr>
+            <a:r>
+              <a:rPr lang="uk-UA" sz="2800" b="1">
+                <a:solidFill>
+                  <a:srgbClr val="F4B6C8"/>
+                </a:solidFill>
+                <a:latin typeface="Fira Sans Extra Condensed Bold"/>
+                <a:ea typeface="Fira Sans Extra Condensed Bold"/>
+                <a:cs typeface="Fira Sans Extra Condensed Bold"/>
+                <a:sym typeface="Fira Sans Extra Condensed Bold"/>
+              </a:rPr>
+              <a:t>Договір 2: оператор</a:t>
+            </a:r>
+          </a:p>
+        </p:txBody>
+      </p:sp>
+      <p:sp>
+        <p:nvSpPr>
+          <p:cNvPr name="TextBox 8" id="8"/>
+          <p:cNvSpPr txBox="true"/>
+          <p:nvPr/>
+        </p:nvSpPr>
+        <p:spPr>
+          <a:xfrm>
+            <a:off x="9594000" y="3350000"/>
+            <a:ext cx="7174800" cy="4900000"/>
+          </a:xfrm>
+          <a:prstGeom prst="rect">
+            <a:avLst/>
+          </a:prstGeom>
+        </p:spPr>
+        <p:txBody>
+          <a:bodyPr anchor="t" wrap="square" rtlCol="false" tIns="0" lIns="0" bIns="0" rIns="0">
+            <a:noAutofit/>
+          </a:bodyPr>
+          <a:lstStyle/>
+          <a:p>
+            <a:pPr algn="l">
+              <a:lnSpc>
+                <a:spcPct val="100000"/>
+              </a:lnSpc>
+              <a:spcAft>
+                <a:spcPts val="1600"/>
+              </a:spcAft>
+            </a:pPr>
+            <a:r>
+              <a:rPr lang="uk-UA" sz="2400" b="0">
+                <a:solidFill>
+                  <a:srgbClr val="FBFBF8"/>
+                </a:solidFill>
+                <a:latin typeface="Fira Sans Extra Condensed"/>
+                <a:ea typeface="Fira Sans Extra Condensed"/>
+                <a:cs typeface="Fira Sans Extra Condensed"/>
+                <a:sym typeface="Fira Sans Extra Condensed"/>
+              </a:rPr>
+              <a:t>— Вихід оператора: інвестор викуповує його обладнання</a:t>
+            </a:r>
+          </a:p>
+          <a:p>
+            <a:pPr algn="l">
+              <a:lnSpc>
+                <a:spcPct val="100000"/>
+              </a:lnSpc>
+              <a:spcAft>
+                <a:spcPts val="1600"/>
+              </a:spcAft>
+            </a:pPr>
+            <a:r>
+              <a:rPr lang="uk-UA" sz="2400" b="0">
+                <a:solidFill>
+                  <a:srgbClr val="FBFBF8"/>
+                </a:solidFill>
+                <a:latin typeface="Fira Sans Extra Condensed"/>
+                <a:ea typeface="Fira Sans Extra Condensed"/>
+                <a:cs typeface="Fira Sans Extra Condensed"/>
+                <a:sym typeface="Fira Sans Extra Condensed"/>
+              </a:rPr>
+              <a:t>— Ціна викупу знижується з 90% до 50% вартості за 5 років</a:t>
+            </a:r>
+          </a:p>
+          <a:p>
+            <a:pPr algn="l">
+              <a:lnSpc>
+                <a:spcPct val="100000"/>
+              </a:lnSpc>
+              <a:spcAft>
+                <a:spcPts val="1600"/>
+              </a:spcAft>
+            </a:pPr>
+            <a:r>
+              <a:rPr lang="uk-UA" sz="2400" b="0">
+                <a:solidFill>
+                  <a:srgbClr val="FBFBF8"/>
+                </a:solidFill>
+                <a:latin typeface="Fira Sans Extra Condensed"/>
+                <a:ea typeface="Fira Sans Extra Condensed"/>
+                <a:cs typeface="Fira Sans Extra Condensed"/>
+                <a:sym typeface="Fira Sans Extra Condensed"/>
+              </a:rPr>
+              <a:t>— Заміна оператора: Lviv Croissants підбирає нового (пропозиція)</a:t>
+            </a:r>
+          </a:p>
+          <a:p>
+            <a:pPr algn="l">
+              <a:lnSpc>
+                <a:spcPct val="100000"/>
+              </a:lnSpc>
+              <a:spcAft>
+                <a:spcPts val="1600"/>
+              </a:spcAft>
+            </a:pPr>
+            <a:r>
+              <a:rPr lang="uk-UA" sz="2400" b="0">
+                <a:solidFill>
+                  <a:srgbClr val="FBFBF8"/>
+                </a:solidFill>
+                <a:latin typeface="Fira Sans Extra Condensed"/>
+                <a:ea typeface="Fira Sans Extra Condensed"/>
+                <a:cs typeface="Fira Sans Extra Condensed"/>
+                <a:sym typeface="Fira Sans Extra Condensed"/>
+              </a:rPr>
+              <a:t>— Розірвання за порушення Стандартів: умови й строки виправлення: відкрито</a:t>
+            </a:r>
+          </a:p>
+        </p:txBody>
+      </p:sp>
+      <p:sp>
+        <p:nvSpPr>
+          <p:cNvPr name="Note 9" id="9"/>
+          <p:cNvSpPr/>
+          <p:nvPr/>
+        </p:nvSpPr>
+        <p:spPr>
+          <a:xfrm>
+            <a:off x="1219200" y="8750000"/>
+            <a:ext cx="15849600" cy="1000000"/>
+          </a:xfrm>
+          <a:prstGeom prst="roundRect">
+            <a:avLst>
+              <a:gd name="adj" fmla="val 7000"/>
+            </a:avLst>
+          </a:prstGeom>
+          <a:solidFill>
+            <a:srgbClr val="F4B6C8"/>
+          </a:solidFill>
+        </p:spPr>
+      </p:sp>
+      <p:sp>
+        <p:nvSpPr>
+          <p:cNvPr name="TextBox 10" id="10"/>
+          <p:cNvSpPr txBox="true"/>
+          <p:nvPr/>
+        </p:nvSpPr>
+        <p:spPr>
+          <a:xfrm>
+            <a:off x="1500000" y="8750000"/>
+            <a:ext cx="15286000" cy="1000000"/>
+          </a:xfrm>
+          <a:prstGeom prst="rect">
+            <a:avLst/>
+          </a:prstGeom>
+        </p:spPr>
+        <p:txBody>
+          <a:bodyPr anchor="ctr" wrap="square" rtlCol="false" tIns="0" lIns="0" bIns="0" rIns="0">
+            <a:noAutofit/>
+          </a:bodyPr>
+          <a:lstStyle/>
+          <a:p>
+            <a:pPr algn="ctr">
+              <a:lnSpc>
+                <a:spcPct val="100000"/>
+              </a:lnSpc>
+              <a:spcAft>
+                <a:spcPts val="0"/>
+              </a:spcAft>
+            </a:pPr>
+            <a:r>
+              <a:rPr lang="uk-UA" sz="2600" b="1">
+                <a:solidFill>
+                  <a:srgbClr val="0E4D38"/>
+                </a:solidFill>
+                <a:latin typeface="Fira Sans Extra Condensed Bold"/>
+                <a:ea typeface="Fira Sans Extra Condensed Bold"/>
+                <a:cs typeface="Fira Sans Extra Condensed Bold"/>
+                <a:sym typeface="Fira Sans Extra Condensed Bold"/>
+              </a:rPr>
+              <a:t>Вихід одного партнера не зупиняє договір іншого</a:t>
+            </a:r>
+          </a:p>
+        </p:txBody>
+      </p:sp>
     </p:spTree>
   </p:cSld>
   <p:clrMapOvr>
@@ -24534,6 +27220,888 @@
                 <a:sym typeface="Fira Sans Extra Condensed Bold"/>
               </a:rPr>
               <a:t>Відповідальність</a:t>
+            </a:r>
+          </a:p>
+        </p:txBody>
+      </p:sp>
+      <p:sp>
+        <p:nvSpPr>
+          <p:cNvPr name="Card 3" id="3"/>
+          <p:cNvSpPr/>
+          <p:nvPr/>
+        </p:nvSpPr>
+        <p:spPr>
+          <a:xfrm>
+            <a:off x="1219200" y="2200000"/>
+            <a:ext cx="7774800" cy="6200000"/>
+          </a:xfrm>
+          <a:prstGeom prst="roundRect">
+            <a:avLst>
+              <a:gd name="adj" fmla="val 7000"/>
+            </a:avLst>
+          </a:prstGeom>
+          <a:solidFill>
+            <a:srgbClr val="135F45"/>
+          </a:solidFill>
+        </p:spPr>
+      </p:sp>
+      <p:sp>
+        <p:nvSpPr>
+          <p:cNvPr name="TextBox 4" id="4"/>
+          <p:cNvSpPr txBox="true"/>
+          <p:nvPr/>
+        </p:nvSpPr>
+        <p:spPr>
+          <a:xfrm>
+            <a:off x="1519200" y="2450000"/>
+            <a:ext cx="7174800" cy="700000"/>
+          </a:xfrm>
+          <a:prstGeom prst="rect">
+            <a:avLst/>
+          </a:prstGeom>
+        </p:spPr>
+        <p:txBody>
+          <a:bodyPr anchor="t" wrap="square" rtlCol="false" tIns="0" lIns="0" bIns="0" rIns="0">
+            <a:noAutofit/>
+          </a:bodyPr>
+          <a:lstStyle/>
+          <a:p>
+            <a:pPr algn="l">
+              <a:lnSpc>
+                <a:spcPct val="100000"/>
+              </a:lnSpc>
+              <a:spcAft>
+                <a:spcPts val="0"/>
+              </a:spcAft>
+            </a:pPr>
+            <a:r>
+              <a:rPr lang="uk-UA" sz="2800" b="1">
+                <a:solidFill>
+                  <a:srgbClr val="F4B6C8"/>
+                </a:solidFill>
+                <a:latin typeface="Fira Sans Extra Condensed Bold"/>
+                <a:ea typeface="Fira Sans Extra Condensed Bold"/>
+                <a:cs typeface="Fira Sans Extra Condensed Bold"/>
+                <a:sym typeface="Fira Sans Extra Condensed Bold"/>
+              </a:rPr>
+              <a:t>Договір 1: інвестор</a:t>
+            </a:r>
+          </a:p>
+        </p:txBody>
+      </p:sp>
+      <p:sp>
+        <p:nvSpPr>
+          <p:cNvPr name="TextBox 5" id="5"/>
+          <p:cNvSpPr txBox="true"/>
+          <p:nvPr/>
+        </p:nvSpPr>
+        <p:spPr>
+          <a:xfrm>
+            <a:off x="1519200" y="3350000"/>
+            <a:ext cx="7174800" cy="4900000"/>
+          </a:xfrm>
+          <a:prstGeom prst="rect">
+            <a:avLst/>
+          </a:prstGeom>
+        </p:spPr>
+        <p:txBody>
+          <a:bodyPr anchor="t" wrap="square" rtlCol="false" tIns="0" lIns="0" bIns="0" rIns="0">
+            <a:noAutofit/>
+          </a:bodyPr>
+          <a:lstStyle/>
+          <a:p>
+            <a:pPr algn="l">
+              <a:lnSpc>
+                <a:spcPct val="100000"/>
+              </a:lnSpc>
+              <a:spcAft>
+                <a:spcPts val="1600"/>
+              </a:spcAft>
+            </a:pPr>
+            <a:r>
+              <a:rPr lang="uk-UA" sz="2400" b="0">
+                <a:solidFill>
+                  <a:srgbClr val="FBFBF8"/>
+                </a:solidFill>
+                <a:latin typeface="Fira Sans Extra Condensed"/>
+                <a:ea typeface="Fira Sans Extra Condensed"/>
+                <a:cs typeface="Fira Sans Extra Condensed"/>
+                <a:sym typeface="Fira Sans Extra Condensed"/>
+              </a:rPr>
+              <a:t>— Інвестор відповідає за виконання своїх фінансових обов'язків</a:t>
+            </a:r>
+          </a:p>
+          <a:p>
+            <a:pPr algn="l">
+              <a:lnSpc>
+                <a:spcPct val="100000"/>
+              </a:lnSpc>
+              <a:spcAft>
+                <a:spcPts val="1600"/>
+              </a:spcAft>
+            </a:pPr>
+            <a:r>
+              <a:rPr lang="uk-UA" sz="2400" b="0">
+                <a:solidFill>
+                  <a:srgbClr val="FBFBF8"/>
+                </a:solidFill>
+                <a:latin typeface="Fira Sans Extra Condensed"/>
+                <a:ea typeface="Fira Sans Extra Condensed"/>
+                <a:cs typeface="Fira Sans Extra Condensed"/>
+                <a:sym typeface="Fira Sans Extra Condensed"/>
+              </a:rPr>
+              <a:t>— Санкції за прострочення вкладень: відкрито</a:t>
+            </a:r>
+          </a:p>
+        </p:txBody>
+      </p:sp>
+      <p:sp>
+        <p:nvSpPr>
+          <p:cNvPr name="Card 6" id="6"/>
+          <p:cNvSpPr/>
+          <p:nvPr/>
+        </p:nvSpPr>
+        <p:spPr>
+          <a:xfrm>
+            <a:off x="9294000" y="2200000"/>
+            <a:ext cx="7774800" cy="6200000"/>
+          </a:xfrm>
+          <a:prstGeom prst="roundRect">
+            <a:avLst>
+              <a:gd name="adj" fmla="val 7000"/>
+            </a:avLst>
+          </a:prstGeom>
+          <a:solidFill>
+            <a:srgbClr val="135F45"/>
+          </a:solidFill>
+        </p:spPr>
+      </p:sp>
+      <p:sp>
+        <p:nvSpPr>
+          <p:cNvPr name="TextBox 7" id="7"/>
+          <p:cNvSpPr txBox="true"/>
+          <p:nvPr/>
+        </p:nvSpPr>
+        <p:spPr>
+          <a:xfrm>
+            <a:off x="9594000" y="2450000"/>
+            <a:ext cx="7174800" cy="700000"/>
+          </a:xfrm>
+          <a:prstGeom prst="rect">
+            <a:avLst/>
+          </a:prstGeom>
+        </p:spPr>
+        <p:txBody>
+          <a:bodyPr anchor="t" wrap="square" rtlCol="false" tIns="0" lIns="0" bIns="0" rIns="0">
+            <a:noAutofit/>
+          </a:bodyPr>
+          <a:lstStyle/>
+          <a:p>
+            <a:pPr algn="l">
+              <a:lnSpc>
+                <a:spcPct val="100000"/>
+              </a:lnSpc>
+              <a:spcAft>
+                <a:spcPts val="0"/>
+              </a:spcAft>
+            </a:pPr>
+            <a:r>
+              <a:rPr lang="uk-UA" sz="2800" b="1">
+                <a:solidFill>
+                  <a:srgbClr val="F4B6C8"/>
+                </a:solidFill>
+                <a:latin typeface="Fira Sans Extra Condensed Bold"/>
+                <a:ea typeface="Fira Sans Extra Condensed Bold"/>
+                <a:cs typeface="Fira Sans Extra Condensed Bold"/>
+                <a:sym typeface="Fira Sans Extra Condensed Bold"/>
+              </a:rPr>
+              <a:t>Договір 2: оператор</a:t>
+            </a:r>
+          </a:p>
+        </p:txBody>
+      </p:sp>
+      <p:sp>
+        <p:nvSpPr>
+          <p:cNvPr name="TextBox 8" id="8"/>
+          <p:cNvSpPr txBox="true"/>
+          <p:nvPr/>
+        </p:nvSpPr>
+        <p:spPr>
+          <a:xfrm>
+            <a:off x="9594000" y="3350000"/>
+            <a:ext cx="7174800" cy="4900000"/>
+          </a:xfrm>
+          <a:prstGeom prst="rect">
+            <a:avLst/>
+          </a:prstGeom>
+        </p:spPr>
+        <p:txBody>
+          <a:bodyPr anchor="t" wrap="square" rtlCol="false" tIns="0" lIns="0" bIns="0" rIns="0">
+            <a:noAutofit/>
+          </a:bodyPr>
+          <a:lstStyle/>
+          <a:p>
+            <a:pPr algn="l">
+              <a:lnSpc>
+                <a:spcPct val="100000"/>
+              </a:lnSpc>
+              <a:spcAft>
+                <a:spcPts val="1600"/>
+              </a:spcAft>
+            </a:pPr>
+            <a:r>
+              <a:rPr lang="uk-UA" sz="2400" b="0">
+                <a:solidFill>
+                  <a:srgbClr val="FBFBF8"/>
+                </a:solidFill>
+                <a:latin typeface="Fira Sans Extra Condensed"/>
+                <a:ea typeface="Fira Sans Extra Condensed"/>
+                <a:cs typeface="Fira Sans Extra Condensed"/>
+                <a:sym typeface="Fira Sans Extra Condensed"/>
+              </a:rPr>
+              <a:t>— Оператор відповідає за операції: персонал, якість, безпеку продукції</a:t>
+            </a:r>
+          </a:p>
+          <a:p>
+            <a:pPr algn="l">
+              <a:lnSpc>
+                <a:spcPct val="100000"/>
+              </a:lnSpc>
+              <a:spcAft>
+                <a:spcPts val="1600"/>
+              </a:spcAft>
+            </a:pPr>
+            <a:r>
+              <a:rPr lang="uk-UA" sz="2400" b="0">
+                <a:solidFill>
+                  <a:srgbClr val="FBFBF8"/>
+                </a:solidFill>
+                <a:latin typeface="Fira Sans Extra Condensed"/>
+                <a:ea typeface="Fira Sans Extra Condensed"/>
+                <a:cs typeface="Fira Sans Extra Condensed"/>
+                <a:sym typeface="Fira Sans Extra Condensed"/>
+              </a:rPr>
+              <a:t>— Lviv Croissants: за якість Стандартів і навчання</a:t>
+            </a:r>
+          </a:p>
+          <a:p>
+            <a:pPr algn="l">
+              <a:lnSpc>
+                <a:spcPct val="100000"/>
+              </a:lnSpc>
+              <a:spcAft>
+                <a:spcPts val="1600"/>
+              </a:spcAft>
+            </a:pPr>
+            <a:r>
+              <a:rPr lang="uk-UA" sz="2400" b="0">
+                <a:solidFill>
+                  <a:srgbClr val="FBFBF8"/>
+                </a:solidFill>
+                <a:latin typeface="Fira Sans Extra Condensed"/>
+                <a:ea typeface="Fira Sans Extra Condensed"/>
+                <a:cs typeface="Fira Sans Extra Condensed"/>
+                <a:sym typeface="Fira Sans Extra Condensed"/>
+              </a:rPr>
+              <a:t>— Санкції за порушення Стандартів, страхування: відкрито</a:t>
+            </a:r>
+          </a:p>
+          <a:p>
+            <a:pPr algn="l">
+              <a:lnSpc>
+                <a:spcPct val="100000"/>
+              </a:lnSpc>
+              <a:spcAft>
+                <a:spcPts val="1600"/>
+              </a:spcAft>
+            </a:pPr>
+            <a:r>
+              <a:rPr lang="uk-UA" sz="2400" b="0">
+                <a:solidFill>
+                  <a:srgbClr val="FBFBF8"/>
+                </a:solidFill>
+                <a:latin typeface="Fira Sans Extra Condensed"/>
+                <a:ea typeface="Fira Sans Extra Condensed"/>
+                <a:cs typeface="Fira Sans Extra Condensed"/>
+                <a:sym typeface="Fira Sans Extra Condensed"/>
+              </a:rPr>
+              <a:t>— Спори: право, місце розгляду, арбітраж: до юриста</a:t>
+            </a:r>
+          </a:p>
+        </p:txBody>
+      </p:sp>
+      <p:sp>
+        <p:nvSpPr>
+          <p:cNvPr name="Note 9" id="9"/>
+          <p:cNvSpPr/>
+          <p:nvPr/>
+        </p:nvSpPr>
+        <p:spPr>
+          <a:xfrm>
+            <a:off x="1219200" y="8750000"/>
+            <a:ext cx="15849600" cy="1000000"/>
+          </a:xfrm>
+          <a:prstGeom prst="roundRect">
+            <a:avLst>
+              <a:gd name="adj" fmla="val 7000"/>
+            </a:avLst>
+          </a:prstGeom>
+          <a:solidFill>
+            <a:srgbClr val="F4B6C8"/>
+          </a:solidFill>
+        </p:spPr>
+      </p:sp>
+      <p:sp>
+        <p:nvSpPr>
+          <p:cNvPr name="TextBox 10" id="10"/>
+          <p:cNvSpPr txBox="true"/>
+          <p:nvPr/>
+        </p:nvSpPr>
+        <p:spPr>
+          <a:xfrm>
+            <a:off x="1500000" y="8750000"/>
+            <a:ext cx="15286000" cy="1000000"/>
+          </a:xfrm>
+          <a:prstGeom prst="rect">
+            <a:avLst/>
+          </a:prstGeom>
+        </p:spPr>
+        <p:txBody>
+          <a:bodyPr anchor="ctr" wrap="square" rtlCol="false" tIns="0" lIns="0" bIns="0" rIns="0">
+            <a:noAutofit/>
+          </a:bodyPr>
+          <a:lstStyle/>
+          <a:p>
+            <a:pPr algn="ctr">
+              <a:lnSpc>
+                <a:spcPct val="100000"/>
+              </a:lnSpc>
+              <a:spcAft>
+                <a:spcPts val="0"/>
+              </a:spcAft>
+            </a:pPr>
+            <a:r>
+              <a:rPr lang="uk-UA" sz="2600" b="1">
+                <a:solidFill>
+                  <a:srgbClr val="0E4D38"/>
+                </a:solidFill>
+                <a:latin typeface="Fira Sans Extra Condensed Bold"/>
+                <a:ea typeface="Fira Sans Extra Condensed Bold"/>
+                <a:cs typeface="Fira Sans Extra Condensed Bold"/>
+                <a:sym typeface="Fira Sans Extra Condensed Bold"/>
+              </a:rPr>
+              <a:t>Кожен відповідає за свою зону; межі прописати в кожному договорі окремо</a:t>
+            </a:r>
+          </a:p>
+        </p:txBody>
+      </p:sp>
+    </p:spTree>
+  </p:cSld>
+  <p:clrMapOvr>
+    <a:masterClrMapping/>
+  </p:clrMapOvr>
+</p:sld>
+</file>
+
+<file path=ppt/slides/slide37.xml><?xml version="1.0" encoding="utf-8"?>
+<p:sld xmlns:p="http://schemas.openxmlformats.org/presentationml/2006/main" xmlns:a="http://schemas.openxmlformats.org/drawingml/2006/main">
+  <p:cSld>
+    <p:bg>
+      <p:bgPr>
+        <a:solidFill>
+          <a:srgbClr val="0E4D38"/>
+        </a:solidFill>
+      </p:bgPr>
+    </p:bg>
+    <p:spTree>
+      <p:nvGrpSpPr>
+        <p:cNvPr id="1" name=""/>
+        <p:cNvGrpSpPr/>
+        <p:nvPr/>
+      </p:nvGrpSpPr>
+      <p:grpSpPr>
+        <a:xfrm>
+          <a:off x="0" y="0"/>
+          <a:ext cx="0" cy="0"/>
+          <a:chOff x="0" y="0"/>
+          <a:chExt cx="0" cy="0"/>
+        </a:xfrm>
+      </p:grpSpPr>
+      <p:sp>
+        <p:nvSpPr>
+          <p:cNvPr name="TextBox 2" id="2"/>
+          <p:cNvSpPr txBox="true"/>
+          <p:nvPr/>
+        </p:nvSpPr>
+        <p:spPr>
+          <a:xfrm>
+            <a:off x="981456" y="1000000"/>
+            <a:ext cx="16325088" cy="900000"/>
+          </a:xfrm>
+          <a:prstGeom prst="rect">
+            <a:avLst/>
+          </a:prstGeom>
+        </p:spPr>
+        <p:txBody>
+          <a:bodyPr anchor="t" wrap="square" rtlCol="false" tIns="0" lIns="0" bIns="0" rIns="0">
+            <a:noAutofit/>
+          </a:bodyPr>
+          <a:lstStyle/>
+          <a:p>
+            <a:pPr algn="ctr">
+              <a:lnSpc>
+                <a:spcPct val="100000"/>
+              </a:lnSpc>
+              <a:spcAft>
+                <a:spcPts val="0"/>
+              </a:spcAft>
+            </a:pPr>
+            <a:r>
+              <a:rPr lang="uk-UA" sz="5400" b="1">
+                <a:solidFill>
+                  <a:srgbClr val="FBFBF8"/>
+                </a:solidFill>
+                <a:latin typeface="Fira Sans Extra Condensed Bold"/>
+                <a:ea typeface="Fira Sans Extra Condensed Bold"/>
+                <a:cs typeface="Fira Sans Extra Condensed Bold"/>
+                <a:sym typeface="Fira Sans Extra Condensed Bold"/>
+              </a:rPr>
+              <a:t>Питання до </a:t>
+            </a:r>
+            <a:r>
+              <a:rPr lang="uk-UA" sz="5400" b="1">
+                <a:solidFill>
+                  <a:srgbClr val="F4B6C8"/>
+                </a:solidFill>
+                <a:latin typeface="Fira Sans Extra Condensed Bold"/>
+                <a:ea typeface="Fira Sans Extra Condensed Bold"/>
+                <a:cs typeface="Fira Sans Extra Condensed Bold"/>
+                <a:sym typeface="Fira Sans Extra Condensed Bold"/>
+              </a:rPr>
+              <a:t>юриста</a:t>
+            </a:r>
+          </a:p>
+        </p:txBody>
+      </p:sp>
+      <p:sp>
+        <p:nvSpPr>
+          <p:cNvPr name="Card 3" id="3"/>
+          <p:cNvSpPr/>
+          <p:nvPr/>
+        </p:nvSpPr>
+        <p:spPr>
+          <a:xfrm>
+            <a:off x="1219200" y="2200000"/>
+            <a:ext cx="7774800" cy="6200000"/>
+          </a:xfrm>
+          <a:prstGeom prst="roundRect">
+            <a:avLst>
+              <a:gd name="adj" fmla="val 7000"/>
+            </a:avLst>
+          </a:prstGeom>
+          <a:solidFill>
+            <a:srgbClr val="135F45"/>
+          </a:solidFill>
+        </p:spPr>
+      </p:sp>
+      <p:sp>
+        <p:nvSpPr>
+          <p:cNvPr name="TextBox 4" id="4"/>
+          <p:cNvSpPr txBox="true"/>
+          <p:nvPr/>
+        </p:nvSpPr>
+        <p:spPr>
+          <a:xfrm>
+            <a:off x="1519200" y="2450000"/>
+            <a:ext cx="7174800" cy="5700000"/>
+          </a:xfrm>
+          <a:prstGeom prst="rect">
+            <a:avLst/>
+          </a:prstGeom>
+        </p:spPr>
+        <p:txBody>
+          <a:bodyPr anchor="t" wrap="square" rtlCol="false" tIns="0" lIns="0" bIns="0" rIns="0">
+            <a:noAutofit/>
+          </a:bodyPr>
+          <a:lstStyle/>
+          <a:p>
+            <a:pPr algn="l">
+              <a:lnSpc>
+                <a:spcPct val="100000"/>
+              </a:lnSpc>
+              <a:spcAft>
+                <a:spcPts val="1800"/>
+              </a:spcAft>
+            </a:pPr>
+            <a:r>
+              <a:rPr lang="uk-UA" sz="2400" b="1">
+                <a:solidFill>
+                  <a:srgbClr val="F4B6C8"/>
+                </a:solidFill>
+                <a:latin typeface="Fira Sans Extra Condensed Bold"/>
+                <a:ea typeface="Fira Sans Extra Condensed Bold"/>
+                <a:cs typeface="Fira Sans Extra Condensed Bold"/>
+                <a:sym typeface="Fira Sans Extra Condensed Bold"/>
+              </a:rPr>
+              <a:t>1.  </a:t>
+            </a:r>
+            <a:r>
+              <a:rPr lang="uk-UA" sz="2400" b="0">
+                <a:solidFill>
+                  <a:srgbClr val="FBFBF8"/>
+                </a:solidFill>
+                <a:latin typeface="Fira Sans Extra Condensed"/>
+                <a:ea typeface="Fira Sans Extra Condensed"/>
+                <a:cs typeface="Fira Sans Extra Condensed"/>
+                <a:sym typeface="Fira Sans Extra Condensed"/>
+              </a:rPr>
+              <a:t>Країна запуску: правила розкриття інформації для франшиз</a:t>
+            </a:r>
+          </a:p>
+          <a:p>
+            <a:pPr algn="l">
+              <a:lnSpc>
+                <a:spcPct val="100000"/>
+              </a:lnSpc>
+              <a:spcAft>
+                <a:spcPts val="1800"/>
+              </a:spcAft>
+            </a:pPr>
+            <a:r>
+              <a:rPr lang="uk-UA" sz="2400" b="1">
+                <a:solidFill>
+                  <a:srgbClr val="F4B6C8"/>
+                </a:solidFill>
+                <a:latin typeface="Fira Sans Extra Condensed Bold"/>
+                <a:ea typeface="Fira Sans Extra Condensed Bold"/>
+                <a:cs typeface="Fira Sans Extra Condensed Bold"/>
+                <a:sym typeface="Fira Sans Extra Condensed Bold"/>
+              </a:rPr>
+              <a:t>2.  </a:t>
+            </a:r>
+            <a:r>
+              <a:rPr lang="uk-UA" sz="2400" b="0">
+                <a:solidFill>
+                  <a:srgbClr val="FBFBF8"/>
+                </a:solidFill>
+                <a:latin typeface="Fira Sans Extra Condensed"/>
+                <a:ea typeface="Fira Sans Extra Condensed"/>
+                <a:cs typeface="Fira Sans Extra Condensed"/>
+                <a:sym typeface="Fira Sans Extra Condensed"/>
+              </a:rPr>
+              <a:t>Правова природа договору 1: інвестиція, партнерство чи позика</a:t>
+            </a:r>
+          </a:p>
+          <a:p>
+            <a:pPr algn="l">
+              <a:lnSpc>
+                <a:spcPct val="100000"/>
+              </a:lnSpc>
+              <a:spcAft>
+                <a:spcPts val="1800"/>
+              </a:spcAft>
+            </a:pPr>
+            <a:r>
+              <a:rPr lang="uk-UA" sz="2400" b="1">
+                <a:solidFill>
+                  <a:srgbClr val="F4B6C8"/>
+                </a:solidFill>
+                <a:latin typeface="Fira Sans Extra Condensed Bold"/>
+                <a:ea typeface="Fira Sans Extra Condensed Bold"/>
+                <a:cs typeface="Fira Sans Extra Condensed Bold"/>
+                <a:sym typeface="Fira Sans Extra Condensed Bold"/>
+              </a:rPr>
+              <a:t>3.  </a:t>
+            </a:r>
+            <a:r>
+              <a:rPr lang="uk-UA" sz="2400" b="0">
+                <a:solidFill>
+                  <a:srgbClr val="FBFBF8"/>
+                </a:solidFill>
+                <a:latin typeface="Fira Sans Extra Condensed"/>
+                <a:ea typeface="Fira Sans Extra Condensed"/>
+                <a:cs typeface="Fira Sans Extra Condensed"/>
+                <a:sym typeface="Fira Sans Extra Condensed"/>
+              </a:rPr>
+              <a:t>Ризик, що оператора визнають працівником або учасником спільного підприємства</a:t>
+            </a:r>
+          </a:p>
+          <a:p>
+            <a:pPr algn="l">
+              <a:lnSpc>
+                <a:spcPct val="100000"/>
+              </a:lnSpc>
+              <a:spcAft>
+                <a:spcPts val="1800"/>
+              </a:spcAft>
+            </a:pPr>
+            <a:r>
+              <a:rPr lang="uk-UA" sz="2400" b="1">
+                <a:solidFill>
+                  <a:srgbClr val="F4B6C8"/>
+                </a:solidFill>
+                <a:latin typeface="Fira Sans Extra Condensed Bold"/>
+                <a:ea typeface="Fira Sans Extra Condensed Bold"/>
+                <a:cs typeface="Fira Sans Extra Condensed Bold"/>
+                <a:sym typeface="Fira Sans Extra Condensed Bold"/>
+              </a:rPr>
+              <a:t>4.  </a:t>
+            </a:r>
+            <a:r>
+              <a:rPr lang="uk-UA" sz="2400" b="0">
+                <a:solidFill>
+                  <a:srgbClr val="FBFBF8"/>
+                </a:solidFill>
+                <a:latin typeface="Fira Sans Extra Condensed"/>
+                <a:ea typeface="Fira Sans Extra Condensed"/>
+                <a:cs typeface="Fira Sans Extra Condensed"/>
+                <a:sym typeface="Fira Sans Extra Condensed"/>
+              </a:rPr>
+              <a:t>Конкурентні обмеження: неконкуренція, територія, ціни (регламент ЄС про вертикальні угоди)</a:t>
+            </a:r>
+          </a:p>
+        </p:txBody>
+      </p:sp>
+      <p:sp>
+        <p:nvSpPr>
+          <p:cNvPr name="Card 5" id="5"/>
+          <p:cNvSpPr/>
+          <p:nvPr/>
+        </p:nvSpPr>
+        <p:spPr>
+          <a:xfrm>
+            <a:off x="9294000" y="2200000"/>
+            <a:ext cx="7774800" cy="6200000"/>
+          </a:xfrm>
+          <a:prstGeom prst="roundRect">
+            <a:avLst>
+              <a:gd name="adj" fmla="val 7000"/>
+            </a:avLst>
+          </a:prstGeom>
+          <a:solidFill>
+            <a:srgbClr val="135F45"/>
+          </a:solidFill>
+        </p:spPr>
+      </p:sp>
+      <p:sp>
+        <p:nvSpPr>
+          <p:cNvPr name="TextBox 6" id="6"/>
+          <p:cNvSpPr txBox="true"/>
+          <p:nvPr/>
+        </p:nvSpPr>
+        <p:spPr>
+          <a:xfrm>
+            <a:off x="9594000" y="2450000"/>
+            <a:ext cx="7174800" cy="5700000"/>
+          </a:xfrm>
+          <a:prstGeom prst="rect">
+            <a:avLst/>
+          </a:prstGeom>
+        </p:spPr>
+        <p:txBody>
+          <a:bodyPr anchor="t" wrap="square" rtlCol="false" tIns="0" lIns="0" bIns="0" rIns="0">
+            <a:noAutofit/>
+          </a:bodyPr>
+          <a:lstStyle/>
+          <a:p>
+            <a:pPr algn="l">
+              <a:lnSpc>
+                <a:spcPct val="100000"/>
+              </a:lnSpc>
+              <a:spcAft>
+                <a:spcPts val="1800"/>
+              </a:spcAft>
+            </a:pPr>
+            <a:r>
+              <a:rPr lang="uk-UA" sz="2400" b="1">
+                <a:solidFill>
+                  <a:srgbClr val="F4B6C8"/>
+                </a:solidFill>
+                <a:latin typeface="Fira Sans Extra Condensed Bold"/>
+                <a:ea typeface="Fira Sans Extra Condensed Bold"/>
+                <a:cs typeface="Fira Sans Extra Condensed Bold"/>
+                <a:sym typeface="Fira Sans Extra Condensed Bold"/>
+              </a:rPr>
+              <a:t>5.  </a:t>
+            </a:r>
+            <a:r>
+              <a:rPr lang="uk-UA" sz="2400" b="0">
+                <a:solidFill>
+                  <a:srgbClr val="FBFBF8"/>
+                </a:solidFill>
+                <a:latin typeface="Fira Sans Extra Condensed"/>
+                <a:ea typeface="Fira Sans Extra Condensed"/>
+                <a:cs typeface="Fira Sans Extra Condensed"/>
+                <a:sym typeface="Fira Sans Extra Condensed"/>
+              </a:rPr>
+              <a:t>Податки: роялті й виплати між Україною та ЄС, ПДВ</a:t>
+            </a:r>
+          </a:p>
+          <a:p>
+            <a:pPr algn="l">
+              <a:lnSpc>
+                <a:spcPct val="100000"/>
+              </a:lnSpc>
+              <a:spcAft>
+                <a:spcPts val="1800"/>
+              </a:spcAft>
+            </a:pPr>
+            <a:r>
+              <a:rPr lang="uk-UA" sz="2400" b="1">
+                <a:solidFill>
+                  <a:srgbClr val="F4B6C8"/>
+                </a:solidFill>
+                <a:latin typeface="Fira Sans Extra Condensed Bold"/>
+                <a:ea typeface="Fira Sans Extra Condensed Bold"/>
+                <a:cs typeface="Fira Sans Extra Condensed Bold"/>
+                <a:sym typeface="Fira Sans Extra Condensed Bold"/>
+              </a:rPr>
+              <a:t>6.  </a:t>
+            </a:r>
+            <a:r>
+              <a:rPr lang="uk-UA" sz="2400" b="0">
+                <a:solidFill>
+                  <a:srgbClr val="FBFBF8"/>
+                </a:solidFill>
+                <a:latin typeface="Fira Sans Extra Condensed"/>
+                <a:ea typeface="Fira Sans Extra Condensed"/>
+                <a:cs typeface="Fira Sans Extra Condensed"/>
+                <a:sym typeface="Fira Sans Extra Condensed"/>
+              </a:rPr>
+              <a:t>Торгова марка: реєстрація в країні запуску</a:t>
+            </a:r>
+          </a:p>
+          <a:p>
+            <a:pPr algn="l">
+              <a:lnSpc>
+                <a:spcPct val="100000"/>
+              </a:lnSpc>
+              <a:spcAft>
+                <a:spcPts val="1800"/>
+              </a:spcAft>
+            </a:pPr>
+            <a:r>
+              <a:rPr lang="uk-UA" sz="2400" b="1">
+                <a:solidFill>
+                  <a:srgbClr val="F4B6C8"/>
+                </a:solidFill>
+                <a:latin typeface="Fira Sans Extra Condensed Bold"/>
+                <a:ea typeface="Fira Sans Extra Condensed Bold"/>
+                <a:cs typeface="Fira Sans Extra Condensed Bold"/>
+                <a:sym typeface="Fira Sans Extra Condensed Bold"/>
+              </a:rPr>
+              <a:t>7.  </a:t>
+            </a:r>
+            <a:r>
+              <a:rPr lang="uk-UA" sz="2400" b="0">
+                <a:solidFill>
+                  <a:srgbClr val="FBFBF8"/>
+                </a:solidFill>
+                <a:latin typeface="Fira Sans Extra Condensed"/>
+                <a:ea typeface="Fira Sans Extra Condensed"/>
+                <a:cs typeface="Fira Sans Extra Condensed"/>
+                <a:sym typeface="Fira Sans Extra Condensed"/>
+              </a:rPr>
+              <a:t>Персональні дані (GDPR): персонал, гості, облік</a:t>
+            </a:r>
+          </a:p>
+          <a:p>
+            <a:pPr algn="l">
+              <a:lnSpc>
+                <a:spcPct val="100000"/>
+              </a:lnSpc>
+              <a:spcAft>
+                <a:spcPts val="1800"/>
+              </a:spcAft>
+            </a:pPr>
+            <a:r>
+              <a:rPr lang="uk-UA" sz="2400" b="1">
+                <a:solidFill>
+                  <a:srgbClr val="F4B6C8"/>
+                </a:solidFill>
+                <a:latin typeface="Fira Sans Extra Condensed Bold"/>
+                <a:ea typeface="Fira Sans Extra Condensed Bold"/>
+                <a:cs typeface="Fira Sans Extra Condensed Bold"/>
+                <a:sym typeface="Fira Sans Extra Condensed Bold"/>
+              </a:rPr>
+              <a:t>8.  </a:t>
+            </a:r>
+            <a:r>
+              <a:rPr lang="uk-UA" sz="2400" b="0">
+                <a:solidFill>
+                  <a:srgbClr val="FBFBF8"/>
+                </a:solidFill>
+                <a:latin typeface="Fira Sans Extra Condensed"/>
+                <a:ea typeface="Fira Sans Extra Condensed"/>
+                <a:cs typeface="Fira Sans Extra Condensed"/>
+                <a:sym typeface="Fira Sans Extra Condensed"/>
+              </a:rPr>
+              <a:t>Право й юрисдикція, арбітраж; договір оренди: хто орендар</a:t>
+            </a:r>
+          </a:p>
+        </p:txBody>
+      </p:sp>
+      <p:sp>
+        <p:nvSpPr>
+          <p:cNvPr name="Note 7" id="7"/>
+          <p:cNvSpPr/>
+          <p:nvPr/>
+        </p:nvSpPr>
+        <p:spPr>
+          <a:xfrm>
+            <a:off x="1219200" y="8750000"/>
+            <a:ext cx="15849600" cy="1000000"/>
+          </a:xfrm>
+          <a:prstGeom prst="roundRect">
+            <a:avLst>
+              <a:gd name="adj" fmla="val 7000"/>
+            </a:avLst>
+          </a:prstGeom>
+          <a:solidFill>
+            <a:srgbClr val="F4B6C8"/>
+          </a:solidFill>
+        </p:spPr>
+      </p:sp>
+      <p:sp>
+        <p:nvSpPr>
+          <p:cNvPr name="TextBox 8" id="8"/>
+          <p:cNvSpPr txBox="true"/>
+          <p:nvPr/>
+        </p:nvSpPr>
+        <p:spPr>
+          <a:xfrm>
+            <a:off x="1500000" y="8750000"/>
+            <a:ext cx="15286000" cy="1000000"/>
+          </a:xfrm>
+          <a:prstGeom prst="rect">
+            <a:avLst/>
+          </a:prstGeom>
+        </p:spPr>
+        <p:txBody>
+          <a:bodyPr anchor="ctr" wrap="square" rtlCol="false" tIns="0" lIns="0" bIns="0" rIns="0">
+            <a:noAutofit/>
+          </a:bodyPr>
+          <a:lstStyle/>
+          <a:p>
+            <a:pPr algn="ctr">
+              <a:lnSpc>
+                <a:spcPct val="100000"/>
+              </a:lnSpc>
+              <a:spcAft>
+                <a:spcPts val="0"/>
+              </a:spcAft>
+            </a:pPr>
+            <a:r>
+              <a:rPr lang="uk-UA" sz="2600" b="1">
+                <a:solidFill>
+                  <a:srgbClr val="0E4D38"/>
+                </a:solidFill>
+                <a:latin typeface="Fira Sans Extra Condensed Bold"/>
+                <a:ea typeface="Fira Sans Extra Condensed Bold"/>
+                <a:cs typeface="Fira Sans Extra Condensed Bold"/>
+                <a:sym typeface="Fira Sans Extra Condensed Bold"/>
+              </a:rPr>
+              <a:t>Це перелік тем, а не висновки: відповісти може лише юрист країни запуску</a:t>
             </a:r>
           </a:p>
         </p:txBody>

</xml_diff>